<commit_message>
feat: add mobile screenshots to presentation and active camera slide
</commit_message>
<xml_diff>
--- a/slides.pptx
+++ b/slides.pptx
@@ -15,6 +15,7 @@
     <p:sldId id="263" r:id="rId14"/>
     <p:sldId id="264" r:id="rId15"/>
     <p:sldId id="265" r:id="rId16"/>
+    <p:sldId id="266" r:id="rId17"/>
   </p:sldIdLst>
   <p:sldSz cx="12191695" cy="6858000" type="screen4x3"/>
   <p:notesSz cx="6858000" cy="9144000"/>
@@ -3250,6 +3251,623 @@
               </a:defRPr>
             </a:pPr>
             <a:r>
+              <a:t>MEDIA CONTROLS</a:t>
+            </a:r>
+          </a:p>
+        </p:txBody>
+      </p:sp>
+      <p:sp>
+        <p:nvSpPr>
+          <p:cNvPr id="3" name="TextBox 2"/>
+          <p:cNvSpPr txBox="1"/>
+          <p:nvPr/>
+        </p:nvSpPr>
+        <p:spPr>
+          <a:xfrm>
+            <a:off x="731520" y="548640"/>
+            <a:ext cx="10698480" cy="731520"/>
+          </a:xfrm>
+          <a:prstGeom prst="rect">
+            <a:avLst/>
+          </a:prstGeom>
+          <a:noFill/>
+        </p:spPr>
+        <p:txBody>
+          <a:bodyPr wrap="square">
+            <a:spAutoFit/>
+          </a:bodyPr>
+          <a:lstStyle/>
+          <a:p>
+            <a:pPr>
+              <a:defRPr sz="2600" b="1">
+                <a:solidFill>
+                  <a:srgbClr val="F8FAFC"/>
+                </a:solidFill>
+                <a:latin typeface="Plus Jakarta Sans"/>
+              </a:defRPr>
+            </a:pPr>
+            <a:r>
+              <a:t>Autoplay Bypass &amp; Instagram-Style Sound Controls</a:t>
+            </a:r>
+          </a:p>
+        </p:txBody>
+      </p:sp>
+      <p:sp>
+        <p:nvSpPr>
+          <p:cNvPr id="4" name="TextBox 3"/>
+          <p:cNvSpPr txBox="1"/>
+          <p:nvPr/>
+        </p:nvSpPr>
+        <p:spPr>
+          <a:xfrm>
+            <a:off x="731520" y="1645920"/>
+            <a:ext cx="4572000" cy="4572000"/>
+          </a:xfrm>
+          <a:prstGeom prst="rect">
+            <a:avLst/>
+          </a:prstGeom>
+          <a:noFill/>
+        </p:spPr>
+        <p:txBody>
+          <a:bodyPr wrap="square">
+            <a:spAutoFit/>
+          </a:bodyPr>
+          <a:lstStyle/>
+          <a:p>
+            <a:pPr>
+              <a:spcBef>
+                <a:spcPts val="1500"/>
+              </a:spcBef>
+              <a:defRPr sz="1600" b="1">
+                <a:solidFill>
+                  <a:srgbClr val="6366F1"/>
+                </a:solidFill>
+                <a:latin typeface="Plus Jakarta Sans"/>
+              </a:defRPr>
+            </a:pPr>
+            <a:r>
+              <a:t>• Bypassing Autoplay Restrictions:</a:t>
+            </a:r>
+          </a:p>
+          <a:p>
+            <a:pPr>
+              <a:spcBef>
+                <a:spcPts val="400"/>
+              </a:spcBef>
+              <a:defRPr sz="1300">
+                <a:solidFill>
+                  <a:srgbClr val="94A3B8"/>
+                </a:solidFill>
+                <a:latin typeface="Plus Jakarta Sans"/>
+              </a:defRPr>
+            </a:pPr>
+            <a:r>
+              <a:t>Mobile browsers block videos from playing automatically if they have sound. To build a seamless AR experience where the video starts immediately when the card is scanned, the video element MUST have the 'muted' attribute.</a:t>
+            </a:r>
+          </a:p>
+          <a:p>
+            <a:pPr>
+              <a:spcBef>
+                <a:spcPts val="1500"/>
+              </a:spcBef>
+              <a:defRPr sz="1600" b="1">
+                <a:solidFill>
+                  <a:srgbClr val="6366F1"/>
+                </a:solidFill>
+                <a:latin typeface="Plus Jakarta Sans"/>
+              </a:defRPr>
+            </a:pPr>
+            <a:r>
+              <a:t>• Instagram-Style Screen Taps:</a:t>
+            </a:r>
+          </a:p>
+          <a:p>
+            <a:pPr>
+              <a:spcBef>
+                <a:spcPts val="400"/>
+              </a:spcBef>
+              <a:defRPr sz="1300">
+                <a:solidFill>
+                  <a:srgbClr val="94A3B8"/>
+                </a:solidFill>
+                <a:latin typeface="Plus Jakarta Sans"/>
+              </a:defRPr>
+            </a:pPr>
+            <a:r>
+              <a:t>To let students unmute the video overlay easily, we attach a page-wide click listener. Clicking anywhere on the camera canvas toggles between muted and unmuted playback.</a:t>
+            </a:r>
+          </a:p>
+          <a:p>
+            <a:pPr>
+              <a:spcBef>
+                <a:spcPts val="1500"/>
+              </a:spcBef>
+              <a:defRPr sz="1600" b="1">
+                <a:solidFill>
+                  <a:srgbClr val="6366F1"/>
+                </a:solidFill>
+                <a:latin typeface="Plus Jakarta Sans"/>
+              </a:defRPr>
+            </a:pPr>
+            <a:r>
+              <a:t>• Visual pop-up indicators:</a:t>
+            </a:r>
+          </a:p>
+          <a:p>
+            <a:pPr>
+              <a:spcBef>
+                <a:spcPts val="400"/>
+              </a:spcBef>
+              <a:defRPr sz="1300">
+                <a:solidFill>
+                  <a:srgbClr val="94A3B8"/>
+                </a:solidFill>
+                <a:latin typeface="Plus Jakarta Sans"/>
+              </a:defRPr>
+            </a:pPr>
+            <a:r>
+              <a:t>When unmuting, a circular speaker status icon flashes in the center of the viewport for 600ms before fading away, matching Instagram's native video layout.</a:t>
+            </a:r>
+          </a:p>
+        </p:txBody>
+      </p:sp>
+      <p:sp>
+        <p:nvSpPr>
+          <p:cNvPr id="5" name="Rectangle 4"/>
+          <p:cNvSpPr/>
+          <p:nvPr/>
+        </p:nvSpPr>
+        <p:spPr>
+          <a:xfrm>
+            <a:off x="5669280" y="1645920"/>
+            <a:ext cx="5760720" cy="4389120"/>
+          </a:xfrm>
+          <a:prstGeom prst="rect">
+            <a:avLst/>
+          </a:prstGeom>
+          <a:solidFill>
+            <a:srgbClr val="1E293B"/>
+          </a:solidFill>
+          <a:ln w="12700">
+            <a:solidFill>
+              <a:srgbClr val="475569"/>
+            </a:solidFill>
+          </a:ln>
+        </p:spPr>
+        <p:style>
+          <a:lnRef idx="1">
+            <a:schemeClr val="accent1"/>
+          </a:lnRef>
+          <a:fillRef idx="3">
+            <a:schemeClr val="accent1"/>
+          </a:fillRef>
+          <a:effectRef idx="2">
+            <a:schemeClr val="accent1"/>
+          </a:effectRef>
+          <a:fontRef idx="minor">
+            <a:schemeClr val="lt1"/>
+          </a:fontRef>
+        </p:style>
+        <p:txBody>
+          <a:bodyPr rtlCol="0" anchor="ctr" wrap="square" lIns="182880" rIns="182880" tIns="182880" bIns="182880"/>
+          <a:lstStyle/>
+          <a:p>
+            <a:pPr algn="ctr">
+              <a:defRPr sz="1100">
+                <a:solidFill>
+                  <a:srgbClr val="38BDF8"/>
+                </a:solidFill>
+                <a:latin typeface="Courier New"/>
+              </a:defRPr>
+            </a:pPr>
+            <a:r>
+              <a:t>// Toggle mute state and center sound flash</a:t>
+            </a:r>
+          </a:p>
+          <a:p>
+            <a:pPr>
+              <a:defRPr sz="1100">
+                <a:solidFill>
+                  <a:srgbClr val="38BDF8"/>
+                </a:solidFill>
+                <a:latin typeface="Courier New"/>
+              </a:defRPr>
+            </a:pPr>
+            <a:r>
+              <a:t>const toggleMuteState = () =&gt; {</a:t>
+            </a:r>
+          </a:p>
+          <a:p>
+            <a:pPr>
+              <a:defRPr sz="1100">
+                <a:solidFill>
+                  <a:srgbClr val="38BDF8"/>
+                </a:solidFill>
+                <a:latin typeface="Courier New"/>
+              </a:defRPr>
+            </a:pPr>
+            <a:r>
+              <a:t>  if (arVideo.muted) {</a:t>
+            </a:r>
+          </a:p>
+          <a:p>
+            <a:pPr>
+              <a:defRPr sz="1100">
+                <a:solidFill>
+                  <a:srgbClr val="38BDF8"/>
+                </a:solidFill>
+                <a:latin typeface="Courier New"/>
+              </a:defRPr>
+            </a:pPr>
+            <a:r>
+              <a:t>    arVideo.muted = false;</a:t>
+            </a:r>
+          </a:p>
+          <a:p>
+            <a:pPr>
+              <a:defRPr sz="1100">
+                <a:solidFill>
+                  <a:srgbClr val="38BDF8"/>
+                </a:solidFill>
+                <a:latin typeface="Courier New"/>
+              </a:defRPr>
+            </a:pPr>
+            <a:r>
+              <a:t>    muteIcon.innerHTML = SPEAKER_UNMUTED_SVG;</a:t>
+            </a:r>
+          </a:p>
+          <a:p>
+            <a:pPr>
+              <a:defRPr sz="1100">
+                <a:solidFill>
+                  <a:srgbClr val="38BDF8"/>
+                </a:solidFill>
+                <a:latin typeface="Courier New"/>
+              </a:defRPr>
+            </a:pPr>
+            <a:r>
+              <a:t>    soundFlashIcon.innerHTML = SPEAKER_UNMUTED_SVG;</a:t>
+            </a:r>
+          </a:p>
+          <a:p>
+            <a:pPr>
+              <a:defRPr sz="1100">
+                <a:solidFill>
+                  <a:srgbClr val="38BDF8"/>
+                </a:solidFill>
+                <a:latin typeface="Courier New"/>
+              </a:defRPr>
+            </a:pPr>
+            <a:r>
+              <a:t>  } else {</a:t>
+            </a:r>
+          </a:p>
+          <a:p>
+            <a:pPr>
+              <a:defRPr sz="1100">
+                <a:solidFill>
+                  <a:srgbClr val="38BDF8"/>
+                </a:solidFill>
+                <a:latin typeface="Courier New"/>
+              </a:defRPr>
+            </a:pPr>
+            <a:r>
+              <a:t>    arVideo.muted = true;</a:t>
+            </a:r>
+          </a:p>
+          <a:p>
+            <a:pPr>
+              <a:defRPr sz="1100">
+                <a:solidFill>
+                  <a:srgbClr val="38BDF8"/>
+                </a:solidFill>
+                <a:latin typeface="Courier New"/>
+              </a:defRPr>
+            </a:pPr>
+            <a:r>
+              <a:t>    muteIcon.innerHTML = SPEAKER_MUTED_SVG;</a:t>
+            </a:r>
+          </a:p>
+          <a:p>
+            <a:pPr>
+              <a:defRPr sz="1100">
+                <a:solidFill>
+                  <a:srgbClr val="38BDF8"/>
+                </a:solidFill>
+                <a:latin typeface="Courier New"/>
+              </a:defRPr>
+            </a:pPr>
+            <a:r>
+              <a:t>    soundFlashIcon.innerHTML = SPEAKER_MUTED_SVG;</a:t>
+            </a:r>
+          </a:p>
+          <a:p>
+            <a:pPr>
+              <a:defRPr sz="1100">
+                <a:solidFill>
+                  <a:srgbClr val="38BDF8"/>
+                </a:solidFill>
+                <a:latin typeface="Courier New"/>
+              </a:defRPr>
+            </a:pPr>
+            <a:r>
+              <a:t>  }</a:t>
+            </a:r>
+          </a:p>
+          <a:p>
+            <a:pPr>
+              <a:defRPr sz="1100">
+                <a:solidFill>
+                  <a:srgbClr val="38BDF8"/>
+                </a:solidFill>
+                <a:latin typeface="Courier New"/>
+              </a:defRPr>
+            </a:pPr>
+          </a:p>
+          <a:p>
+            <a:pPr>
+              <a:defRPr sz="1100">
+                <a:solidFill>
+                  <a:srgbClr val="38BDF8"/>
+                </a:solidFill>
+                <a:latin typeface="Courier New"/>
+              </a:defRPr>
+            </a:pPr>
+            <a:r>
+              <a:t>  // Flash pop-up icon in center</a:t>
+            </a:r>
+          </a:p>
+          <a:p>
+            <a:pPr>
+              <a:defRPr sz="1100">
+                <a:solidFill>
+                  <a:srgbClr val="38BDF8"/>
+                </a:solidFill>
+                <a:latin typeface="Courier New"/>
+              </a:defRPr>
+            </a:pPr>
+            <a:r>
+              <a:t>  soundFlash.classList.remove("show");</a:t>
+            </a:r>
+          </a:p>
+          <a:p>
+            <a:pPr>
+              <a:defRPr sz="1100">
+                <a:solidFill>
+                  <a:srgbClr val="38BDF8"/>
+                </a:solidFill>
+                <a:latin typeface="Courier New"/>
+              </a:defRPr>
+            </a:pPr>
+            <a:r>
+              <a:t>  void soundFlash.offsetWidth; // force reflow</a:t>
+            </a:r>
+          </a:p>
+          <a:p>
+            <a:pPr>
+              <a:defRPr sz="1100">
+                <a:solidFill>
+                  <a:srgbClr val="38BDF8"/>
+                </a:solidFill>
+                <a:latin typeface="Courier New"/>
+              </a:defRPr>
+            </a:pPr>
+            <a:r>
+              <a:t>  soundFlash.classList.add("show");</a:t>
+            </a:r>
+          </a:p>
+          <a:p>
+            <a:pPr>
+              <a:defRPr sz="1100">
+                <a:solidFill>
+                  <a:srgbClr val="38BDF8"/>
+                </a:solidFill>
+                <a:latin typeface="Courier New"/>
+              </a:defRPr>
+            </a:pPr>
+            <a:r>
+              <a:t>  setTimeout(() =&gt; {</a:t>
+            </a:r>
+          </a:p>
+          <a:p>
+            <a:pPr>
+              <a:defRPr sz="1100">
+                <a:solidFill>
+                  <a:srgbClr val="38BDF8"/>
+                </a:solidFill>
+                <a:latin typeface="Courier New"/>
+              </a:defRPr>
+            </a:pPr>
+            <a:r>
+              <a:t>    soundFlash.classList.remove("show");</a:t>
+            </a:r>
+          </a:p>
+          <a:p>
+            <a:pPr>
+              <a:defRPr sz="1100">
+                <a:solidFill>
+                  <a:srgbClr val="38BDF8"/>
+                </a:solidFill>
+                <a:latin typeface="Courier New"/>
+              </a:defRPr>
+            </a:pPr>
+            <a:r>
+              <a:t>  }, 600);</a:t>
+            </a:r>
+          </a:p>
+          <a:p>
+            <a:pPr>
+              <a:defRPr sz="1100">
+                <a:solidFill>
+                  <a:srgbClr val="38BDF8"/>
+                </a:solidFill>
+                <a:latin typeface="Courier New"/>
+              </a:defRPr>
+            </a:pPr>
+            <a:r>
+              <a:t>};</a:t>
+            </a:r>
+          </a:p>
+          <a:p>
+            <a:pPr>
+              <a:defRPr sz="1100">
+                <a:solidFill>
+                  <a:srgbClr val="38BDF8"/>
+                </a:solidFill>
+                <a:latin typeface="Courier New"/>
+              </a:defRPr>
+            </a:pPr>
+          </a:p>
+          <a:p>
+            <a:pPr>
+              <a:defRPr sz="1100">
+                <a:solidFill>
+                  <a:srgbClr val="38BDF8"/>
+                </a:solidFill>
+                <a:latin typeface="Courier New"/>
+              </a:defRPr>
+            </a:pPr>
+            <a:r>
+              <a:t>// Tap screen background to toggle</a:t>
+            </a:r>
+          </a:p>
+          <a:p>
+            <a:pPr>
+              <a:defRPr sz="1100">
+                <a:solidFill>
+                  <a:srgbClr val="38BDF8"/>
+                </a:solidFill>
+                <a:latin typeface="Courier New"/>
+              </a:defRPr>
+            </a:pPr>
+            <a:r>
+              <a:t>document.body.addEventListener("click", (e) =&gt; {</a:t>
+            </a:r>
+          </a:p>
+          <a:p>
+            <a:pPr>
+              <a:defRPr sz="1100">
+                <a:solidFill>
+                  <a:srgbClr val="38BDF8"/>
+                </a:solidFill>
+                <a:latin typeface="Courier New"/>
+              </a:defRPr>
+            </a:pPr>
+            <a:r>
+              <a:t>  if (e.target.closest("#start-screen") ||</a:t>
+            </a:r>
+          </a:p>
+          <a:p>
+            <a:pPr>
+              <a:defRPr sz="1100">
+                <a:solidFill>
+                  <a:srgbClr val="38BDF8"/>
+                </a:solidFill>
+                <a:latin typeface="Courier New"/>
+              </a:defRPr>
+            </a:pPr>
+            <a:r>
+              <a:t>      e.target.closest(".header") ||</a:t>
+            </a:r>
+          </a:p>
+          <a:p>
+            <a:pPr>
+              <a:defRPr sz="1100">
+                <a:solidFill>
+                  <a:srgbClr val="38BDF8"/>
+                </a:solidFill>
+                <a:latin typeface="Courier New"/>
+              </a:defRPr>
+            </a:pPr>
+            <a:r>
+              <a:t>      e.target.closest("#mute-button")) return;</a:t>
+            </a:r>
+          </a:p>
+          <a:p>
+            <a:pPr>
+              <a:defRPr sz="1100">
+                <a:solidFill>
+                  <a:srgbClr val="38BDF8"/>
+                </a:solidFill>
+                <a:latin typeface="Courier New"/>
+              </a:defRPr>
+            </a:pPr>
+            <a:r>
+              <a:t>  toggleMuteState();</a:t>
+            </a:r>
+          </a:p>
+          <a:p>
+            <a:pPr>
+              <a:defRPr sz="1100">
+                <a:solidFill>
+                  <a:srgbClr val="38BDF8"/>
+                </a:solidFill>
+                <a:latin typeface="Courier New"/>
+              </a:defRPr>
+            </a:pPr>
+            <a:r>
+              <a:t>});</a:t>
+            </a:r>
+          </a:p>
+        </p:txBody>
+      </p:sp>
+    </p:spTree>
+  </p:cSld>
+  <p:clrMapOvr>
+    <a:masterClrMapping/>
+  </p:clrMapOvr>
+</p:sld>
+</file>
+
+<file path=ppt/slides/slide11.xml><?xml version="1.0" encoding="utf-8"?>
+<p:sld xmlns:a="http://schemas.openxmlformats.org/drawingml/2006/main" xmlns:p="http://schemas.openxmlformats.org/presentationml/2006/main" xmlns:r="http://schemas.openxmlformats.org/officeDocument/2006/relationships">
+  <p:cSld>
+    <p:bg>
+      <p:bgPr>
+        <a:solidFill>
+          <a:srgbClr val="0F172A"/>
+        </a:solidFill>
+        <a:effectLst/>
+      </p:bgPr>
+    </p:bg>
+    <p:spTree>
+      <p:nvGrpSpPr>
+        <p:cNvPr id="1" name=""/>
+        <p:cNvGrpSpPr/>
+        <p:nvPr/>
+      </p:nvGrpSpPr>
+      <p:grpSpPr/>
+      <p:sp>
+        <p:nvSpPr>
+          <p:cNvPr id="2" name="TextBox 1"/>
+          <p:cNvSpPr txBox="1"/>
+          <p:nvPr/>
+        </p:nvSpPr>
+        <p:spPr>
+          <a:xfrm>
+            <a:off x="731520" y="365760"/>
+            <a:ext cx="10698480" cy="365760"/>
+          </a:xfrm>
+          <a:prstGeom prst="rect">
+            <a:avLst/>
+          </a:prstGeom>
+          <a:noFill/>
+        </p:spPr>
+        <p:txBody>
+          <a:bodyPr wrap="square">
+            <a:spAutoFit/>
+          </a:bodyPr>
+          <a:lstStyle/>
+          <a:p>
+            <a:pPr>
+              <a:defRPr sz="1000" b="1">
+                <a:solidFill>
+                  <a:srgbClr val="6366F1"/>
+                </a:solidFill>
+                <a:latin typeface="Plus Jakarta Sans"/>
+              </a:defRPr>
+            </a:pPr>
+            <a:r>
               <a:t>TESTING TARGETS</a:t>
             </a:r>
           </a:p>
@@ -4204,7 +4822,7 @@
         <p:spPr>
           <a:xfrm>
             <a:off x="731520" y="1645920"/>
-            <a:ext cx="5303520" cy="4572000"/>
+            <a:ext cx="4206240" cy="4572000"/>
           </a:xfrm>
           <a:prstGeom prst="rect">
             <a:avLst/>
@@ -4330,14 +4948,110 @@
         </p:blipFill>
         <p:spPr>
           <a:xfrm>
-            <a:off x="6400800" y="1645920"/>
-            <a:ext cx="5029200" cy="4114800"/>
+            <a:off x="5120640" y="1645920"/>
+            <a:ext cx="3840480" cy="2880360"/>
           </a:xfrm>
           <a:prstGeom prst="rect">
             <a:avLst/>
           </a:prstGeom>
         </p:spPr>
       </p:pic>
+      <p:sp>
+        <p:nvSpPr>
+          <p:cNvPr id="6" name="TextBox 5"/>
+          <p:cNvSpPr txBox="1"/>
+          <p:nvPr/>
+        </p:nvSpPr>
+        <p:spPr>
+          <a:xfrm>
+            <a:off x="5120640" y="4572000"/>
+            <a:ext cx="3840480" cy="365760"/>
+          </a:xfrm>
+          <a:prstGeom prst="rect">
+            <a:avLst/>
+          </a:prstGeom>
+          <a:noFill/>
+        </p:spPr>
+        <p:txBody>
+          <a:bodyPr wrap="none">
+            <a:spAutoFit/>
+          </a:bodyPr>
+          <a:lstStyle/>
+          <a:p>
+            <a:pPr algn="ctr">
+              <a:defRPr sz="1100">
+                <a:solidFill>
+                  <a:srgbClr val="94A3B8"/>
+                </a:solidFill>
+                <a:latin typeface="Plus Jakarta Sans"/>
+              </a:defRPr>
+            </a:pPr>
+            <a:r>
+              <a:t>Desktop Onboarding</a:t>
+            </a:r>
+          </a:p>
+        </p:txBody>
+      </p:sp>
+      <p:pic>
+        <p:nvPicPr>
+          <p:cNvPr id="7" name="Picture 6" descr="screenshot_mobile_start.png"/>
+          <p:cNvPicPr>
+            <a:picLocks noChangeAspect="1"/>
+          </p:cNvPicPr>
+          <p:nvPr/>
+        </p:nvPicPr>
+        <p:blipFill>
+          <a:blip r:embed="rId3"/>
+          <a:stretch>
+            <a:fillRect/>
+          </a:stretch>
+        </p:blipFill>
+        <p:spPr>
+          <a:xfrm>
+            <a:off x="9418320" y="1645920"/>
+            <a:ext cx="2011680" cy="4352544"/>
+          </a:xfrm>
+          <a:prstGeom prst="rect">
+            <a:avLst/>
+          </a:prstGeom>
+        </p:spPr>
+      </p:pic>
+      <p:sp>
+        <p:nvSpPr>
+          <p:cNvPr id="8" name="TextBox 7"/>
+          <p:cNvSpPr txBox="1"/>
+          <p:nvPr/>
+        </p:nvSpPr>
+        <p:spPr>
+          <a:xfrm>
+            <a:off x="9418320" y="6035040"/>
+            <a:ext cx="2011680" cy="365760"/>
+          </a:xfrm>
+          <a:prstGeom prst="rect">
+            <a:avLst/>
+          </a:prstGeom>
+          <a:noFill/>
+        </p:spPr>
+        <p:txBody>
+          <a:bodyPr wrap="none">
+            <a:spAutoFit/>
+          </a:bodyPr>
+          <a:lstStyle/>
+          <a:p>
+            <a:pPr algn="ctr">
+              <a:defRPr sz="1100">
+                <a:solidFill>
+                  <a:srgbClr val="94A3B8"/>
+                </a:solidFill>
+                <a:latin typeface="Plus Jakarta Sans"/>
+              </a:defRPr>
+            </a:pPr>
+            <a:r>
+              <a:t>Mobile Onboarding</a:t>
+            </a:r>
+          </a:p>
+        </p:txBody>
+      </p:sp>
     </p:spTree>
   </p:cSld>
   <p:clrMapOvr>
@@ -4347,6 +5061,315 @@
 </file>
 
 <file path=ppt/slides/slide5.xml><?xml version="1.0" encoding="utf-8"?>
+<p:sld xmlns:a="http://schemas.openxmlformats.org/drawingml/2006/main" xmlns:p="http://schemas.openxmlformats.org/presentationml/2006/main" xmlns:r="http://schemas.openxmlformats.org/officeDocument/2006/relationships">
+  <p:cSld>
+    <p:bg>
+      <p:bgPr>
+        <a:solidFill>
+          <a:srgbClr val="0F172A"/>
+        </a:solidFill>
+        <a:effectLst/>
+      </p:bgPr>
+    </p:bg>
+    <p:spTree>
+      <p:nvGrpSpPr>
+        <p:cNvPr id="1" name=""/>
+        <p:cNvGrpSpPr/>
+        <p:nvPr/>
+      </p:nvGrpSpPr>
+      <p:grpSpPr/>
+      <p:sp>
+        <p:nvSpPr>
+          <p:cNvPr id="2" name="TextBox 1"/>
+          <p:cNvSpPr txBox="1"/>
+          <p:nvPr/>
+        </p:nvSpPr>
+        <p:spPr>
+          <a:xfrm>
+            <a:off x="731520" y="365760"/>
+            <a:ext cx="10698480" cy="365760"/>
+          </a:xfrm>
+          <a:prstGeom prst="rect">
+            <a:avLst/>
+          </a:prstGeom>
+          <a:noFill/>
+        </p:spPr>
+        <p:txBody>
+          <a:bodyPr wrap="square">
+            <a:spAutoFit/>
+          </a:bodyPr>
+          <a:lstStyle/>
+          <a:p>
+            <a:pPr>
+              <a:defRPr sz="1000" b="1">
+                <a:solidFill>
+                  <a:srgbClr val="6366F1"/>
+                </a:solidFill>
+                <a:latin typeface="Plus Jakarta Sans"/>
+              </a:defRPr>
+            </a:pPr>
+            <a:r>
+              <a:t>APPLICATION INTERFACE</a:t>
+            </a:r>
+          </a:p>
+        </p:txBody>
+      </p:sp>
+      <p:sp>
+        <p:nvSpPr>
+          <p:cNvPr id="3" name="TextBox 2"/>
+          <p:cNvSpPr txBox="1"/>
+          <p:nvPr/>
+        </p:nvSpPr>
+        <p:spPr>
+          <a:xfrm>
+            <a:off x="731520" y="548640"/>
+            <a:ext cx="10698480" cy="731520"/>
+          </a:xfrm>
+          <a:prstGeom prst="rect">
+            <a:avLst/>
+          </a:prstGeom>
+          <a:noFill/>
+        </p:spPr>
+        <p:txBody>
+          <a:bodyPr wrap="square">
+            <a:spAutoFit/>
+          </a:bodyPr>
+          <a:lstStyle/>
+          <a:p>
+            <a:pPr>
+              <a:defRPr sz="2600" b="1">
+                <a:solidFill>
+                  <a:srgbClr val="F8FAFC"/>
+                </a:solidFill>
+                <a:latin typeface="Plus Jakarta Sans"/>
+              </a:defRPr>
+            </a:pPr>
+            <a:r>
+              <a:t>Active Tracking &amp; Scanning Interface</a:t>
+            </a:r>
+          </a:p>
+        </p:txBody>
+      </p:sp>
+      <p:sp>
+        <p:nvSpPr>
+          <p:cNvPr id="4" name="TextBox 3"/>
+          <p:cNvSpPr txBox="1"/>
+          <p:nvPr/>
+        </p:nvSpPr>
+        <p:spPr>
+          <a:xfrm>
+            <a:off x="731520" y="1645920"/>
+            <a:ext cx="7772400" cy="4572000"/>
+          </a:xfrm>
+          <a:prstGeom prst="rect">
+            <a:avLst/>
+          </a:prstGeom>
+          <a:noFill/>
+        </p:spPr>
+        <p:txBody>
+          <a:bodyPr wrap="square">
+            <a:spAutoFit/>
+          </a:bodyPr>
+          <a:lstStyle/>
+          <a:p>
+            <a:pPr>
+              <a:spcBef>
+                <a:spcPts val="1200"/>
+              </a:spcBef>
+              <a:defRPr sz="1600" b="1">
+                <a:solidFill>
+                  <a:srgbClr val="6366F1"/>
+                </a:solidFill>
+                <a:latin typeface="Plus Jakarta Sans"/>
+              </a:defRPr>
+            </a:pPr>
+            <a:r>
+              <a:t>• Live Camera Stream View:</a:t>
+            </a:r>
+          </a:p>
+          <a:p>
+            <a:pPr>
+              <a:spcBef>
+                <a:spcPts val="300"/>
+              </a:spcBef>
+              <a:defRPr sz="1300">
+                <a:solidFill>
+                  <a:srgbClr val="94A3B8"/>
+                </a:solidFill>
+                <a:latin typeface="Plus Jakarta Sans"/>
+              </a:defRPr>
+            </a:pPr>
+            <a:r>
+              <a:t>Once permissions are granted, the active WebRTC camera feed starts streaming. The custom mock camera feed generates a rotating color wheel pattern in local simulated tests.</a:t>
+            </a:r>
+          </a:p>
+          <a:p>
+            <a:pPr>
+              <a:spcBef>
+                <a:spcPts val="1200"/>
+              </a:spcBef>
+              <a:defRPr sz="1600" b="1">
+                <a:solidFill>
+                  <a:srgbClr val="6366F1"/>
+                </a:solidFill>
+                <a:latin typeface="Plus Jakarta Sans"/>
+              </a:defRPr>
+            </a:pPr>
+            <a:r>
+              <a:t>• Interactive Scanning Guide Frame:</a:t>
+            </a:r>
+          </a:p>
+          <a:p>
+            <a:pPr>
+              <a:spcBef>
+                <a:spcPts val="300"/>
+              </a:spcBef>
+              <a:defRPr sz="1300">
+                <a:solidFill>
+                  <a:srgbClr val="94A3B8"/>
+                </a:solidFill>
+                <a:latin typeface="Plus Jakarta Sans"/>
+              </a:defRPr>
+            </a:pPr>
+            <a:r>
+              <a:t>A dashed rectangular container guides students where to align the target card. It uses fluid CSS parameters to scale dynamically on mobile screens.</a:t>
+            </a:r>
+          </a:p>
+          <a:p>
+            <a:pPr>
+              <a:spcBef>
+                <a:spcPts val="1200"/>
+              </a:spcBef>
+              <a:defRPr sz="1600" b="1">
+                <a:solidFill>
+                  <a:srgbClr val="6366F1"/>
+                </a:solidFill>
+                <a:latin typeface="Plus Jakarta Sans"/>
+              </a:defRPr>
+            </a:pPr>
+            <a:r>
+              <a:t>• Status Toast Notification:</a:t>
+            </a:r>
+          </a:p>
+          <a:p>
+            <a:pPr>
+              <a:spcBef>
+                <a:spcPts val="300"/>
+              </a:spcBef>
+              <a:defRPr sz="1300">
+                <a:solidFill>
+                  <a:srgbClr val="94A3B8"/>
+                </a:solidFill>
+                <a:latin typeface="Plus Jakarta Sans"/>
+              </a:defRPr>
+            </a:pPr>
+            <a:r>
+              <a:t>Floating dynamically at the top center of the viewport, a toast card reads 'Looking for target...' or displays tracking feedback context in real time.</a:t>
+            </a:r>
+          </a:p>
+          <a:p>
+            <a:pPr>
+              <a:spcBef>
+                <a:spcPts val="1200"/>
+              </a:spcBef>
+              <a:defRPr sz="1600" b="1">
+                <a:solidFill>
+                  <a:srgbClr val="6366F1"/>
+                </a:solidFill>
+                <a:latin typeface="Plus Jakarta Sans"/>
+              </a:defRPr>
+            </a:pPr>
+            <a:r>
+              <a:t>• Fixed Volume Toggle Button:</a:t>
+            </a:r>
+          </a:p>
+          <a:p>
+            <a:pPr>
+              <a:spcBef>
+                <a:spcPts val="300"/>
+              </a:spcBef>
+              <a:defRPr sz="1300">
+                <a:solidFill>
+                  <a:srgbClr val="94A3B8"/>
+                </a:solidFill>
+                <a:latin typeface="Plus Jakarta Sans"/>
+              </a:defRPr>
+            </a:pPr>
+            <a:r>
+              <a:t>Instagram-inspired floating volume indicators show whether the target video's audio track is currently muted or unmuted.</a:t>
+            </a:r>
+          </a:p>
+        </p:txBody>
+      </p:sp>
+      <p:pic>
+        <p:nvPicPr>
+          <p:cNvPr id="5" name="Picture 4" descr="screenshot_mobile_camera.png"/>
+          <p:cNvPicPr>
+            <a:picLocks noChangeAspect="1"/>
+          </p:cNvPicPr>
+          <p:nvPr/>
+        </p:nvPicPr>
+        <p:blipFill>
+          <a:blip r:embed="rId2"/>
+          <a:stretch>
+            <a:fillRect/>
+          </a:stretch>
+        </p:blipFill>
+        <p:spPr>
+          <a:xfrm>
+            <a:off x="9144000" y="1645920"/>
+            <a:ext cx="2011680" cy="4352544"/>
+          </a:xfrm>
+          <a:prstGeom prst="rect">
+            <a:avLst/>
+          </a:prstGeom>
+        </p:spPr>
+      </p:pic>
+      <p:sp>
+        <p:nvSpPr>
+          <p:cNvPr id="6" name="TextBox 5"/>
+          <p:cNvSpPr txBox="1"/>
+          <p:nvPr/>
+        </p:nvSpPr>
+        <p:spPr>
+          <a:xfrm>
+            <a:off x="9144000" y="6035040"/>
+            <a:ext cx="2011680" cy="365760"/>
+          </a:xfrm>
+          <a:prstGeom prst="rect">
+            <a:avLst/>
+          </a:prstGeom>
+          <a:noFill/>
+        </p:spPr>
+        <p:txBody>
+          <a:bodyPr wrap="none">
+            <a:spAutoFit/>
+          </a:bodyPr>
+          <a:lstStyle/>
+          <a:p>
+            <a:pPr algn="ctr">
+              <a:defRPr sz="1100">
+                <a:solidFill>
+                  <a:srgbClr val="94A3B8"/>
+                </a:solidFill>
+                <a:latin typeface="Plus Jakarta Sans"/>
+              </a:defRPr>
+            </a:pPr>
+            <a:r>
+              <a:t>Mobile Camera Active</a:t>
+            </a:r>
+          </a:p>
+        </p:txBody>
+      </p:sp>
+    </p:spTree>
+  </p:cSld>
+  <p:clrMapOvr>
+    <a:masterClrMapping/>
+  </p:clrMapOvr>
+</p:sld>
+</file>
+
+<file path=ppt/slides/slide6.xml><?xml version="1.0" encoding="utf-8"?>
 <p:sld xmlns:a="http://schemas.openxmlformats.org/drawingml/2006/main" xmlns:p="http://schemas.openxmlformats.org/presentationml/2006/main" xmlns:r="http://schemas.openxmlformats.org/officeDocument/2006/relationships">
   <p:cSld>
     <p:bg>
@@ -4831,7 +5854,7 @@
 </p:sld>
 </file>
 
-<file path=ppt/slides/slide6.xml><?xml version="1.0" encoding="utf-8"?>
+<file path=ppt/slides/slide7.xml><?xml version="1.0" encoding="utf-8"?>
 <p:sld xmlns:a="http://schemas.openxmlformats.org/drawingml/2006/main" xmlns:p="http://schemas.openxmlformats.org/presentationml/2006/main" xmlns:r="http://schemas.openxmlformats.org/officeDocument/2006/relationships">
   <p:cSld>
     <p:bg>
@@ -5322,231 +6345,6 @@
 </p:sld>
 </file>
 
-<file path=ppt/slides/slide7.xml><?xml version="1.0" encoding="utf-8"?>
-<p:sld xmlns:a="http://schemas.openxmlformats.org/drawingml/2006/main" xmlns:p="http://schemas.openxmlformats.org/presentationml/2006/main" xmlns:r="http://schemas.openxmlformats.org/officeDocument/2006/relationships">
-  <p:cSld>
-    <p:bg>
-      <p:bgPr>
-        <a:solidFill>
-          <a:srgbClr val="0F172A"/>
-        </a:solidFill>
-        <a:effectLst/>
-      </p:bgPr>
-    </p:bg>
-    <p:spTree>
-      <p:nvGrpSpPr>
-        <p:cNvPr id="1" name=""/>
-        <p:cNvGrpSpPr/>
-        <p:nvPr/>
-      </p:nvGrpSpPr>
-      <p:grpSpPr/>
-      <p:sp>
-        <p:nvSpPr>
-          <p:cNvPr id="2" name="TextBox 1"/>
-          <p:cNvSpPr txBox="1"/>
-          <p:nvPr/>
-        </p:nvSpPr>
-        <p:spPr>
-          <a:xfrm>
-            <a:off x="731520" y="365760"/>
-            <a:ext cx="10698480" cy="365760"/>
-          </a:xfrm>
-          <a:prstGeom prst="rect">
-            <a:avLst/>
-          </a:prstGeom>
-          <a:noFill/>
-        </p:spPr>
-        <p:txBody>
-          <a:bodyPr wrap="square">
-            <a:spAutoFit/>
-          </a:bodyPr>
-          <a:lstStyle/>
-          <a:p>
-            <a:pPr>
-              <a:defRPr sz="1000" b="1">
-                <a:solidFill>
-                  <a:srgbClr val="6366F1"/>
-                </a:solidFill>
-                <a:latin typeface="Plus Jakarta Sans"/>
-              </a:defRPr>
-            </a:pPr>
-            <a:r>
-              <a:t>TESTING &amp; SECURITY</a:t>
-            </a:r>
-          </a:p>
-        </p:txBody>
-      </p:sp>
-      <p:sp>
-        <p:nvSpPr>
-          <p:cNvPr id="3" name="TextBox 2"/>
-          <p:cNvSpPr txBox="1"/>
-          <p:nvPr/>
-        </p:nvSpPr>
-        <p:spPr>
-          <a:xfrm>
-            <a:off x="731520" y="548640"/>
-            <a:ext cx="10698480" cy="731520"/>
-          </a:xfrm>
-          <a:prstGeom prst="rect">
-            <a:avLst/>
-          </a:prstGeom>
-          <a:noFill/>
-        </p:spPr>
-        <p:txBody>
-          <a:bodyPr wrap="square">
-            <a:spAutoFit/>
-          </a:bodyPr>
-          <a:lstStyle/>
-          <a:p>
-            <a:pPr>
-              <a:defRPr sz="2600" b="1">
-                <a:solidFill>
-                  <a:srgbClr val="F8FAFC"/>
-                </a:solidFill>
-                <a:latin typeface="Plus Jakarta Sans"/>
-              </a:defRPr>
-            </a:pPr>
-            <a:r>
-              <a:t>Mobile WebRTC: Secure Connections (HTTPS)</a:t>
-            </a:r>
-          </a:p>
-        </p:txBody>
-      </p:sp>
-      <p:sp>
-        <p:nvSpPr>
-          <p:cNvPr id="4" name="TextBox 3"/>
-          <p:cNvSpPr txBox="1"/>
-          <p:nvPr/>
-        </p:nvSpPr>
-        <p:spPr>
-          <a:xfrm>
-            <a:off x="731520" y="1645920"/>
-            <a:ext cx="10698480" cy="4572000"/>
-          </a:xfrm>
-          <a:prstGeom prst="rect">
-            <a:avLst/>
-          </a:prstGeom>
-          <a:noFill/>
-        </p:spPr>
-        <p:txBody>
-          <a:bodyPr wrap="square">
-            <a:spAutoFit/>
-          </a:bodyPr>
-          <a:lstStyle/>
-          <a:p>
-            <a:pPr>
-              <a:spcBef>
-                <a:spcPts val="1500"/>
-              </a:spcBef>
-              <a:defRPr sz="1800" b="1">
-                <a:solidFill>
-                  <a:srgbClr val="6366F1"/>
-                </a:solidFill>
-                <a:latin typeface="Plus Jakarta Sans"/>
-              </a:defRPr>
-            </a:pPr>
-            <a:r>
-              <a:t>🛡️ WebRTC Security Model (getUserMedia)</a:t>
-            </a:r>
-          </a:p>
-          <a:p>
-            <a:pPr>
-              <a:spcBef>
-                <a:spcPts val="400"/>
-              </a:spcBef>
-              <a:defRPr sz="1400">
-                <a:solidFill>
-                  <a:srgbClr val="94A3B8"/>
-                </a:solidFill>
-                <a:latin typeface="Plus Jakarta Sans"/>
-              </a:defRPr>
-            </a:pPr>
-            <a:r>
-              <a:t>Web browsers strictly block webcam streams from running unless the page is loaded over a fully secure HTTPS connection (or localhost on desktop).</a:t>
-            </a:r>
-          </a:p>
-          <a:p>
-            <a:pPr>
-              <a:spcBef>
-                <a:spcPts val="1500"/>
-              </a:spcBef>
-              <a:defRPr sz="1800" b="1">
-                <a:solidFill>
-                  <a:srgbClr val="6366F1"/>
-                </a:solidFill>
-                <a:latin typeface="Plus Jakarta Sans"/>
-              </a:defRPr>
-            </a:pPr>
-            <a:r>
-              <a:t>📱 Connecting Your Phone to a Local Server</a:t>
-            </a:r>
-          </a:p>
-          <a:p>
-            <a:pPr>
-              <a:spcBef>
-                <a:spcPts val="400"/>
-              </a:spcBef>
-              <a:defRPr sz="1400">
-                <a:solidFill>
-                  <a:srgbClr val="94A3B8"/>
-                </a:solidFill>
-                <a:latin typeface="Plus Jakarta Sans"/>
-              </a:defRPr>
-            </a:pPr>
-            <a:r>
-              <a:t>To test the application on your physical mobile device, the device must connect to your computer's local network server. The server runs a dual-port node instance printing the direct local IP URL, e.g. https://192.168.1.178:3030.</a:t>
-            </a:r>
-          </a:p>
-          <a:p>
-            <a:pPr>
-              <a:spcBef>
-                <a:spcPts val="1500"/>
-              </a:spcBef>
-              <a:defRPr sz="1800" b="1">
-                <a:solidFill>
-                  <a:srgbClr val="6366F1"/>
-                </a:solidFill>
-                <a:latin typeface="Plus Jakarta Sans"/>
-              </a:defRPr>
-            </a:pPr>
-            <a:r>
-              <a:t>⚠️ Bypassing Self-Signed SSL Warnings</a:t>
-            </a:r>
-          </a:p>
-          <a:p>
-            <a:pPr>
-              <a:spcBef>
-                <a:spcPts val="400"/>
-              </a:spcBef>
-              <a:defRPr sz="1400">
-                <a:solidFill>
-                  <a:srgbClr val="94A3B8"/>
-                </a:solidFill>
-                <a:latin typeface="Plus Jakarta Sans"/>
-              </a:defRPr>
-            </a:pPr>
-            <a:r>
-              <a:t>Because local HTTPS uses a self-signed developer certificate, mobile browsers display a warning page on load. This is safe to bypass:</a:t>
-            </a:r>
-            <a:br/>
-            <a:r>
-              <a:t>• iOS Safari: Tap 'Show Details' -&gt; Tap 'visit this website' at the bottom -&gt; Tap 'Visit Website'.</a:t>
-            </a:r>
-            <a:br/>
-            <a:r>
-              <a:t>• Android Chrome: Tap 'Advanced' -&gt; Tap 'Proceed to &lt;IP&gt; (unsafe)'.</a:t>
-            </a:r>
-          </a:p>
-        </p:txBody>
-      </p:sp>
-    </p:spTree>
-  </p:cSld>
-  <p:clrMapOvr>
-    <a:masterClrMapping/>
-  </p:clrMapOvr>
-</p:sld>
-</file>
-
 <file path=ppt/slides/slide8.xml><?xml version="1.0" encoding="utf-8"?>
 <p:sld xmlns:a="http://schemas.openxmlformats.org/drawingml/2006/main" xmlns:p="http://schemas.openxmlformats.org/presentationml/2006/main" xmlns:r="http://schemas.openxmlformats.org/officeDocument/2006/relationships">
   <p:cSld>
@@ -5596,7 +6394,7 @@
               </a:defRPr>
             </a:pPr>
             <a:r>
-              <a:t>UX OPTIMIZATIONS</a:t>
+              <a:t>TESTING &amp; SECURITY</a:t>
             </a:r>
           </a:p>
         </p:txBody>
@@ -5632,7 +6430,7 @@
               </a:defRPr>
             </a:pPr>
             <a:r>
-              <a:t>Tab Focus Recovery &amp; Native Refresh Support</a:t>
+              <a:t>Mobile WebRTC: Secure Connections (HTTPS)</a:t>
             </a:r>
           </a:p>
         </p:txBody>
@@ -5661,9 +6459,9 @@
           <a:p>
             <a:pPr>
               <a:spcBef>
-                <a:spcPts val="1200"/>
+                <a:spcPts val="1500"/>
               </a:spcBef>
-              <a:defRPr sz="1600" b="1">
+              <a:defRPr sz="1800" b="1">
                 <a:solidFill>
                   <a:srgbClr val="6366F1"/>
                 </a:solidFill>
@@ -5671,15 +6469,15 @@
               </a:defRPr>
             </a:pPr>
             <a:r>
-              <a:t>📲 Native Pull-to-Refresh on WebAR Pages</a:t>
+              <a:t>🛡️ WebRTC Security Model (getUserMedia)</a:t>
             </a:r>
           </a:p>
           <a:p>
             <a:pPr>
               <a:spcBef>
-                <a:spcPts val="300"/>
+                <a:spcPts val="400"/>
               </a:spcBef>
-              <a:defRPr sz="1300">
+              <a:defRPr sz="1400">
                 <a:solidFill>
                   <a:srgbClr val="94A3B8"/>
                 </a:solidFill>
@@ -5687,79 +6485,79 @@
               </a:defRPr>
             </a:pPr>
             <a:r>
-              <a:t>Usually, full-screen WebAR applications use 'overflow: hidden' to prevent scroll shifting, which blocks the mobile browser's native drag-down-to-reload gesture.</a:t>
+              <a:t>Web browsers strictly block webcam streams from running unless the page is loaded over a fully secure HTTPS connection (or localhost on desktop).</a:t>
+            </a:r>
+          </a:p>
+          <a:p>
+            <a:pPr>
+              <a:spcBef>
+                <a:spcPts val="1500"/>
+              </a:spcBef>
+              <a:defRPr sz="1800" b="1">
+                <a:solidFill>
+                  <a:srgbClr val="6366F1"/>
+                </a:solidFill>
+                <a:latin typeface="Plus Jakarta Sans"/>
+              </a:defRPr>
+            </a:pPr>
+            <a:r>
+              <a:t>📱 Connecting Your Phone to a Local Server</a:t>
+            </a:r>
+          </a:p>
+          <a:p>
+            <a:pPr>
+              <a:spcBef>
+                <a:spcPts val="400"/>
+              </a:spcBef>
+              <a:defRPr sz="1400">
+                <a:solidFill>
+                  <a:srgbClr val="94A3B8"/>
+                </a:solidFill>
+                <a:latin typeface="Plus Jakarta Sans"/>
+              </a:defRPr>
+            </a:pPr>
+            <a:r>
+              <a:t>To test the application on your physical mobile device, the device must connect to your computer's local network server. The server runs a dual-port node instance printing the direct local IP URL, e.g. https://192.168.1.178:3030.</a:t>
+            </a:r>
+          </a:p>
+          <a:p>
+            <a:pPr>
+              <a:spcBef>
+                <a:spcPts val="1500"/>
+              </a:spcBef>
+              <a:defRPr sz="1800" b="1">
+                <a:solidFill>
+                  <a:srgbClr val="6366F1"/>
+                </a:solidFill>
+                <a:latin typeface="Plus Jakarta Sans"/>
+              </a:defRPr>
+            </a:pPr>
+            <a:r>
+              <a:t>⚠️ Bypassing Self-Signed SSL Warnings</a:t>
+            </a:r>
+          </a:p>
+          <a:p>
+            <a:pPr>
+              <a:spcBef>
+                <a:spcPts val="400"/>
+              </a:spcBef>
+              <a:defRPr sz="1400">
+                <a:solidFill>
+                  <a:srgbClr val="94A3B8"/>
+                </a:solidFill>
+                <a:latin typeface="Plus Jakarta Sans"/>
+              </a:defRPr>
+            </a:pPr>
+            <a:r>
+              <a:t>Because local HTTPS uses a self-signed developer certificate, mobile browsers display a warning page on load. This is safe to bypass:</a:t>
             </a:r>
             <a:br/>
             <a:r>
-              <a:t>By changing the CSS parameters to overflow-y: auto, we restore native browser reload support. Since our UI overlays are styled using fixed/absolute coordinates, the layout stays pinned, letting users refresh the camera feed without alignment glitches.</a:t>
-            </a:r>
-          </a:p>
-          <a:p>
-            <a:pPr>
-              <a:spcBef>
-                <a:spcPts val="1200"/>
-              </a:spcBef>
-              <a:defRPr sz="1600" b="1">
-                <a:solidFill>
-                  <a:srgbClr val="6366F1"/>
-                </a:solidFill>
-                <a:latin typeface="Plus Jakarta Sans"/>
-              </a:defRPr>
-            </a:pPr>
-            <a:r>
-              <a:t>⚡ Solving Scene Race Conditions (A-Frame 'loaded' Event)</a:t>
-            </a:r>
-          </a:p>
-          <a:p>
-            <a:pPr>
-              <a:spcBef>
-                <a:spcPts val="300"/>
-              </a:spcBef>
-              <a:defRPr sz="1300">
-                <a:solidFill>
-                  <a:srgbClr val="94A3B8"/>
-                </a:solidFill>
-                <a:latin typeface="Plus Jakarta Sans"/>
-              </a:defRPr>
-            </a:pPr>
-            <a:r>
-              <a:t>When refreshing the page, starting the camera tracker immediately can fail if the tracking engine is not fully loaded yet. By wrapping the autostart logic inside an A-Frame scene 'loaded' event listener, we guarantee the camera starts successfully every time on refresh.</a:t>
-            </a:r>
-          </a:p>
-          <a:p>
-            <a:pPr>
-              <a:spcBef>
-                <a:spcPts val="1200"/>
-              </a:spcBef>
-              <a:defRPr sz="1600" b="1">
-                <a:solidFill>
-                  <a:srgbClr val="6366F1"/>
-                </a:solidFill>
-                <a:latin typeface="Plus Jakarta Sans"/>
-              </a:defRPr>
-            </a:pPr>
-            <a:r>
-              <a:t>🔄 Visibility Recovery (Tab Switching &amp; Phone Sleep)</a:t>
-            </a:r>
-          </a:p>
-          <a:p>
-            <a:pPr>
-              <a:spcBef>
-                <a:spcPts val="300"/>
-              </a:spcBef>
-              <a:defRPr sz="1300">
-                <a:solidFill>
-                  <a:srgbClr val="94A3B8"/>
-                </a:solidFill>
-                <a:latin typeface="Plus Jakarta Sans"/>
-              </a:defRPr>
-            </a:pPr>
-            <a:r>
-              <a:t>If you switch tabs or lock your phone, iOS and Android suspend active webcam capture streams.</a:t>
+              <a:t>• iOS Safari: Tap 'Show Details' -&gt; Tap 'visit this website' at the bottom -&gt; Tap 'Visit Website'.</a:t>
             </a:r>
             <a:br/>
             <a:r>
-              <a:t>We add a listener to the 'visibilitychange' event. When the user returns to the tab, the system automatically shuts down the stalled stream and requests a fresh, active camera capture.</a:t>
+              <a:t>• Android Chrome: Tap 'Advanced' -&gt; Tap 'Proceed to &lt;IP&gt; (unsafe)'.</a:t>
             </a:r>
           </a:p>
         </p:txBody>
@@ -5821,7 +6619,7 @@
               </a:defRPr>
             </a:pPr>
             <a:r>
-              <a:t>MEDIA CONTROLS</a:t>
+              <a:t>UX OPTIMIZATIONS</a:t>
             </a:r>
           </a:p>
         </p:txBody>
@@ -5857,7 +6655,7 @@
               </a:defRPr>
             </a:pPr>
             <a:r>
-              <a:t>Autoplay Bypass &amp; Instagram-Style Sound Controls</a:t>
+              <a:t>Tab Focus Recovery &amp; Native Refresh Support</a:t>
             </a:r>
           </a:p>
         </p:txBody>
@@ -5871,7 +6669,7 @@
         <p:spPr>
           <a:xfrm>
             <a:off x="731520" y="1645920"/>
-            <a:ext cx="4572000" cy="4572000"/>
+            <a:ext cx="10698480" cy="4572000"/>
           </a:xfrm>
           <a:prstGeom prst="rect">
             <a:avLst/>
@@ -5886,7 +6684,7 @@
           <a:p>
             <a:pPr>
               <a:spcBef>
-                <a:spcPts val="1500"/>
+                <a:spcPts val="1200"/>
               </a:spcBef>
               <a:defRPr sz="1600" b="1">
                 <a:solidFill>
@@ -5896,13 +6694,13 @@
               </a:defRPr>
             </a:pPr>
             <a:r>
-              <a:t>• Bypassing Autoplay Restrictions:</a:t>
+              <a:t>📲 Native Pull-to-Refresh on WebAR Pages</a:t>
             </a:r>
           </a:p>
           <a:p>
             <a:pPr>
               <a:spcBef>
-                <a:spcPts val="400"/>
+                <a:spcPts val="300"/>
               </a:spcBef>
               <a:defRPr sz="1300">
                 <a:solidFill>
@@ -5912,13 +6710,17 @@
               </a:defRPr>
             </a:pPr>
             <a:r>
-              <a:t>Mobile browsers block videos from playing automatically if they have sound. To build a seamless AR experience where the video starts immediately when the card is scanned, the video element MUST have the 'muted' attribute.</a:t>
+              <a:t>Usually, full-screen WebAR applications use 'overflow: hidden' to prevent scroll shifting, which blocks the mobile browser's native drag-down-to-reload gesture.</a:t>
+            </a:r>
+            <a:br/>
+            <a:r>
+              <a:t>By changing the CSS parameters to overflow-y: auto, we restore native browser reload support. Since our UI overlays are styled using fixed/absolute coordinates, the layout stays pinned, letting users refresh the camera feed without alignment glitches.</a:t>
             </a:r>
           </a:p>
           <a:p>
             <a:pPr>
               <a:spcBef>
-                <a:spcPts val="1500"/>
+                <a:spcPts val="1200"/>
               </a:spcBef>
               <a:defRPr sz="1600" b="1">
                 <a:solidFill>
@@ -5928,13 +6730,13 @@
               </a:defRPr>
             </a:pPr>
             <a:r>
-              <a:t>• Instagram-Style Screen Taps:</a:t>
+              <a:t>⚡ Solving Scene Race Conditions (A-Frame 'loaded' Event)</a:t>
             </a:r>
           </a:p>
           <a:p>
             <a:pPr>
               <a:spcBef>
-                <a:spcPts val="400"/>
+                <a:spcPts val="300"/>
               </a:spcBef>
               <a:defRPr sz="1300">
                 <a:solidFill>
@@ -5944,13 +6746,13 @@
               </a:defRPr>
             </a:pPr>
             <a:r>
-              <a:t>To let students unmute the video overlay easily, we attach a page-wide click listener. Clicking anywhere on the camera canvas toggles between muted and unmuted playback.</a:t>
+              <a:t>When refreshing the page, starting the camera tracker immediately can fail if the tracking engine is not fully loaded yet. By wrapping the autostart logic inside an A-Frame scene 'loaded' event listener, we guarantee the camera starts successfully every time on refresh.</a:t>
             </a:r>
           </a:p>
           <a:p>
             <a:pPr>
               <a:spcBef>
-                <a:spcPts val="1500"/>
+                <a:spcPts val="1200"/>
               </a:spcBef>
               <a:defRPr sz="1600" b="1">
                 <a:solidFill>
@@ -5960,13 +6762,13 @@
               </a:defRPr>
             </a:pPr>
             <a:r>
-              <a:t>• Visual pop-up indicators:</a:t>
+              <a:t>🔄 Visibility Recovery (Tab Switching &amp; Phone Sleep)</a:t>
             </a:r>
           </a:p>
           <a:p>
             <a:pPr>
               <a:spcBef>
-                <a:spcPts val="400"/>
+                <a:spcPts val="300"/>
               </a:spcBef>
               <a:defRPr sz="1300">
                 <a:solidFill>
@@ -5976,407 +6778,11 @@
               </a:defRPr>
             </a:pPr>
             <a:r>
-              <a:t>When unmuting, a circular speaker status icon flashes in the center of the viewport for 600ms before fading away, matching Instagram's native video layout.</a:t>
-            </a:r>
-          </a:p>
-        </p:txBody>
-      </p:sp>
-      <p:sp>
-        <p:nvSpPr>
-          <p:cNvPr id="5" name="Rectangle 4"/>
-          <p:cNvSpPr/>
-          <p:nvPr/>
-        </p:nvSpPr>
-        <p:spPr>
-          <a:xfrm>
-            <a:off x="5669280" y="1645920"/>
-            <a:ext cx="5760720" cy="4389120"/>
-          </a:xfrm>
-          <a:prstGeom prst="rect">
-            <a:avLst/>
-          </a:prstGeom>
-          <a:solidFill>
-            <a:srgbClr val="1E293B"/>
-          </a:solidFill>
-          <a:ln w="12700">
-            <a:solidFill>
-              <a:srgbClr val="475569"/>
-            </a:solidFill>
-          </a:ln>
-        </p:spPr>
-        <p:style>
-          <a:lnRef idx="1">
-            <a:schemeClr val="accent1"/>
-          </a:lnRef>
-          <a:fillRef idx="3">
-            <a:schemeClr val="accent1"/>
-          </a:fillRef>
-          <a:effectRef idx="2">
-            <a:schemeClr val="accent1"/>
-          </a:effectRef>
-          <a:fontRef idx="minor">
-            <a:schemeClr val="lt1"/>
-          </a:fontRef>
-        </p:style>
-        <p:txBody>
-          <a:bodyPr rtlCol="0" anchor="ctr" wrap="square" lIns="182880" rIns="182880" tIns="182880" bIns="182880"/>
-          <a:lstStyle/>
-          <a:p>
-            <a:pPr algn="ctr">
-              <a:defRPr sz="1100">
-                <a:solidFill>
-                  <a:srgbClr val="38BDF8"/>
-                </a:solidFill>
-                <a:latin typeface="Courier New"/>
-              </a:defRPr>
-            </a:pPr>
-            <a:r>
-              <a:t>// Toggle mute state and center sound flash</a:t>
-            </a:r>
-          </a:p>
-          <a:p>
-            <a:pPr>
-              <a:defRPr sz="1100">
-                <a:solidFill>
-                  <a:srgbClr val="38BDF8"/>
-                </a:solidFill>
-                <a:latin typeface="Courier New"/>
-              </a:defRPr>
-            </a:pPr>
-            <a:r>
-              <a:t>const toggleMuteState = () =&gt; {</a:t>
-            </a:r>
-          </a:p>
-          <a:p>
-            <a:pPr>
-              <a:defRPr sz="1100">
-                <a:solidFill>
-                  <a:srgbClr val="38BDF8"/>
-                </a:solidFill>
-                <a:latin typeface="Courier New"/>
-              </a:defRPr>
-            </a:pPr>
-            <a:r>
-              <a:t>  if (arVideo.muted) {</a:t>
-            </a:r>
-          </a:p>
-          <a:p>
-            <a:pPr>
-              <a:defRPr sz="1100">
-                <a:solidFill>
-                  <a:srgbClr val="38BDF8"/>
-                </a:solidFill>
-                <a:latin typeface="Courier New"/>
-              </a:defRPr>
-            </a:pPr>
-            <a:r>
-              <a:t>    arVideo.muted = false;</a:t>
-            </a:r>
-          </a:p>
-          <a:p>
-            <a:pPr>
-              <a:defRPr sz="1100">
-                <a:solidFill>
-                  <a:srgbClr val="38BDF8"/>
-                </a:solidFill>
-                <a:latin typeface="Courier New"/>
-              </a:defRPr>
-            </a:pPr>
-            <a:r>
-              <a:t>    muteIcon.innerHTML = SPEAKER_UNMUTED_SVG;</a:t>
-            </a:r>
-          </a:p>
-          <a:p>
-            <a:pPr>
-              <a:defRPr sz="1100">
-                <a:solidFill>
-                  <a:srgbClr val="38BDF8"/>
-                </a:solidFill>
-                <a:latin typeface="Courier New"/>
-              </a:defRPr>
-            </a:pPr>
-            <a:r>
-              <a:t>    soundFlashIcon.innerHTML = SPEAKER_UNMUTED_SVG;</a:t>
-            </a:r>
-          </a:p>
-          <a:p>
-            <a:pPr>
-              <a:defRPr sz="1100">
-                <a:solidFill>
-                  <a:srgbClr val="38BDF8"/>
-                </a:solidFill>
-                <a:latin typeface="Courier New"/>
-              </a:defRPr>
-            </a:pPr>
-            <a:r>
-              <a:t>  } else {</a:t>
-            </a:r>
-          </a:p>
-          <a:p>
-            <a:pPr>
-              <a:defRPr sz="1100">
-                <a:solidFill>
-                  <a:srgbClr val="38BDF8"/>
-                </a:solidFill>
-                <a:latin typeface="Courier New"/>
-              </a:defRPr>
-            </a:pPr>
-            <a:r>
-              <a:t>    arVideo.muted = true;</a:t>
-            </a:r>
-          </a:p>
-          <a:p>
-            <a:pPr>
-              <a:defRPr sz="1100">
-                <a:solidFill>
-                  <a:srgbClr val="38BDF8"/>
-                </a:solidFill>
-                <a:latin typeface="Courier New"/>
-              </a:defRPr>
-            </a:pPr>
-            <a:r>
-              <a:t>    muteIcon.innerHTML = SPEAKER_MUTED_SVG;</a:t>
-            </a:r>
-          </a:p>
-          <a:p>
-            <a:pPr>
-              <a:defRPr sz="1100">
-                <a:solidFill>
-                  <a:srgbClr val="38BDF8"/>
-                </a:solidFill>
-                <a:latin typeface="Courier New"/>
-              </a:defRPr>
-            </a:pPr>
-            <a:r>
-              <a:t>    soundFlashIcon.innerHTML = SPEAKER_MUTED_SVG;</a:t>
-            </a:r>
-          </a:p>
-          <a:p>
-            <a:pPr>
-              <a:defRPr sz="1100">
-                <a:solidFill>
-                  <a:srgbClr val="38BDF8"/>
-                </a:solidFill>
-                <a:latin typeface="Courier New"/>
-              </a:defRPr>
-            </a:pPr>
-            <a:r>
-              <a:t>  }</a:t>
-            </a:r>
-          </a:p>
-          <a:p>
-            <a:pPr>
-              <a:defRPr sz="1100">
-                <a:solidFill>
-                  <a:srgbClr val="38BDF8"/>
-                </a:solidFill>
-                <a:latin typeface="Courier New"/>
-              </a:defRPr>
-            </a:pPr>
-          </a:p>
-          <a:p>
-            <a:pPr>
-              <a:defRPr sz="1100">
-                <a:solidFill>
-                  <a:srgbClr val="38BDF8"/>
-                </a:solidFill>
-                <a:latin typeface="Courier New"/>
-              </a:defRPr>
-            </a:pPr>
-            <a:r>
-              <a:t>  // Flash pop-up icon in center</a:t>
-            </a:r>
-          </a:p>
-          <a:p>
-            <a:pPr>
-              <a:defRPr sz="1100">
-                <a:solidFill>
-                  <a:srgbClr val="38BDF8"/>
-                </a:solidFill>
-                <a:latin typeface="Courier New"/>
-              </a:defRPr>
-            </a:pPr>
-            <a:r>
-              <a:t>  soundFlash.classList.remove("show");</a:t>
-            </a:r>
-          </a:p>
-          <a:p>
-            <a:pPr>
-              <a:defRPr sz="1100">
-                <a:solidFill>
-                  <a:srgbClr val="38BDF8"/>
-                </a:solidFill>
-                <a:latin typeface="Courier New"/>
-              </a:defRPr>
-            </a:pPr>
-            <a:r>
-              <a:t>  void soundFlash.offsetWidth; // force reflow</a:t>
-            </a:r>
-          </a:p>
-          <a:p>
-            <a:pPr>
-              <a:defRPr sz="1100">
-                <a:solidFill>
-                  <a:srgbClr val="38BDF8"/>
-                </a:solidFill>
-                <a:latin typeface="Courier New"/>
-              </a:defRPr>
-            </a:pPr>
-            <a:r>
-              <a:t>  soundFlash.classList.add("show");</a:t>
-            </a:r>
-          </a:p>
-          <a:p>
-            <a:pPr>
-              <a:defRPr sz="1100">
-                <a:solidFill>
-                  <a:srgbClr val="38BDF8"/>
-                </a:solidFill>
-                <a:latin typeface="Courier New"/>
-              </a:defRPr>
-            </a:pPr>
-            <a:r>
-              <a:t>  setTimeout(() =&gt; {</a:t>
-            </a:r>
-          </a:p>
-          <a:p>
-            <a:pPr>
-              <a:defRPr sz="1100">
-                <a:solidFill>
-                  <a:srgbClr val="38BDF8"/>
-                </a:solidFill>
-                <a:latin typeface="Courier New"/>
-              </a:defRPr>
-            </a:pPr>
-            <a:r>
-              <a:t>    soundFlash.classList.remove("show");</a:t>
-            </a:r>
-          </a:p>
-          <a:p>
-            <a:pPr>
-              <a:defRPr sz="1100">
-                <a:solidFill>
-                  <a:srgbClr val="38BDF8"/>
-                </a:solidFill>
-                <a:latin typeface="Courier New"/>
-              </a:defRPr>
-            </a:pPr>
-            <a:r>
-              <a:t>  }, 600);</a:t>
-            </a:r>
-          </a:p>
-          <a:p>
-            <a:pPr>
-              <a:defRPr sz="1100">
-                <a:solidFill>
-                  <a:srgbClr val="38BDF8"/>
-                </a:solidFill>
-                <a:latin typeface="Courier New"/>
-              </a:defRPr>
-            </a:pPr>
-            <a:r>
-              <a:t>};</a:t>
-            </a:r>
-          </a:p>
-          <a:p>
-            <a:pPr>
-              <a:defRPr sz="1100">
-                <a:solidFill>
-                  <a:srgbClr val="38BDF8"/>
-                </a:solidFill>
-                <a:latin typeface="Courier New"/>
-              </a:defRPr>
-            </a:pPr>
-          </a:p>
-          <a:p>
-            <a:pPr>
-              <a:defRPr sz="1100">
-                <a:solidFill>
-                  <a:srgbClr val="38BDF8"/>
-                </a:solidFill>
-                <a:latin typeface="Courier New"/>
-              </a:defRPr>
-            </a:pPr>
-            <a:r>
-              <a:t>// Tap screen background to toggle</a:t>
-            </a:r>
-          </a:p>
-          <a:p>
-            <a:pPr>
-              <a:defRPr sz="1100">
-                <a:solidFill>
-                  <a:srgbClr val="38BDF8"/>
-                </a:solidFill>
-                <a:latin typeface="Courier New"/>
-              </a:defRPr>
-            </a:pPr>
-            <a:r>
-              <a:t>document.body.addEventListener("click", (e) =&gt; {</a:t>
-            </a:r>
-          </a:p>
-          <a:p>
-            <a:pPr>
-              <a:defRPr sz="1100">
-                <a:solidFill>
-                  <a:srgbClr val="38BDF8"/>
-                </a:solidFill>
-                <a:latin typeface="Courier New"/>
-              </a:defRPr>
-            </a:pPr>
-            <a:r>
-              <a:t>  if (e.target.closest("#start-screen") ||</a:t>
-            </a:r>
-          </a:p>
-          <a:p>
-            <a:pPr>
-              <a:defRPr sz="1100">
-                <a:solidFill>
-                  <a:srgbClr val="38BDF8"/>
-                </a:solidFill>
-                <a:latin typeface="Courier New"/>
-              </a:defRPr>
-            </a:pPr>
-            <a:r>
-              <a:t>      e.target.closest(".header") ||</a:t>
-            </a:r>
-          </a:p>
-          <a:p>
-            <a:pPr>
-              <a:defRPr sz="1100">
-                <a:solidFill>
-                  <a:srgbClr val="38BDF8"/>
-                </a:solidFill>
-                <a:latin typeface="Courier New"/>
-              </a:defRPr>
-            </a:pPr>
-            <a:r>
-              <a:t>      e.target.closest("#mute-button")) return;</a:t>
-            </a:r>
-          </a:p>
-          <a:p>
-            <a:pPr>
-              <a:defRPr sz="1100">
-                <a:solidFill>
-                  <a:srgbClr val="38BDF8"/>
-                </a:solidFill>
-                <a:latin typeface="Courier New"/>
-              </a:defRPr>
-            </a:pPr>
-            <a:r>
-              <a:t>  toggleMuteState();</a:t>
-            </a:r>
-          </a:p>
-          <a:p>
-            <a:pPr>
-              <a:defRPr sz="1100">
-                <a:solidFill>
-                  <a:srgbClr val="38BDF8"/>
-                </a:solidFill>
-                <a:latin typeface="Courier New"/>
-              </a:defRPr>
-            </a:pPr>
-            <a:r>
-              <a:t>});</a:t>
+              <a:t>If you switch tabs or lock your phone, iOS and Android suspend active webcam capture streams.</a:t>
+            </a:r>
+            <a:br/>
+            <a:r>
+              <a:t>We add a listener to the 'visibilitychange' event. When the user returns to the tab, the system automatically shuts down the stalled stream and requests a fresh, active camera capture.</a:t>
             </a:r>
           </a:p>
         </p:txBody>

</xml_diff>

<commit_message>
design: update slides to a playful and fancy light theme with Montserrat typography
</commit_message>
<xml_diff>
--- a/slides.pptx
+++ b/slides.pptx
@@ -3094,7 +3094,7 @@
     <p:bg>
       <p:bgPr>
         <a:solidFill>
-          <a:srgbClr val="0F172A"/>
+          <a:srgbClr val="FAF9FE"/>
         </a:solidFill>
         <a:effectLst/>
       </p:bgPr>
@@ -3108,14 +3108,143 @@
       <p:grpSpPr/>
       <p:sp>
         <p:nvSpPr>
-          <p:cNvPr id="2" name="TextBox 1"/>
+          <p:cNvPr id="2" name="Oval 1"/>
+          <p:cNvSpPr/>
+          <p:nvPr/>
+        </p:nvSpPr>
+        <p:spPr>
+          <a:xfrm>
+            <a:off x="9326880" y="-1371600"/>
+            <a:ext cx="4114800" cy="4114800"/>
+          </a:xfrm>
+          <a:prstGeom prst="ellipse">
+            <a:avLst/>
+          </a:prstGeom>
+          <a:solidFill>
+            <a:srgbClr val="EDE9FE"/>
+          </a:solidFill>
+          <a:ln>
+            <a:noFill/>
+          </a:ln>
+        </p:spPr>
+        <p:style>
+          <a:lnRef idx="1">
+            <a:schemeClr val="accent1"/>
+          </a:lnRef>
+          <a:fillRef idx="3">
+            <a:schemeClr val="accent1"/>
+          </a:fillRef>
+          <a:effectRef idx="2">
+            <a:schemeClr val="accent1"/>
+          </a:effectRef>
+          <a:fontRef idx="minor">
+            <a:schemeClr val="lt1"/>
+          </a:fontRef>
+        </p:style>
+        <p:txBody>
+          <a:bodyPr rtlCol="0" anchor="ctr"/>
+          <a:lstStyle/>
+          <a:p>
+            <a:pPr algn="ctr"/>
+          </a:p>
+        </p:txBody>
+      </p:sp>
+      <p:sp>
+        <p:nvSpPr>
+          <p:cNvPr id="3" name="Oval 2"/>
+          <p:cNvSpPr/>
+          <p:nvPr/>
+        </p:nvSpPr>
+        <p:spPr>
+          <a:xfrm>
+            <a:off x="8686800" y="1097280"/>
+            <a:ext cx="731520" cy="731520"/>
+          </a:xfrm>
+          <a:prstGeom prst="ellipse">
+            <a:avLst/>
+          </a:prstGeom>
+          <a:solidFill>
+            <a:srgbClr val="FEE2E2"/>
+          </a:solidFill>
+          <a:ln>
+            <a:noFill/>
+          </a:ln>
+        </p:spPr>
+        <p:style>
+          <a:lnRef idx="1">
+            <a:schemeClr val="accent1"/>
+          </a:lnRef>
+          <a:fillRef idx="3">
+            <a:schemeClr val="accent1"/>
+          </a:fillRef>
+          <a:effectRef idx="2">
+            <a:schemeClr val="accent1"/>
+          </a:effectRef>
+          <a:fontRef idx="minor">
+            <a:schemeClr val="lt1"/>
+          </a:fontRef>
+        </p:style>
+        <p:txBody>
+          <a:bodyPr rtlCol="0" anchor="ctr"/>
+          <a:lstStyle/>
+          <a:p>
+            <a:pPr algn="ctr"/>
+          </a:p>
+        </p:txBody>
+      </p:sp>
+      <p:sp>
+        <p:nvSpPr>
+          <p:cNvPr id="4" name="Rounded Rectangle 3"/>
+          <p:cNvSpPr/>
+          <p:nvPr/>
+        </p:nvSpPr>
+        <p:spPr>
+          <a:xfrm>
+            <a:off x="731520" y="2057400"/>
+            <a:ext cx="109728" cy="1645920"/>
+          </a:xfrm>
+          <a:prstGeom prst="roundRect">
+            <a:avLst/>
+          </a:prstGeom>
+          <a:solidFill>
+            <a:srgbClr val="7C3AED"/>
+          </a:solidFill>
+          <a:ln>
+            <a:noFill/>
+          </a:ln>
+        </p:spPr>
+        <p:style>
+          <a:lnRef idx="1">
+            <a:schemeClr val="accent1"/>
+          </a:lnRef>
+          <a:fillRef idx="3">
+            <a:schemeClr val="accent1"/>
+          </a:fillRef>
+          <a:effectRef idx="2">
+            <a:schemeClr val="accent1"/>
+          </a:effectRef>
+          <a:fontRef idx="minor">
+            <a:schemeClr val="lt1"/>
+          </a:fontRef>
+        </p:style>
+        <p:txBody>
+          <a:bodyPr rtlCol="0" anchor="ctr"/>
+          <a:lstStyle/>
+          <a:p>
+            <a:pPr algn="ctr"/>
+          </a:p>
+        </p:txBody>
+      </p:sp>
+      <p:sp>
+        <p:nvSpPr>
+          <p:cNvPr id="5" name="TextBox 4"/>
           <p:cNvSpPr txBox="1"/>
           <p:nvPr/>
         </p:nvSpPr>
         <p:spPr>
           <a:xfrm>
-            <a:off x="914400" y="2011680"/>
-            <a:ext cx="10332720" cy="1828800"/>
+            <a:off x="1097280" y="2011680"/>
+            <a:ext cx="10149840" cy="1828800"/>
           </a:xfrm>
           <a:prstGeom prst="rect">
             <a:avLst/>
@@ -3131,9 +3260,9 @@
             <a:pPr>
               <a:defRPr sz="4600" b="1">
                 <a:solidFill>
-                  <a:srgbClr val="6366F1"/>
-                </a:solidFill>
-                <a:latin typeface="Plus Jakarta Sans"/>
+                  <a:srgbClr val="7C3AED"/>
+                </a:solidFill>
+                <a:latin typeface="Montserrat"/>
               </a:defRPr>
             </a:pPr>
             <a:r>
@@ -3147,9 +3276,9 @@
               </a:spcBef>
               <a:defRPr sz="2000">
                 <a:solidFill>
-                  <a:srgbClr val="F8FAFC"/>
-                </a:solidFill>
-                <a:latin typeface="Plus Jakarta Sans"/>
+                  <a:srgbClr val="1E1B4B"/>
+                </a:solidFill>
+                <a:latin typeface="Montserrat"/>
               </a:defRPr>
             </a:pPr>
             <a:r>
@@ -3160,7 +3289,7 @@
       </p:sp>
       <p:sp>
         <p:nvSpPr>
-          <p:cNvPr id="3" name="TextBox 2"/>
+          <p:cNvPr id="6" name="TextBox 5"/>
           <p:cNvSpPr txBox="1"/>
           <p:nvPr/>
         </p:nvSpPr>
@@ -3183,9 +3312,9 @@
             <a:pPr>
               <a:defRPr sz="1400">
                 <a:solidFill>
-                  <a:srgbClr val="94A3B8"/>
-                </a:solidFill>
-                <a:latin typeface="Plus Jakarta Sans"/>
+                  <a:srgbClr val="475569"/>
+                </a:solidFill>
+                <a:latin typeface="Montserrat"/>
               </a:defRPr>
             </a:pPr>
             <a:r>
@@ -3208,7 +3337,7 @@
     <p:bg>
       <p:bgPr>
         <a:solidFill>
-          <a:srgbClr val="0F172A"/>
+          <a:srgbClr val="FAF9FE"/>
         </a:solidFill>
         <a:effectLst/>
       </p:bgPr>
@@ -3245,9 +3374,9 @@
             <a:pPr>
               <a:defRPr sz="1000" b="1">
                 <a:solidFill>
-                  <a:srgbClr val="6366F1"/>
-                </a:solidFill>
-                <a:latin typeface="Plus Jakarta Sans"/>
+                  <a:srgbClr val="EC4899"/>
+                </a:solidFill>
+                <a:latin typeface="Montserrat"/>
               </a:defRPr>
             </a:pPr>
             <a:r>
@@ -3281,9 +3410,9 @@
             <a:pPr>
               <a:defRPr sz="2600" b="1">
                 <a:solidFill>
-                  <a:srgbClr val="F8FAFC"/>
-                </a:solidFill>
-                <a:latin typeface="Plus Jakarta Sans"/>
+                  <a:srgbClr val="1E1B4B"/>
+                </a:solidFill>
+                <a:latin typeface="Montserrat"/>
               </a:defRPr>
             </a:pPr>
             <a:r>
@@ -3294,144 +3423,23 @@
       </p:sp>
       <p:sp>
         <p:nvSpPr>
-          <p:cNvPr id="4" name="TextBox 3"/>
-          <p:cNvSpPr txBox="1"/>
-          <p:nvPr/>
-        </p:nvSpPr>
-        <p:spPr>
-          <a:xfrm>
-            <a:off x="731520" y="1645920"/>
-            <a:ext cx="4572000" cy="4572000"/>
-          </a:xfrm>
-          <a:prstGeom prst="rect">
-            <a:avLst/>
-          </a:prstGeom>
-          <a:noFill/>
-        </p:spPr>
-        <p:txBody>
-          <a:bodyPr wrap="square">
-            <a:spAutoFit/>
-          </a:bodyPr>
-          <a:lstStyle/>
-          <a:p>
-            <a:pPr>
-              <a:spcBef>
-                <a:spcPts val="1500"/>
-              </a:spcBef>
-              <a:defRPr sz="1600" b="1">
-                <a:solidFill>
-                  <a:srgbClr val="6366F1"/>
-                </a:solidFill>
-                <a:latin typeface="Plus Jakarta Sans"/>
-              </a:defRPr>
-            </a:pPr>
-            <a:r>
-              <a:t>• Bypassing Autoplay Restrictions:</a:t>
-            </a:r>
-          </a:p>
-          <a:p>
-            <a:pPr>
-              <a:spcBef>
-                <a:spcPts val="400"/>
-              </a:spcBef>
-              <a:defRPr sz="1300">
-                <a:solidFill>
-                  <a:srgbClr val="94A3B8"/>
-                </a:solidFill>
-                <a:latin typeface="Plus Jakarta Sans"/>
-              </a:defRPr>
-            </a:pPr>
-            <a:r>
-              <a:t>Mobile browsers block videos from playing automatically if they have sound. To build a seamless AR experience where the video starts immediately when the card is scanned, the video element MUST have the 'muted' attribute.</a:t>
-            </a:r>
-          </a:p>
-          <a:p>
-            <a:pPr>
-              <a:spcBef>
-                <a:spcPts val="1500"/>
-              </a:spcBef>
-              <a:defRPr sz="1600" b="1">
-                <a:solidFill>
-                  <a:srgbClr val="6366F1"/>
-                </a:solidFill>
-                <a:latin typeface="Plus Jakarta Sans"/>
-              </a:defRPr>
-            </a:pPr>
-            <a:r>
-              <a:t>• Instagram-Style Screen Taps:</a:t>
-            </a:r>
-          </a:p>
-          <a:p>
-            <a:pPr>
-              <a:spcBef>
-                <a:spcPts val="400"/>
-              </a:spcBef>
-              <a:defRPr sz="1300">
-                <a:solidFill>
-                  <a:srgbClr val="94A3B8"/>
-                </a:solidFill>
-                <a:latin typeface="Plus Jakarta Sans"/>
-              </a:defRPr>
-            </a:pPr>
-            <a:r>
-              <a:t>To let students unmute the video overlay easily, we attach a page-wide click listener. Clicking anywhere on the camera canvas toggles between muted and unmuted playback.</a:t>
-            </a:r>
-          </a:p>
-          <a:p>
-            <a:pPr>
-              <a:spcBef>
-                <a:spcPts val="1500"/>
-              </a:spcBef>
-              <a:defRPr sz="1600" b="1">
-                <a:solidFill>
-                  <a:srgbClr val="6366F1"/>
-                </a:solidFill>
-                <a:latin typeface="Plus Jakarta Sans"/>
-              </a:defRPr>
-            </a:pPr>
-            <a:r>
-              <a:t>• Visual pop-up indicators:</a:t>
-            </a:r>
-          </a:p>
-          <a:p>
-            <a:pPr>
-              <a:spcBef>
-                <a:spcPts val="400"/>
-              </a:spcBef>
-              <a:defRPr sz="1300">
-                <a:solidFill>
-                  <a:srgbClr val="94A3B8"/>
-                </a:solidFill>
-                <a:latin typeface="Plus Jakarta Sans"/>
-              </a:defRPr>
-            </a:pPr>
-            <a:r>
-              <a:t>When unmuting, a circular speaker status icon flashes in the center of the viewport for 600ms before fading away, matching Instagram's native video layout.</a:t>
-            </a:r>
-          </a:p>
-        </p:txBody>
-      </p:sp>
-      <p:sp>
-        <p:nvSpPr>
-          <p:cNvPr id="5" name="Rectangle 4"/>
+          <p:cNvPr id="4" name="Rectangle 3"/>
           <p:cNvSpPr/>
           <p:nvPr/>
         </p:nvSpPr>
         <p:spPr>
           <a:xfrm>
-            <a:off x="5669280" y="1645920"/>
-            <a:ext cx="5760720" cy="4389120"/>
+            <a:off x="731520" y="1325880"/>
+            <a:ext cx="10728655" cy="18288"/>
           </a:xfrm>
           <a:prstGeom prst="rect">
             <a:avLst/>
           </a:prstGeom>
           <a:solidFill>
-            <a:srgbClr val="1E293B"/>
+            <a:srgbClr val="7C3AED"/>
           </a:solidFill>
-          <a:ln w="12700">
-            <a:solidFill>
-              <a:srgbClr val="475569"/>
-            </a:solidFill>
+          <a:ln>
+            <a:noFill/>
           </a:ln>
         </p:spPr>
         <p:style>
@@ -3449,13 +3457,177 @@
           </a:fontRef>
         </p:style>
         <p:txBody>
+          <a:bodyPr rtlCol="0" anchor="ctr"/>
+          <a:lstStyle/>
+          <a:p>
+            <a:pPr algn="ctr"/>
+          </a:p>
+        </p:txBody>
+      </p:sp>
+      <p:sp>
+        <p:nvSpPr>
+          <p:cNvPr id="5" name="TextBox 4"/>
+          <p:cNvSpPr txBox="1"/>
+          <p:nvPr/>
+        </p:nvSpPr>
+        <p:spPr>
+          <a:xfrm>
+            <a:off x="731520" y="1645920"/>
+            <a:ext cx="4572000" cy="4572000"/>
+          </a:xfrm>
+          <a:prstGeom prst="rect">
+            <a:avLst/>
+          </a:prstGeom>
+          <a:noFill/>
+        </p:spPr>
+        <p:txBody>
+          <a:bodyPr wrap="square">
+            <a:spAutoFit/>
+          </a:bodyPr>
+          <a:lstStyle/>
+          <a:p>
+            <a:pPr>
+              <a:spcBef>
+                <a:spcPts val="1500"/>
+              </a:spcBef>
+              <a:defRPr sz="1600" b="1">
+                <a:solidFill>
+                  <a:srgbClr val="7C3AED"/>
+                </a:solidFill>
+                <a:latin typeface="Montserrat"/>
+              </a:defRPr>
+            </a:pPr>
+            <a:r>
+              <a:t>• Bypassing Autoplay Restrictions:</a:t>
+            </a:r>
+          </a:p>
+          <a:p>
+            <a:pPr>
+              <a:spcBef>
+                <a:spcPts val="400"/>
+              </a:spcBef>
+              <a:defRPr sz="1300">
+                <a:solidFill>
+                  <a:srgbClr val="475569"/>
+                </a:solidFill>
+                <a:latin typeface="Montserrat"/>
+              </a:defRPr>
+            </a:pPr>
+            <a:r>
+              <a:t>Mobile browsers block videos from playing automatically if they have sound. To build a seamless AR experience where the video starts immediately when the card is scanned, the video element MUST have the 'muted' attribute.</a:t>
+            </a:r>
+          </a:p>
+          <a:p>
+            <a:pPr>
+              <a:spcBef>
+                <a:spcPts val="1500"/>
+              </a:spcBef>
+              <a:defRPr sz="1600" b="1">
+                <a:solidFill>
+                  <a:srgbClr val="7C3AED"/>
+                </a:solidFill>
+                <a:latin typeface="Montserrat"/>
+              </a:defRPr>
+            </a:pPr>
+            <a:r>
+              <a:t>• Instagram-Style Screen Taps:</a:t>
+            </a:r>
+          </a:p>
+          <a:p>
+            <a:pPr>
+              <a:spcBef>
+                <a:spcPts val="400"/>
+              </a:spcBef>
+              <a:defRPr sz="1300">
+                <a:solidFill>
+                  <a:srgbClr val="475569"/>
+                </a:solidFill>
+                <a:latin typeface="Montserrat"/>
+              </a:defRPr>
+            </a:pPr>
+            <a:r>
+              <a:t>To let students unmute the video overlay easily, we attach a page-wide click listener. Clicking anywhere on the camera canvas toggles between muted and unmuted playback.</a:t>
+            </a:r>
+          </a:p>
+          <a:p>
+            <a:pPr>
+              <a:spcBef>
+                <a:spcPts val="1500"/>
+              </a:spcBef>
+              <a:defRPr sz="1600" b="1">
+                <a:solidFill>
+                  <a:srgbClr val="7C3AED"/>
+                </a:solidFill>
+                <a:latin typeface="Montserrat"/>
+              </a:defRPr>
+            </a:pPr>
+            <a:r>
+              <a:t>• Visual pop-up indicators:</a:t>
+            </a:r>
+          </a:p>
+          <a:p>
+            <a:pPr>
+              <a:spcBef>
+                <a:spcPts val="400"/>
+              </a:spcBef>
+              <a:defRPr sz="1300">
+                <a:solidFill>
+                  <a:srgbClr val="475569"/>
+                </a:solidFill>
+                <a:latin typeface="Montserrat"/>
+              </a:defRPr>
+            </a:pPr>
+            <a:r>
+              <a:t>When unmuting, a circular speaker status icon flashes in the center of the viewport for 600ms before fading away, matching Instagram's native video layout.</a:t>
+            </a:r>
+          </a:p>
+        </p:txBody>
+      </p:sp>
+      <p:sp>
+        <p:nvSpPr>
+          <p:cNvPr id="6" name="Rounded Rectangle 5"/>
+          <p:cNvSpPr/>
+          <p:nvPr/>
+        </p:nvSpPr>
+        <p:spPr>
+          <a:xfrm>
+            <a:off x="5669280" y="1645920"/>
+            <a:ext cx="5760720" cy="4389120"/>
+          </a:xfrm>
+          <a:prstGeom prst="roundRect">
+            <a:avLst/>
+          </a:prstGeom>
+          <a:solidFill>
+            <a:srgbClr val="F1F5F9"/>
+          </a:solidFill>
+          <a:ln w="12700">
+            <a:solidFill>
+              <a:srgbClr val="E2E8F0"/>
+            </a:solidFill>
+          </a:ln>
+        </p:spPr>
+        <p:style>
+          <a:lnRef idx="1">
+            <a:schemeClr val="accent1"/>
+          </a:lnRef>
+          <a:fillRef idx="3">
+            <a:schemeClr val="accent1"/>
+          </a:fillRef>
+          <a:effectRef idx="2">
+            <a:schemeClr val="accent1"/>
+          </a:effectRef>
+          <a:fontRef idx="minor">
+            <a:schemeClr val="lt1"/>
+          </a:fontRef>
+        </p:style>
+        <p:txBody>
           <a:bodyPr rtlCol="0" anchor="ctr" wrap="square" lIns="182880" rIns="182880" tIns="182880" bIns="182880"/>
           <a:lstStyle/>
           <a:p>
             <a:pPr algn="ctr">
               <a:defRPr sz="1100">
                 <a:solidFill>
-                  <a:srgbClr val="38BDF8"/>
+                  <a:srgbClr val="0F766E"/>
                 </a:solidFill>
                 <a:latin typeface="Courier New"/>
               </a:defRPr>
@@ -3468,7 +3640,7 @@
             <a:pPr>
               <a:defRPr sz="1100">
                 <a:solidFill>
-                  <a:srgbClr val="38BDF8"/>
+                  <a:srgbClr val="0F766E"/>
                 </a:solidFill>
                 <a:latin typeface="Courier New"/>
               </a:defRPr>
@@ -3481,7 +3653,7 @@
             <a:pPr>
               <a:defRPr sz="1100">
                 <a:solidFill>
-                  <a:srgbClr val="38BDF8"/>
+                  <a:srgbClr val="0F766E"/>
                 </a:solidFill>
                 <a:latin typeface="Courier New"/>
               </a:defRPr>
@@ -3494,7 +3666,7 @@
             <a:pPr>
               <a:defRPr sz="1100">
                 <a:solidFill>
-                  <a:srgbClr val="38BDF8"/>
+                  <a:srgbClr val="0F766E"/>
                 </a:solidFill>
                 <a:latin typeface="Courier New"/>
               </a:defRPr>
@@ -3507,7 +3679,7 @@
             <a:pPr>
               <a:defRPr sz="1100">
                 <a:solidFill>
-                  <a:srgbClr val="38BDF8"/>
+                  <a:srgbClr val="0F766E"/>
                 </a:solidFill>
                 <a:latin typeface="Courier New"/>
               </a:defRPr>
@@ -3520,7 +3692,7 @@
             <a:pPr>
               <a:defRPr sz="1100">
                 <a:solidFill>
-                  <a:srgbClr val="38BDF8"/>
+                  <a:srgbClr val="0F766E"/>
                 </a:solidFill>
                 <a:latin typeface="Courier New"/>
               </a:defRPr>
@@ -3533,7 +3705,7 @@
             <a:pPr>
               <a:defRPr sz="1100">
                 <a:solidFill>
-                  <a:srgbClr val="38BDF8"/>
+                  <a:srgbClr val="0F766E"/>
                 </a:solidFill>
                 <a:latin typeface="Courier New"/>
               </a:defRPr>
@@ -3546,7 +3718,7 @@
             <a:pPr>
               <a:defRPr sz="1100">
                 <a:solidFill>
-                  <a:srgbClr val="38BDF8"/>
+                  <a:srgbClr val="0F766E"/>
                 </a:solidFill>
                 <a:latin typeface="Courier New"/>
               </a:defRPr>
@@ -3559,7 +3731,7 @@
             <a:pPr>
               <a:defRPr sz="1100">
                 <a:solidFill>
-                  <a:srgbClr val="38BDF8"/>
+                  <a:srgbClr val="0F766E"/>
                 </a:solidFill>
                 <a:latin typeface="Courier New"/>
               </a:defRPr>
@@ -3572,7 +3744,7 @@
             <a:pPr>
               <a:defRPr sz="1100">
                 <a:solidFill>
-                  <a:srgbClr val="38BDF8"/>
+                  <a:srgbClr val="0F766E"/>
                 </a:solidFill>
                 <a:latin typeface="Courier New"/>
               </a:defRPr>
@@ -3585,7 +3757,7 @@
             <a:pPr>
               <a:defRPr sz="1100">
                 <a:solidFill>
-                  <a:srgbClr val="38BDF8"/>
+                  <a:srgbClr val="0F766E"/>
                 </a:solidFill>
                 <a:latin typeface="Courier New"/>
               </a:defRPr>
@@ -3598,7 +3770,7 @@
             <a:pPr>
               <a:defRPr sz="1100">
                 <a:solidFill>
-                  <a:srgbClr val="38BDF8"/>
+                  <a:srgbClr val="0F766E"/>
                 </a:solidFill>
                 <a:latin typeface="Courier New"/>
               </a:defRPr>
@@ -3608,7 +3780,7 @@
             <a:pPr>
               <a:defRPr sz="1100">
                 <a:solidFill>
-                  <a:srgbClr val="38BDF8"/>
+                  <a:srgbClr val="0F766E"/>
                 </a:solidFill>
                 <a:latin typeface="Courier New"/>
               </a:defRPr>
@@ -3621,7 +3793,7 @@
             <a:pPr>
               <a:defRPr sz="1100">
                 <a:solidFill>
-                  <a:srgbClr val="38BDF8"/>
+                  <a:srgbClr val="0F766E"/>
                 </a:solidFill>
                 <a:latin typeface="Courier New"/>
               </a:defRPr>
@@ -3634,7 +3806,7 @@
             <a:pPr>
               <a:defRPr sz="1100">
                 <a:solidFill>
-                  <a:srgbClr val="38BDF8"/>
+                  <a:srgbClr val="0F766E"/>
                 </a:solidFill>
                 <a:latin typeface="Courier New"/>
               </a:defRPr>
@@ -3647,7 +3819,7 @@
             <a:pPr>
               <a:defRPr sz="1100">
                 <a:solidFill>
-                  <a:srgbClr val="38BDF8"/>
+                  <a:srgbClr val="0F766E"/>
                 </a:solidFill>
                 <a:latin typeface="Courier New"/>
               </a:defRPr>
@@ -3660,7 +3832,7 @@
             <a:pPr>
               <a:defRPr sz="1100">
                 <a:solidFill>
-                  <a:srgbClr val="38BDF8"/>
+                  <a:srgbClr val="0F766E"/>
                 </a:solidFill>
                 <a:latin typeface="Courier New"/>
               </a:defRPr>
@@ -3673,7 +3845,7 @@
             <a:pPr>
               <a:defRPr sz="1100">
                 <a:solidFill>
-                  <a:srgbClr val="38BDF8"/>
+                  <a:srgbClr val="0F766E"/>
                 </a:solidFill>
                 <a:latin typeface="Courier New"/>
               </a:defRPr>
@@ -3686,7 +3858,7 @@
             <a:pPr>
               <a:defRPr sz="1100">
                 <a:solidFill>
-                  <a:srgbClr val="38BDF8"/>
+                  <a:srgbClr val="0F766E"/>
                 </a:solidFill>
                 <a:latin typeface="Courier New"/>
               </a:defRPr>
@@ -3699,7 +3871,7 @@
             <a:pPr>
               <a:defRPr sz="1100">
                 <a:solidFill>
-                  <a:srgbClr val="38BDF8"/>
+                  <a:srgbClr val="0F766E"/>
                 </a:solidFill>
                 <a:latin typeface="Courier New"/>
               </a:defRPr>
@@ -3712,7 +3884,7 @@
             <a:pPr>
               <a:defRPr sz="1100">
                 <a:solidFill>
-                  <a:srgbClr val="38BDF8"/>
+                  <a:srgbClr val="0F766E"/>
                 </a:solidFill>
                 <a:latin typeface="Courier New"/>
               </a:defRPr>
@@ -3722,7 +3894,7 @@
             <a:pPr>
               <a:defRPr sz="1100">
                 <a:solidFill>
-                  <a:srgbClr val="38BDF8"/>
+                  <a:srgbClr val="0F766E"/>
                 </a:solidFill>
                 <a:latin typeface="Courier New"/>
               </a:defRPr>
@@ -3735,7 +3907,7 @@
             <a:pPr>
               <a:defRPr sz="1100">
                 <a:solidFill>
-                  <a:srgbClr val="38BDF8"/>
+                  <a:srgbClr val="0F766E"/>
                 </a:solidFill>
                 <a:latin typeface="Courier New"/>
               </a:defRPr>
@@ -3748,7 +3920,7 @@
             <a:pPr>
               <a:defRPr sz="1100">
                 <a:solidFill>
-                  <a:srgbClr val="38BDF8"/>
+                  <a:srgbClr val="0F766E"/>
                 </a:solidFill>
                 <a:latin typeface="Courier New"/>
               </a:defRPr>
@@ -3761,7 +3933,7 @@
             <a:pPr>
               <a:defRPr sz="1100">
                 <a:solidFill>
-                  <a:srgbClr val="38BDF8"/>
+                  <a:srgbClr val="0F766E"/>
                 </a:solidFill>
                 <a:latin typeface="Courier New"/>
               </a:defRPr>
@@ -3774,7 +3946,7 @@
             <a:pPr>
               <a:defRPr sz="1100">
                 <a:solidFill>
-                  <a:srgbClr val="38BDF8"/>
+                  <a:srgbClr val="0F766E"/>
                 </a:solidFill>
                 <a:latin typeface="Courier New"/>
               </a:defRPr>
@@ -3787,7 +3959,7 @@
             <a:pPr>
               <a:defRPr sz="1100">
                 <a:solidFill>
-                  <a:srgbClr val="38BDF8"/>
+                  <a:srgbClr val="0F766E"/>
                 </a:solidFill>
                 <a:latin typeface="Courier New"/>
               </a:defRPr>
@@ -3800,7 +3972,7 @@
             <a:pPr>
               <a:defRPr sz="1100">
                 <a:solidFill>
-                  <a:srgbClr val="38BDF8"/>
+                  <a:srgbClr val="0F766E"/>
                 </a:solidFill>
                 <a:latin typeface="Courier New"/>
               </a:defRPr>
@@ -3825,7 +3997,7 @@
     <p:bg>
       <p:bgPr>
         <a:solidFill>
-          <a:srgbClr val="0F172A"/>
+          <a:srgbClr val="FAF9FE"/>
         </a:solidFill>
         <a:effectLst/>
       </p:bgPr>
@@ -3862,9 +4034,9 @@
             <a:pPr>
               <a:defRPr sz="1000" b="1">
                 <a:solidFill>
-                  <a:srgbClr val="6366F1"/>
-                </a:solidFill>
-                <a:latin typeface="Plus Jakarta Sans"/>
+                  <a:srgbClr val="EC4899"/>
+                </a:solidFill>
+                <a:latin typeface="Montserrat"/>
               </a:defRPr>
             </a:pPr>
             <a:r>
@@ -3898,9 +4070,9 @@
             <a:pPr>
               <a:defRPr sz="2600" b="1">
                 <a:solidFill>
-                  <a:srgbClr val="F8FAFC"/>
-                </a:solidFill>
-                <a:latin typeface="Plus Jakarta Sans"/>
+                  <a:srgbClr val="1E1B4B"/>
+                </a:solidFill>
+                <a:latin typeface="Montserrat"/>
               </a:defRPr>
             </a:pPr>
             <a:r>
@@ -3911,7 +4083,50 @@
       </p:sp>
       <p:sp>
         <p:nvSpPr>
-          <p:cNvPr id="4" name="TextBox 3"/>
+          <p:cNvPr id="4" name="Rectangle 3"/>
+          <p:cNvSpPr/>
+          <p:nvPr/>
+        </p:nvSpPr>
+        <p:spPr>
+          <a:xfrm>
+            <a:off x="731520" y="1325880"/>
+            <a:ext cx="10728655" cy="18288"/>
+          </a:xfrm>
+          <a:prstGeom prst="rect">
+            <a:avLst/>
+          </a:prstGeom>
+          <a:solidFill>
+            <a:srgbClr val="7C3AED"/>
+          </a:solidFill>
+          <a:ln>
+            <a:noFill/>
+          </a:ln>
+        </p:spPr>
+        <p:style>
+          <a:lnRef idx="1">
+            <a:schemeClr val="accent1"/>
+          </a:lnRef>
+          <a:fillRef idx="3">
+            <a:schemeClr val="accent1"/>
+          </a:fillRef>
+          <a:effectRef idx="2">
+            <a:schemeClr val="accent1"/>
+          </a:effectRef>
+          <a:fontRef idx="minor">
+            <a:schemeClr val="lt1"/>
+          </a:fontRef>
+        </p:style>
+        <p:txBody>
+          <a:bodyPr rtlCol="0" anchor="ctr"/>
+          <a:lstStyle/>
+          <a:p>
+            <a:pPr algn="ctr"/>
+          </a:p>
+        </p:txBody>
+      </p:sp>
+      <p:sp>
+        <p:nvSpPr>
+          <p:cNvPr id="5" name="TextBox 4"/>
           <p:cNvSpPr txBox="1"/>
           <p:nvPr/>
         </p:nvSpPr>
@@ -3937,9 +4152,9 @@
               </a:spcBef>
               <a:defRPr sz="1600" b="1">
                 <a:solidFill>
-                  <a:srgbClr val="6366F1"/>
-                </a:solidFill>
-                <a:latin typeface="Plus Jakarta Sans"/>
+                  <a:srgbClr val="7C3AED"/>
+                </a:solidFill>
+                <a:latin typeface="Montserrat"/>
               </a:defRPr>
             </a:pPr>
             <a:r>
@@ -3953,9 +4168,9 @@
               </a:spcBef>
               <a:defRPr sz="1300">
                 <a:solidFill>
-                  <a:srgbClr val="94A3B8"/>
-                </a:solidFill>
-                <a:latin typeface="Plus Jakarta Sans"/>
+                  <a:srgbClr val="475569"/>
+                </a:solidFill>
+                <a:latin typeface="Montserrat"/>
               </a:defRPr>
             </a:pPr>
             <a:r>
@@ -3969,9 +4184,9 @@
               </a:spcBef>
               <a:defRPr sz="1600" b="1">
                 <a:solidFill>
-                  <a:srgbClr val="6366F1"/>
-                </a:solidFill>
-                <a:latin typeface="Plus Jakarta Sans"/>
+                  <a:srgbClr val="7C3AED"/>
+                </a:solidFill>
+                <a:latin typeface="Montserrat"/>
               </a:defRPr>
             </a:pPr>
             <a:r>
@@ -3985,9 +4200,9 @@
               </a:spcBef>
               <a:defRPr sz="1300">
                 <a:solidFill>
-                  <a:srgbClr val="94A3B8"/>
-                </a:solidFill>
-                <a:latin typeface="Plus Jakarta Sans"/>
+                  <a:srgbClr val="475569"/>
+                </a:solidFill>
+                <a:latin typeface="Montserrat"/>
               </a:defRPr>
             </a:pPr>
             <a:r>
@@ -4001,9 +4216,9 @@
               </a:spcBef>
               <a:defRPr sz="1600" b="1">
                 <a:solidFill>
-                  <a:srgbClr val="6366F1"/>
-                </a:solidFill>
-                <a:latin typeface="Plus Jakarta Sans"/>
+                  <a:srgbClr val="7C3AED"/>
+                </a:solidFill>
+                <a:latin typeface="Montserrat"/>
               </a:defRPr>
             </a:pPr>
             <a:r>
@@ -4017,9 +4232,9 @@
               </a:spcBef>
               <a:defRPr sz="1300">
                 <a:solidFill>
-                  <a:srgbClr val="94A3B8"/>
-                </a:solidFill>
-                <a:latin typeface="Plus Jakarta Sans"/>
+                  <a:srgbClr val="475569"/>
+                </a:solidFill>
+                <a:latin typeface="Montserrat"/>
               </a:defRPr>
             </a:pPr>
             <a:r>
@@ -4030,7 +4245,7 @@
       </p:sp>
       <p:pic>
         <p:nvPicPr>
-          <p:cNvPr id="5" name="Picture 4" descr="screenshot_preview.png"/>
+          <p:cNvPr id="6" name="Picture 5" descr="screenshot_preview.png"/>
           <p:cNvPicPr>
             <a:picLocks noChangeAspect="1"/>
           </p:cNvPicPr>
@@ -4066,7 +4281,7 @@
     <p:bg>
       <p:bgPr>
         <a:solidFill>
-          <a:srgbClr val="0F172A"/>
+          <a:srgbClr val="FAF9FE"/>
         </a:solidFill>
         <a:effectLst/>
       </p:bgPr>
@@ -4103,9 +4318,9 @@
             <a:pPr>
               <a:defRPr sz="1000" b="1">
                 <a:solidFill>
-                  <a:srgbClr val="6366F1"/>
-                </a:solidFill>
-                <a:latin typeface="Plus Jakarta Sans"/>
+                  <a:srgbClr val="EC4899"/>
+                </a:solidFill>
+                <a:latin typeface="Montserrat"/>
               </a:defRPr>
             </a:pPr>
             <a:r>
@@ -4139,9 +4354,9 @@
             <a:pPr>
               <a:defRPr sz="2600" b="1">
                 <a:solidFill>
-                  <a:srgbClr val="F8FAFC"/>
-                </a:solidFill>
-                <a:latin typeface="Plus Jakarta Sans"/>
+                  <a:srgbClr val="1E1B4B"/>
+                </a:solidFill>
+                <a:latin typeface="Montserrat"/>
               </a:defRPr>
             </a:pPr>
             <a:r>
@@ -4152,119 +4367,304 @@
       </p:sp>
       <p:sp>
         <p:nvSpPr>
-          <p:cNvPr id="4" name="TextBox 3"/>
-          <p:cNvSpPr txBox="1"/>
+          <p:cNvPr id="4" name="Rectangle 3"/>
+          <p:cNvSpPr/>
           <p:nvPr/>
         </p:nvSpPr>
         <p:spPr>
           <a:xfrm>
-            <a:off x="731520" y="1645920"/>
-            <a:ext cx="10698480" cy="4572000"/>
+            <a:off x="731520" y="1325880"/>
+            <a:ext cx="10728655" cy="18288"/>
           </a:xfrm>
           <a:prstGeom prst="rect">
             <a:avLst/>
           </a:prstGeom>
-          <a:noFill/>
-        </p:spPr>
-        <p:txBody>
-          <a:bodyPr wrap="square">
-            <a:spAutoFit/>
-          </a:bodyPr>
-          <a:lstStyle/>
-          <a:p>
-            <a:pPr>
-              <a:spcBef>
-                <a:spcPts val="1500"/>
-              </a:spcBef>
-              <a:defRPr sz="1800" b="1">
-                <a:solidFill>
-                  <a:srgbClr val="6366F1"/>
-                </a:solidFill>
-                <a:latin typeface="Plus Jakarta Sans"/>
-              </a:defRPr>
-            </a:pPr>
-            <a:r>
-              <a:t>1. WebRTC (Webcam Feed Access)</a:t>
-            </a:r>
-          </a:p>
-          <a:p>
-            <a:pPr>
-              <a:spcBef>
+          <a:solidFill>
+            <a:srgbClr val="7C3AED"/>
+          </a:solidFill>
+          <a:ln>
+            <a:noFill/>
+          </a:ln>
+        </p:spPr>
+        <p:style>
+          <a:lnRef idx="1">
+            <a:schemeClr val="accent1"/>
+          </a:lnRef>
+          <a:fillRef idx="3">
+            <a:schemeClr val="accent1"/>
+          </a:fillRef>
+          <a:effectRef idx="2">
+            <a:schemeClr val="accent1"/>
+          </a:effectRef>
+          <a:fontRef idx="minor">
+            <a:schemeClr val="lt1"/>
+          </a:fontRef>
+        </p:style>
+        <p:txBody>
+          <a:bodyPr rtlCol="0" anchor="ctr"/>
+          <a:lstStyle/>
+          <a:p>
+            <a:pPr algn="ctr"/>
+          </a:p>
+        </p:txBody>
+      </p:sp>
+      <p:sp>
+        <p:nvSpPr>
+          <p:cNvPr id="5" name="Rounded Rectangle 4"/>
+          <p:cNvSpPr/>
+          <p:nvPr/>
+        </p:nvSpPr>
+        <p:spPr>
+          <a:xfrm>
+            <a:off x="731520" y="1828800"/>
+            <a:ext cx="3291840" cy="4114800"/>
+          </a:xfrm>
+          <a:prstGeom prst="roundRect">
+            <a:avLst/>
+          </a:prstGeom>
+          <a:solidFill>
+            <a:srgbClr val="F1F5F9"/>
+          </a:solidFill>
+          <a:ln w="19050">
+            <a:solidFill>
+              <a:srgbClr val="E2E8F0"/>
+            </a:solidFill>
+          </a:ln>
+        </p:spPr>
+        <p:style>
+          <a:lnRef idx="1">
+            <a:schemeClr val="accent1"/>
+          </a:lnRef>
+          <a:fillRef idx="3">
+            <a:schemeClr val="accent1"/>
+          </a:fillRef>
+          <a:effectRef idx="2">
+            <a:schemeClr val="accent1"/>
+          </a:effectRef>
+          <a:fontRef idx="minor">
+            <a:schemeClr val="lt1"/>
+          </a:fontRef>
+        </p:style>
+        <p:txBody>
+          <a:bodyPr rtlCol="0" anchor="ctr" wrap="square" lIns="228600" rIns="228600" tIns="274320" bIns="274320"/>
+          <a:lstStyle/>
+          <a:p>
+            <a:pPr algn="ctr">
+              <a:spcAft>
                 <a:spcPts val="400"/>
-              </a:spcBef>
-              <a:defRPr sz="1400">
-                <a:solidFill>
-                  <a:srgbClr val="94A3B8"/>
-                </a:solidFill>
-                <a:latin typeface="Plus Jakarta Sans"/>
+              </a:spcAft>
+              <a:defRPr sz="1100" b="1">
+                <a:solidFill>
+                  <a:srgbClr val="EC4899"/>
+                </a:solidFill>
+                <a:latin typeface="Montserrat"/>
+              </a:defRPr>
+            </a:pPr>
+            <a:r>
+              <a:t>1. WEBRTC</a:t>
+            </a:r>
+          </a:p>
+          <a:p>
+            <a:pPr algn="ctr">
+              <a:spcAft>
+                <a:spcPts val="1400"/>
+              </a:spcAft>
+              <a:defRPr sz="1600" b="1">
+                <a:solidFill>
+                  <a:srgbClr val="1E1B4B"/>
+                </a:solidFill>
+                <a:latin typeface="Montserrat"/>
+              </a:defRPr>
+            </a:pPr>
+            <a:r>
+              <a:t>Webcam Feed Access</a:t>
+            </a:r>
+          </a:p>
+          <a:p>
+            <a:pPr algn="l">
+              <a:defRPr sz="1200">
+                <a:solidFill>
+                  <a:srgbClr val="475569"/>
+                </a:solidFill>
+                <a:latin typeface="Montserrat"/>
               </a:defRPr>
             </a:pPr>
             <a:r>
               <a:t>The browser requests secure camera permissions from the mobile device using the 'getUserMedia' API to render a live camera stream on the page.</a:t>
             </a:r>
           </a:p>
-          <a:p>
-            <a:pPr>
-              <a:spcBef>
-                <a:spcPts val="1500"/>
-              </a:spcBef>
-              <a:defRPr sz="1800" b="1">
-                <a:solidFill>
-                  <a:srgbClr val="6366F1"/>
-                </a:solidFill>
-                <a:latin typeface="Plus Jakarta Sans"/>
-              </a:defRPr>
-            </a:pPr>
-            <a:r>
-              <a:t>2. Computer Vision (MindAR Engine)</a:t>
-            </a:r>
-          </a:p>
-          <a:p>
-            <a:pPr>
-              <a:spcBef>
+        </p:txBody>
+      </p:sp>
+      <p:sp>
+        <p:nvSpPr>
+          <p:cNvPr id="6" name="Rounded Rectangle 5"/>
+          <p:cNvSpPr/>
+          <p:nvPr/>
+        </p:nvSpPr>
+        <p:spPr>
+          <a:xfrm>
+            <a:off x="4443984" y="1828800"/>
+            <a:ext cx="3291840" cy="4114800"/>
+          </a:xfrm>
+          <a:prstGeom prst="roundRect">
+            <a:avLst/>
+          </a:prstGeom>
+          <a:solidFill>
+            <a:srgbClr val="F1F5F9"/>
+          </a:solidFill>
+          <a:ln w="19050">
+            <a:solidFill>
+              <a:srgbClr val="E2E8F0"/>
+            </a:solidFill>
+          </a:ln>
+        </p:spPr>
+        <p:style>
+          <a:lnRef idx="1">
+            <a:schemeClr val="accent1"/>
+          </a:lnRef>
+          <a:fillRef idx="3">
+            <a:schemeClr val="accent1"/>
+          </a:fillRef>
+          <a:effectRef idx="2">
+            <a:schemeClr val="accent1"/>
+          </a:effectRef>
+          <a:fontRef idx="minor">
+            <a:schemeClr val="lt1"/>
+          </a:fontRef>
+        </p:style>
+        <p:txBody>
+          <a:bodyPr rtlCol="0" anchor="ctr" wrap="square" lIns="228600" rIns="228600" tIns="274320" bIns="274320"/>
+          <a:lstStyle/>
+          <a:p>
+            <a:pPr algn="ctr">
+              <a:spcAft>
                 <a:spcPts val="400"/>
-              </a:spcBef>
-              <a:defRPr sz="1400">
-                <a:solidFill>
-                  <a:srgbClr val="94A3B8"/>
-                </a:solidFill>
-                <a:latin typeface="Plus Jakarta Sans"/>
-              </a:defRPr>
-            </a:pPr>
-            <a:r>
-              <a:t>The tracking engine scans each frames of the webcam feed. It searches for high-contrast feature anchors (corners, edges) matching the pre-compiled target signature (.mind file).</a:t>
-            </a:r>
-          </a:p>
-          <a:p>
-            <a:pPr>
-              <a:spcBef>
-                <a:spcPts val="1500"/>
-              </a:spcBef>
-              <a:defRPr sz="1800" b="1">
-                <a:solidFill>
-                  <a:srgbClr val="6366F1"/>
-                </a:solidFill>
-                <a:latin typeface="Plus Jakarta Sans"/>
-              </a:defRPr>
-            </a:pPr>
-            <a:r>
-              <a:t>3. WebGL / 3D Rendering (A-Frame)</a:t>
-            </a:r>
-          </a:p>
-          <a:p>
-            <a:pPr>
-              <a:spcBef>
+              </a:spcAft>
+              <a:defRPr sz="1100" b="1">
+                <a:solidFill>
+                  <a:srgbClr val="EC4899"/>
+                </a:solidFill>
+                <a:latin typeface="Montserrat"/>
+              </a:defRPr>
+            </a:pPr>
+            <a:r>
+              <a:t>2. COMPUTER VISION</a:t>
+            </a:r>
+          </a:p>
+          <a:p>
+            <a:pPr algn="ctr">
+              <a:spcAft>
+                <a:spcPts val="1400"/>
+              </a:spcAft>
+              <a:defRPr sz="1600" b="1">
+                <a:solidFill>
+                  <a:srgbClr val="1E1B4B"/>
+                </a:solidFill>
+                <a:latin typeface="Montserrat"/>
+              </a:defRPr>
+            </a:pPr>
+            <a:r>
+              <a:t>MindAR Engine</a:t>
+            </a:r>
+          </a:p>
+          <a:p>
+            <a:pPr algn="l">
+              <a:defRPr sz="1200">
+                <a:solidFill>
+                  <a:srgbClr val="475569"/>
+                </a:solidFill>
+                <a:latin typeface="Montserrat"/>
+              </a:defRPr>
+            </a:pPr>
+            <a:r>
+              <a:t>The tracking engine scans each frame of the webcam feed. It searches for high-contrast feature anchors matching the pre-compiled target signature (.mind file).</a:t>
+            </a:r>
+          </a:p>
+        </p:txBody>
+      </p:sp>
+      <p:sp>
+        <p:nvSpPr>
+          <p:cNvPr id="7" name="Rounded Rectangle 6"/>
+          <p:cNvSpPr/>
+          <p:nvPr/>
+        </p:nvSpPr>
+        <p:spPr>
+          <a:xfrm>
+            <a:off x="8156448" y="1828800"/>
+            <a:ext cx="3291840" cy="4114800"/>
+          </a:xfrm>
+          <a:prstGeom prst="roundRect">
+            <a:avLst/>
+          </a:prstGeom>
+          <a:solidFill>
+            <a:srgbClr val="F1F5F9"/>
+          </a:solidFill>
+          <a:ln w="19050">
+            <a:solidFill>
+              <a:srgbClr val="E2E8F0"/>
+            </a:solidFill>
+          </a:ln>
+        </p:spPr>
+        <p:style>
+          <a:lnRef idx="1">
+            <a:schemeClr val="accent1"/>
+          </a:lnRef>
+          <a:fillRef idx="3">
+            <a:schemeClr val="accent1"/>
+          </a:fillRef>
+          <a:effectRef idx="2">
+            <a:schemeClr val="accent1"/>
+          </a:effectRef>
+          <a:fontRef idx="minor">
+            <a:schemeClr val="lt1"/>
+          </a:fontRef>
+        </p:style>
+        <p:txBody>
+          <a:bodyPr rtlCol="0" anchor="ctr" wrap="square" lIns="228600" rIns="228600" tIns="274320" bIns="274320"/>
+          <a:lstStyle/>
+          <a:p>
+            <a:pPr algn="ctr">
+              <a:spcAft>
                 <a:spcPts val="400"/>
-              </a:spcBef>
-              <a:defRPr sz="1400">
-                <a:solidFill>
-                  <a:srgbClr val="94A3B8"/>
-                </a:solidFill>
-                <a:latin typeface="Plus Jakarta Sans"/>
-              </a:defRPr>
-            </a:pPr>
-            <a:r>
-              <a:t>Once the target card is found, A-Frame (built on Three.js) projects virtual 3D elements (like an overlay video plane) onto the tracked 3D space coordinates, matching its position and rotation in real time.</a:t>
+              </a:spcAft>
+              <a:defRPr sz="1100" b="1">
+                <a:solidFill>
+                  <a:srgbClr val="EC4899"/>
+                </a:solidFill>
+                <a:latin typeface="Montserrat"/>
+              </a:defRPr>
+            </a:pPr>
+            <a:r>
+              <a:t>3. WEBGL / 3D RENDERING</a:t>
+            </a:r>
+          </a:p>
+          <a:p>
+            <a:pPr algn="ctr">
+              <a:spcAft>
+                <a:spcPts val="1400"/>
+              </a:spcAft>
+              <a:defRPr sz="1600" b="1">
+                <a:solidFill>
+                  <a:srgbClr val="1E1B4B"/>
+                </a:solidFill>
+                <a:latin typeface="Montserrat"/>
+              </a:defRPr>
+            </a:pPr>
+            <a:r>
+              <a:t>A-Frame Graphics</a:t>
+            </a:r>
+          </a:p>
+          <a:p>
+            <a:pPr algn="l">
+              <a:defRPr sz="1200">
+                <a:solidFill>
+                  <a:srgbClr val="475569"/>
+                </a:solidFill>
+                <a:latin typeface="Montserrat"/>
+              </a:defRPr>
+            </a:pPr>
+            <a:r>
+              <a:t>A-Frame projects virtual 3D elements (like an overlay video plane) onto the tracked 3D space coordinates, matching its position and rotation in real time.</a:t>
             </a:r>
           </a:p>
         </p:txBody>
@@ -4283,7 +4683,7 @@
     <p:bg>
       <p:bgPr>
         <a:solidFill>
-          <a:srgbClr val="0F172A"/>
+          <a:srgbClr val="FAF9FE"/>
         </a:solidFill>
         <a:effectLst/>
       </p:bgPr>
@@ -4320,9 +4720,9 @@
             <a:pPr>
               <a:defRPr sz="1000" b="1">
                 <a:solidFill>
-                  <a:srgbClr val="6366F1"/>
-                </a:solidFill>
-                <a:latin typeface="Plus Jakarta Sans"/>
+                  <a:srgbClr val="EC4899"/>
+                </a:solidFill>
+                <a:latin typeface="Montserrat"/>
               </a:defRPr>
             </a:pPr>
             <a:r>
@@ -4356,9 +4756,9 @@
             <a:pPr>
               <a:defRPr sz="2600" b="1">
                 <a:solidFill>
-                  <a:srgbClr val="F8FAFC"/>
-                </a:solidFill>
-                <a:latin typeface="Plus Jakarta Sans"/>
+                  <a:srgbClr val="1E1B4B"/>
+                </a:solidFill>
+                <a:latin typeface="Montserrat"/>
               </a:defRPr>
             </a:pPr>
             <a:r>
@@ -4369,188 +4769,23 @@
       </p:sp>
       <p:sp>
         <p:nvSpPr>
-          <p:cNvPr id="4" name="TextBox 3"/>
-          <p:cNvSpPr txBox="1"/>
-          <p:nvPr/>
-        </p:nvSpPr>
-        <p:spPr>
-          <a:xfrm>
-            <a:off x="731520" y="1645920"/>
-            <a:ext cx="5303520" cy="4572000"/>
-          </a:xfrm>
-          <a:prstGeom prst="rect">
-            <a:avLst/>
-          </a:prstGeom>
-          <a:noFill/>
-        </p:spPr>
-        <p:txBody>
-          <a:bodyPr wrap="square">
-            <a:spAutoFit/>
-          </a:bodyPr>
-          <a:lstStyle/>
-          <a:p>
-            <a:pPr>
-              <a:spcBef>
-                <a:spcPts val="1200"/>
-              </a:spcBef>
-              <a:defRPr sz="1600" b="1">
-                <a:solidFill>
-                  <a:srgbClr val="6366F1"/>
-                </a:solidFill>
-                <a:latin typeface="Plus Jakarta Sans"/>
-              </a:defRPr>
-            </a:pPr>
-            <a:r>
-              <a:t>📁 assets/</a:t>
-            </a:r>
-          </a:p>
-          <a:p>
-            <a:pPr>
-              <a:spcBef>
-                <a:spcPts val="200"/>
-              </a:spcBef>
-              <a:defRPr sz="1300">
-                <a:solidFill>
-                  <a:srgbClr val="94A3B8"/>
-                </a:solidFill>
-                <a:latin typeface="Plus Jakarta Sans"/>
-              </a:defRPr>
-            </a:pPr>
-            <a:r>
-              <a:t>Contains static tracking targets and video assets:</a:t>
-            </a:r>
-            <a:br/>
-            <a:r>
-              <a:t>• card.png: Printable physical target image.</a:t>
-            </a:r>
-            <a:br/>
-            <a:r>
-              <a:t>• card.mind: Compiled feature anchor signature.</a:t>
-            </a:r>
-            <a:br/>
-            <a:r>
-              <a:t>• video.mp4: Video plane overlay media file.</a:t>
-            </a:r>
-          </a:p>
-          <a:p>
-            <a:pPr>
-              <a:spcBef>
-                <a:spcPts val="1200"/>
-              </a:spcBef>
-              <a:defRPr sz="1600" b="1">
-                <a:solidFill>
-                  <a:srgbClr val="6366F1"/>
-                </a:solidFill>
-                <a:latin typeface="Plus Jakarta Sans"/>
-              </a:defRPr>
-            </a:pPr>
-            <a:r>
-              <a:t>📄 index.html</a:t>
-            </a:r>
-          </a:p>
-          <a:p>
-            <a:pPr>
-              <a:spcBef>
-                <a:spcPts val="200"/>
-              </a:spcBef>
-              <a:defRPr sz="1300">
-                <a:solidFill>
-                  <a:srgbClr val="94A3B8"/>
-                </a:solidFill>
-                <a:latin typeface="Plus Jakarta Sans"/>
-              </a:defRPr>
-            </a:pPr>
-            <a:r>
-              <a:t>The main WebAR application scanner file. Consolidates A-Frame configuration, HTML overlays, CSS styles, and tracking logic in a single readable document.</a:t>
-            </a:r>
-          </a:p>
-          <a:p>
-            <a:pPr>
-              <a:spcBef>
-                <a:spcPts val="1200"/>
-              </a:spcBef>
-              <a:defRPr sz="1600" b="1">
-                <a:solidFill>
-                  <a:srgbClr val="6366F1"/>
-                </a:solidFill>
-                <a:latin typeface="Plus Jakarta Sans"/>
-              </a:defRPr>
-            </a:pPr>
-            <a:r>
-              <a:t>📄 preview.html</a:t>
-            </a:r>
-          </a:p>
-          <a:p>
-            <a:pPr>
-              <a:spcBef>
-                <a:spcPts val="200"/>
-              </a:spcBef>
-              <a:defRPr sz="1300">
-                <a:solidFill>
-                  <a:srgbClr val="94A3B8"/>
-                </a:solidFill>
-                <a:latin typeface="Plus Jakarta Sans"/>
-              </a:defRPr>
-            </a:pPr>
-            <a:r>
-              <a:t>Utility target page display that lets students view and print the reference card for target tracking.</a:t>
-            </a:r>
-          </a:p>
-          <a:p>
-            <a:pPr>
-              <a:spcBef>
-                <a:spcPts val="1200"/>
-              </a:spcBef>
-              <a:defRPr sz="1600" b="1">
-                <a:solidFill>
-                  <a:srgbClr val="6366F1"/>
-                </a:solidFill>
-                <a:latin typeface="Plus Jakarta Sans"/>
-              </a:defRPr>
-            </a:pPr>
-            <a:r>
-              <a:t>📄 server.js</a:t>
-            </a:r>
-          </a:p>
-          <a:p>
-            <a:pPr>
-              <a:spcBef>
-                <a:spcPts val="200"/>
-              </a:spcBef>
-              <a:defRPr sz="1300">
-                <a:solidFill>
-                  <a:srgbClr val="94A3B8"/>
-                </a:solidFill>
-                <a:latin typeface="Plus Jakarta Sans"/>
-              </a:defRPr>
-            </a:pPr>
-            <a:r>
-              <a:t>Minimal local Node.js server. Configured to run secure local HTTPS (port 3030) allowing mobile camera access.</a:t>
-            </a:r>
-          </a:p>
-        </p:txBody>
-      </p:sp>
-      <p:sp>
-        <p:nvSpPr>
-          <p:cNvPr id="5" name="Rectangle 4"/>
+          <p:cNvPr id="4" name="Rectangle 3"/>
           <p:cNvSpPr/>
           <p:nvPr/>
         </p:nvSpPr>
         <p:spPr>
           <a:xfrm>
-            <a:off x="6583680" y="1645920"/>
-            <a:ext cx="4754880" cy="4114800"/>
+            <a:off x="731520" y="1325880"/>
+            <a:ext cx="10728655" cy="18288"/>
           </a:xfrm>
           <a:prstGeom prst="rect">
             <a:avLst/>
           </a:prstGeom>
           <a:solidFill>
-            <a:srgbClr val="1E293B"/>
+            <a:srgbClr val="7C3AED"/>
           </a:solidFill>
-          <a:ln w="12700">
-            <a:solidFill>
-              <a:srgbClr val="475569"/>
-            </a:solidFill>
+          <a:ln>
+            <a:noFill/>
           </a:ln>
         </p:spPr>
         <p:style>
@@ -4568,13 +4803,221 @@
           </a:fontRef>
         </p:style>
         <p:txBody>
+          <a:bodyPr rtlCol="0" anchor="ctr"/>
+          <a:lstStyle/>
+          <a:p>
+            <a:pPr algn="ctr"/>
+          </a:p>
+        </p:txBody>
+      </p:sp>
+      <p:sp>
+        <p:nvSpPr>
+          <p:cNvPr id="5" name="TextBox 4"/>
+          <p:cNvSpPr txBox="1"/>
+          <p:nvPr/>
+        </p:nvSpPr>
+        <p:spPr>
+          <a:xfrm>
+            <a:off x="731520" y="1645920"/>
+            <a:ext cx="5303520" cy="4572000"/>
+          </a:xfrm>
+          <a:prstGeom prst="rect">
+            <a:avLst/>
+          </a:prstGeom>
+          <a:noFill/>
+        </p:spPr>
+        <p:txBody>
+          <a:bodyPr wrap="square">
+            <a:spAutoFit/>
+          </a:bodyPr>
+          <a:lstStyle/>
+          <a:p>
+            <a:pPr>
+              <a:spcBef>
+                <a:spcPts val="1200"/>
+              </a:spcBef>
+              <a:defRPr sz="1600" b="1">
+                <a:solidFill>
+                  <a:srgbClr val="7C3AED"/>
+                </a:solidFill>
+                <a:latin typeface="Montserrat"/>
+              </a:defRPr>
+            </a:pPr>
+            <a:r>
+              <a:t>📁 assets/</a:t>
+            </a:r>
+          </a:p>
+          <a:p>
+            <a:pPr>
+              <a:spcBef>
+                <a:spcPts val="200"/>
+              </a:spcBef>
+              <a:defRPr sz="1300">
+                <a:solidFill>
+                  <a:srgbClr val="475569"/>
+                </a:solidFill>
+                <a:latin typeface="Montserrat"/>
+              </a:defRPr>
+            </a:pPr>
+            <a:r>
+              <a:t>Contains static tracking targets and video assets:</a:t>
+            </a:r>
+            <a:br/>
+            <a:r>
+              <a:t>• card.png: Printable physical target image.</a:t>
+            </a:r>
+            <a:br/>
+            <a:r>
+              <a:t>• card.mind: Compiled feature anchor signature.</a:t>
+            </a:r>
+            <a:br/>
+            <a:r>
+              <a:t>• video.mp4: Video plane overlay media file.</a:t>
+            </a:r>
+          </a:p>
+          <a:p>
+            <a:pPr>
+              <a:spcBef>
+                <a:spcPts val="1200"/>
+              </a:spcBef>
+              <a:defRPr sz="1600" b="1">
+                <a:solidFill>
+                  <a:srgbClr val="7C3AED"/>
+                </a:solidFill>
+                <a:latin typeface="Montserrat"/>
+              </a:defRPr>
+            </a:pPr>
+            <a:r>
+              <a:t>📄 index.html</a:t>
+            </a:r>
+          </a:p>
+          <a:p>
+            <a:pPr>
+              <a:spcBef>
+                <a:spcPts val="200"/>
+              </a:spcBef>
+              <a:defRPr sz="1300">
+                <a:solidFill>
+                  <a:srgbClr val="475569"/>
+                </a:solidFill>
+                <a:latin typeface="Montserrat"/>
+              </a:defRPr>
+            </a:pPr>
+            <a:r>
+              <a:t>The main WebAR application scanner file. Consolidates A-Frame configuration, HTML overlays, CSS styles, and tracking logic in a single readable document.</a:t>
+            </a:r>
+          </a:p>
+          <a:p>
+            <a:pPr>
+              <a:spcBef>
+                <a:spcPts val="1200"/>
+              </a:spcBef>
+              <a:defRPr sz="1600" b="1">
+                <a:solidFill>
+                  <a:srgbClr val="7C3AED"/>
+                </a:solidFill>
+                <a:latin typeface="Montserrat"/>
+              </a:defRPr>
+            </a:pPr>
+            <a:r>
+              <a:t>📄 preview.html</a:t>
+            </a:r>
+          </a:p>
+          <a:p>
+            <a:pPr>
+              <a:spcBef>
+                <a:spcPts val="200"/>
+              </a:spcBef>
+              <a:defRPr sz="1300">
+                <a:solidFill>
+                  <a:srgbClr val="475569"/>
+                </a:solidFill>
+                <a:latin typeface="Montserrat"/>
+              </a:defRPr>
+            </a:pPr>
+            <a:r>
+              <a:t>Utility target page display that lets students view and print the reference card for target tracking.</a:t>
+            </a:r>
+          </a:p>
+          <a:p>
+            <a:pPr>
+              <a:spcBef>
+                <a:spcPts val="1200"/>
+              </a:spcBef>
+              <a:defRPr sz="1600" b="1">
+                <a:solidFill>
+                  <a:srgbClr val="7C3AED"/>
+                </a:solidFill>
+                <a:latin typeface="Montserrat"/>
+              </a:defRPr>
+            </a:pPr>
+            <a:r>
+              <a:t>📄 server.js</a:t>
+            </a:r>
+          </a:p>
+          <a:p>
+            <a:pPr>
+              <a:spcBef>
+                <a:spcPts val="200"/>
+              </a:spcBef>
+              <a:defRPr sz="1300">
+                <a:solidFill>
+                  <a:srgbClr val="475569"/>
+                </a:solidFill>
+                <a:latin typeface="Montserrat"/>
+              </a:defRPr>
+            </a:pPr>
+            <a:r>
+              <a:t>Minimal local Node.js server. Configured to run secure local HTTPS (port 3030) allowing mobile camera access.</a:t>
+            </a:r>
+          </a:p>
+        </p:txBody>
+      </p:sp>
+      <p:sp>
+        <p:nvSpPr>
+          <p:cNvPr id="6" name="Rounded Rectangle 5"/>
+          <p:cNvSpPr/>
+          <p:nvPr/>
+        </p:nvSpPr>
+        <p:spPr>
+          <a:xfrm>
+            <a:off x="6583680" y="1645920"/>
+            <a:ext cx="4754880" cy="4114800"/>
+          </a:xfrm>
+          <a:prstGeom prst="roundRect">
+            <a:avLst/>
+          </a:prstGeom>
+          <a:solidFill>
+            <a:srgbClr val="F1F5F9"/>
+          </a:solidFill>
+          <a:ln w="12700">
+            <a:solidFill>
+              <a:srgbClr val="E2E8F0"/>
+            </a:solidFill>
+          </a:ln>
+        </p:spPr>
+        <p:style>
+          <a:lnRef idx="1">
+            <a:schemeClr val="accent1"/>
+          </a:lnRef>
+          <a:fillRef idx="3">
+            <a:schemeClr val="accent1"/>
+          </a:fillRef>
+          <a:effectRef idx="2">
+            <a:schemeClr val="accent1"/>
+          </a:effectRef>
+          <a:fontRef idx="minor">
+            <a:schemeClr val="lt1"/>
+          </a:fontRef>
+        </p:style>
+        <p:txBody>
           <a:bodyPr rtlCol="0" anchor="ctr" wrap="square" lIns="182880" rIns="182880" tIns="182880" bIns="182880"/>
           <a:lstStyle/>
           <a:p>
             <a:pPr algn="ctr">
               <a:defRPr sz="1100">
                 <a:solidFill>
-                  <a:srgbClr val="38BDF8"/>
+                  <a:srgbClr val="0F766E"/>
                 </a:solidFill>
                 <a:latin typeface="Courier New"/>
               </a:defRPr>
@@ -4587,7 +5030,7 @@
             <a:pPr>
               <a:defRPr sz="1100">
                 <a:solidFill>
-                  <a:srgbClr val="38BDF8"/>
+                  <a:srgbClr val="0F766E"/>
                 </a:solidFill>
                 <a:latin typeface="Courier New"/>
               </a:defRPr>
@@ -4600,7 +5043,7 @@
             <a:pPr>
               <a:defRPr sz="1100">
                 <a:solidFill>
-                  <a:srgbClr val="38BDF8"/>
+                  <a:srgbClr val="0F766E"/>
                 </a:solidFill>
                 <a:latin typeface="Courier New"/>
               </a:defRPr>
@@ -4613,7 +5056,7 @@
             <a:pPr>
               <a:defRPr sz="1100">
                 <a:solidFill>
-                  <a:srgbClr val="38BDF8"/>
+                  <a:srgbClr val="0F766E"/>
                 </a:solidFill>
                 <a:latin typeface="Courier New"/>
               </a:defRPr>
@@ -4626,7 +5069,7 @@
             <a:pPr>
               <a:defRPr sz="1100">
                 <a:solidFill>
-                  <a:srgbClr val="38BDF8"/>
+                  <a:srgbClr val="0F766E"/>
                 </a:solidFill>
                 <a:latin typeface="Courier New"/>
               </a:defRPr>
@@ -4639,7 +5082,7 @@
             <a:pPr>
               <a:defRPr sz="1100">
                 <a:solidFill>
-                  <a:srgbClr val="38BDF8"/>
+                  <a:srgbClr val="0F766E"/>
                 </a:solidFill>
                 <a:latin typeface="Courier New"/>
               </a:defRPr>
@@ -4652,7 +5095,7 @@
             <a:pPr>
               <a:defRPr sz="1100">
                 <a:solidFill>
-                  <a:srgbClr val="38BDF8"/>
+                  <a:srgbClr val="0F766E"/>
                 </a:solidFill>
                 <a:latin typeface="Courier New"/>
               </a:defRPr>
@@ -4665,7 +5108,7 @@
             <a:pPr>
               <a:defRPr sz="1100">
                 <a:solidFill>
-                  <a:srgbClr val="38BDF8"/>
+                  <a:srgbClr val="0F766E"/>
                 </a:solidFill>
                 <a:latin typeface="Courier New"/>
               </a:defRPr>
@@ -4678,7 +5121,7 @@
             <a:pPr>
               <a:defRPr sz="1100">
                 <a:solidFill>
-                  <a:srgbClr val="38BDF8"/>
+                  <a:srgbClr val="0F766E"/>
                 </a:solidFill>
                 <a:latin typeface="Courier New"/>
               </a:defRPr>
@@ -4691,7 +5134,7 @@
             <a:pPr>
               <a:defRPr sz="1100">
                 <a:solidFill>
-                  <a:srgbClr val="38BDF8"/>
+                  <a:srgbClr val="0F766E"/>
                 </a:solidFill>
                 <a:latin typeface="Courier New"/>
               </a:defRPr>
@@ -4704,7 +5147,7 @@
             <a:pPr>
               <a:defRPr sz="1100">
                 <a:solidFill>
-                  <a:srgbClr val="38BDF8"/>
+                  <a:srgbClr val="0F766E"/>
                 </a:solidFill>
                 <a:latin typeface="Courier New"/>
               </a:defRPr>
@@ -4729,7 +5172,7 @@
     <p:bg>
       <p:bgPr>
         <a:solidFill>
-          <a:srgbClr val="0F172A"/>
+          <a:srgbClr val="FAF9FE"/>
         </a:solidFill>
         <a:effectLst/>
       </p:bgPr>
@@ -4766,9 +5209,9 @@
             <a:pPr>
               <a:defRPr sz="1000" b="1">
                 <a:solidFill>
-                  <a:srgbClr val="6366F1"/>
-                </a:solidFill>
-                <a:latin typeface="Plus Jakarta Sans"/>
+                  <a:srgbClr val="EC4899"/>
+                </a:solidFill>
+                <a:latin typeface="Montserrat"/>
               </a:defRPr>
             </a:pPr>
             <a:r>
@@ -4802,9 +5245,9 @@
             <a:pPr>
               <a:defRPr sz="2600" b="1">
                 <a:solidFill>
-                  <a:srgbClr val="F8FAFC"/>
-                </a:solidFill>
-                <a:latin typeface="Plus Jakarta Sans"/>
+                  <a:srgbClr val="1E1B4B"/>
+                </a:solidFill>
+                <a:latin typeface="Montserrat"/>
               </a:defRPr>
             </a:pPr>
             <a:r>
@@ -4815,7 +5258,50 @@
       </p:sp>
       <p:sp>
         <p:nvSpPr>
-          <p:cNvPr id="4" name="TextBox 3"/>
+          <p:cNvPr id="4" name="Rectangle 3"/>
+          <p:cNvSpPr/>
+          <p:nvPr/>
+        </p:nvSpPr>
+        <p:spPr>
+          <a:xfrm>
+            <a:off x="731520" y="1325880"/>
+            <a:ext cx="10728655" cy="18288"/>
+          </a:xfrm>
+          <a:prstGeom prst="rect">
+            <a:avLst/>
+          </a:prstGeom>
+          <a:solidFill>
+            <a:srgbClr val="7C3AED"/>
+          </a:solidFill>
+          <a:ln>
+            <a:noFill/>
+          </a:ln>
+        </p:spPr>
+        <p:style>
+          <a:lnRef idx="1">
+            <a:schemeClr val="accent1"/>
+          </a:lnRef>
+          <a:fillRef idx="3">
+            <a:schemeClr val="accent1"/>
+          </a:fillRef>
+          <a:effectRef idx="2">
+            <a:schemeClr val="accent1"/>
+          </a:effectRef>
+          <a:fontRef idx="minor">
+            <a:schemeClr val="lt1"/>
+          </a:fontRef>
+        </p:style>
+        <p:txBody>
+          <a:bodyPr rtlCol="0" anchor="ctr"/>
+          <a:lstStyle/>
+          <a:p>
+            <a:pPr algn="ctr"/>
+          </a:p>
+        </p:txBody>
+      </p:sp>
+      <p:sp>
+        <p:nvSpPr>
+          <p:cNvPr id="5" name="TextBox 4"/>
           <p:cNvSpPr txBox="1"/>
           <p:nvPr/>
         </p:nvSpPr>
@@ -4841,9 +5327,9 @@
               </a:spcBef>
               <a:defRPr sz="1600" b="1">
                 <a:solidFill>
-                  <a:srgbClr val="6366F1"/>
-                </a:solidFill>
-                <a:latin typeface="Plus Jakarta Sans"/>
+                  <a:srgbClr val="7C3AED"/>
+                </a:solidFill>
+                <a:latin typeface="Montserrat"/>
               </a:defRPr>
             </a:pPr>
             <a:r>
@@ -4857,9 +5343,9 @@
               </a:spcBef>
               <a:defRPr sz="1300">
                 <a:solidFill>
-                  <a:srgbClr val="94A3B8"/>
-                </a:solidFill>
-                <a:latin typeface="Plus Jakarta Sans"/>
+                  <a:srgbClr val="475569"/>
+                </a:solidFill>
+                <a:latin typeface="Montserrat"/>
               </a:defRPr>
             </a:pPr>
             <a:r>
@@ -4873,9 +5359,9 @@
               </a:spcBef>
               <a:defRPr sz="1600" b="1">
                 <a:solidFill>
-                  <a:srgbClr val="6366F1"/>
-                </a:solidFill>
-                <a:latin typeface="Plus Jakarta Sans"/>
+                  <a:srgbClr val="7C3AED"/>
+                </a:solidFill>
+                <a:latin typeface="Montserrat"/>
               </a:defRPr>
             </a:pPr>
             <a:r>
@@ -4889,9 +5375,9 @@
               </a:spcBef>
               <a:defRPr sz="1300">
                 <a:solidFill>
-                  <a:srgbClr val="94A3B8"/>
-                </a:solidFill>
-                <a:latin typeface="Plus Jakarta Sans"/>
+                  <a:srgbClr val="475569"/>
+                </a:solidFill>
+                <a:latin typeface="Montserrat"/>
               </a:defRPr>
             </a:pPr>
             <a:r>
@@ -4905,9 +5391,9 @@
               </a:spcBef>
               <a:defRPr sz="1600" b="1">
                 <a:solidFill>
-                  <a:srgbClr val="6366F1"/>
-                </a:solidFill>
-                <a:latin typeface="Plus Jakarta Sans"/>
+                  <a:srgbClr val="7C3AED"/>
+                </a:solidFill>
+                <a:latin typeface="Montserrat"/>
               </a:defRPr>
             </a:pPr>
             <a:r>
@@ -4921,9 +5407,9 @@
               </a:spcBef>
               <a:defRPr sz="1300">
                 <a:solidFill>
-                  <a:srgbClr val="94A3B8"/>
-                </a:solidFill>
-                <a:latin typeface="Plus Jakarta Sans"/>
+                  <a:srgbClr val="475569"/>
+                </a:solidFill>
+                <a:latin typeface="Montserrat"/>
               </a:defRPr>
             </a:pPr>
             <a:r>
@@ -4934,7 +5420,7 @@
       </p:sp>
       <p:pic>
         <p:nvPicPr>
-          <p:cNvPr id="5" name="Picture 4" descr="screenshot_start.png"/>
+          <p:cNvPr id="6" name="Picture 5" descr="screenshot_start.png"/>
           <p:cNvPicPr>
             <a:picLocks noChangeAspect="1"/>
           </p:cNvPicPr>
@@ -4958,7 +5444,7 @@
       </p:pic>
       <p:sp>
         <p:nvSpPr>
-          <p:cNvPr id="6" name="TextBox 5"/>
+          <p:cNvPr id="7" name="TextBox 6"/>
           <p:cNvSpPr txBox="1"/>
           <p:nvPr/>
         </p:nvSpPr>
@@ -4981,9 +5467,9 @@
             <a:pPr algn="ctr">
               <a:defRPr sz="1100">
                 <a:solidFill>
-                  <a:srgbClr val="94A3B8"/>
-                </a:solidFill>
-                <a:latin typeface="Plus Jakarta Sans"/>
+                  <a:srgbClr val="475569"/>
+                </a:solidFill>
+                <a:latin typeface="Montserrat"/>
               </a:defRPr>
             </a:pPr>
             <a:r>
@@ -4994,7 +5480,7 @@
       </p:sp>
       <p:pic>
         <p:nvPicPr>
-          <p:cNvPr id="7" name="Picture 6" descr="screenshot_mobile_start.png"/>
+          <p:cNvPr id="8" name="Picture 7" descr="screenshot_mobile_start.png"/>
           <p:cNvPicPr>
             <a:picLocks noChangeAspect="1"/>
           </p:cNvPicPr>
@@ -5018,7 +5504,7 @@
       </p:pic>
       <p:sp>
         <p:nvSpPr>
-          <p:cNvPr id="8" name="TextBox 7"/>
+          <p:cNvPr id="9" name="TextBox 8"/>
           <p:cNvSpPr txBox="1"/>
           <p:nvPr/>
         </p:nvSpPr>
@@ -5041,9 +5527,9 @@
             <a:pPr algn="ctr">
               <a:defRPr sz="1100">
                 <a:solidFill>
-                  <a:srgbClr val="94A3B8"/>
-                </a:solidFill>
-                <a:latin typeface="Plus Jakarta Sans"/>
+                  <a:srgbClr val="475569"/>
+                </a:solidFill>
+                <a:latin typeface="Montserrat"/>
               </a:defRPr>
             </a:pPr>
             <a:r>
@@ -5066,7 +5552,7 @@
     <p:bg>
       <p:bgPr>
         <a:solidFill>
-          <a:srgbClr val="0F172A"/>
+          <a:srgbClr val="FAF9FE"/>
         </a:solidFill>
         <a:effectLst/>
       </p:bgPr>
@@ -5103,9 +5589,9 @@
             <a:pPr>
               <a:defRPr sz="1000" b="1">
                 <a:solidFill>
-                  <a:srgbClr val="6366F1"/>
-                </a:solidFill>
-                <a:latin typeface="Plus Jakarta Sans"/>
+                  <a:srgbClr val="EC4899"/>
+                </a:solidFill>
+                <a:latin typeface="Montserrat"/>
               </a:defRPr>
             </a:pPr>
             <a:r>
@@ -5139,9 +5625,9 @@
             <a:pPr>
               <a:defRPr sz="2600" b="1">
                 <a:solidFill>
-                  <a:srgbClr val="F8FAFC"/>
-                </a:solidFill>
-                <a:latin typeface="Plus Jakarta Sans"/>
+                  <a:srgbClr val="1E1B4B"/>
+                </a:solidFill>
+                <a:latin typeface="Montserrat"/>
               </a:defRPr>
             </a:pPr>
             <a:r>
@@ -5152,7 +5638,50 @@
       </p:sp>
       <p:sp>
         <p:nvSpPr>
-          <p:cNvPr id="4" name="TextBox 3"/>
+          <p:cNvPr id="4" name="Rectangle 3"/>
+          <p:cNvSpPr/>
+          <p:nvPr/>
+        </p:nvSpPr>
+        <p:spPr>
+          <a:xfrm>
+            <a:off x="731520" y="1325880"/>
+            <a:ext cx="10728655" cy="18288"/>
+          </a:xfrm>
+          <a:prstGeom prst="rect">
+            <a:avLst/>
+          </a:prstGeom>
+          <a:solidFill>
+            <a:srgbClr val="7C3AED"/>
+          </a:solidFill>
+          <a:ln>
+            <a:noFill/>
+          </a:ln>
+        </p:spPr>
+        <p:style>
+          <a:lnRef idx="1">
+            <a:schemeClr val="accent1"/>
+          </a:lnRef>
+          <a:fillRef idx="3">
+            <a:schemeClr val="accent1"/>
+          </a:fillRef>
+          <a:effectRef idx="2">
+            <a:schemeClr val="accent1"/>
+          </a:effectRef>
+          <a:fontRef idx="minor">
+            <a:schemeClr val="lt1"/>
+          </a:fontRef>
+        </p:style>
+        <p:txBody>
+          <a:bodyPr rtlCol="0" anchor="ctr"/>
+          <a:lstStyle/>
+          <a:p>
+            <a:pPr algn="ctr"/>
+          </a:p>
+        </p:txBody>
+      </p:sp>
+      <p:sp>
+        <p:nvSpPr>
+          <p:cNvPr id="5" name="TextBox 4"/>
           <p:cNvSpPr txBox="1"/>
           <p:nvPr/>
         </p:nvSpPr>
@@ -5178,9 +5707,9 @@
               </a:spcBef>
               <a:defRPr sz="1600" b="1">
                 <a:solidFill>
-                  <a:srgbClr val="6366F1"/>
-                </a:solidFill>
-                <a:latin typeface="Plus Jakarta Sans"/>
+                  <a:srgbClr val="7C3AED"/>
+                </a:solidFill>
+                <a:latin typeface="Montserrat"/>
               </a:defRPr>
             </a:pPr>
             <a:r>
@@ -5194,9 +5723,9 @@
               </a:spcBef>
               <a:defRPr sz="1300">
                 <a:solidFill>
-                  <a:srgbClr val="94A3B8"/>
-                </a:solidFill>
-                <a:latin typeface="Plus Jakarta Sans"/>
+                  <a:srgbClr val="475569"/>
+                </a:solidFill>
+                <a:latin typeface="Montserrat"/>
               </a:defRPr>
             </a:pPr>
             <a:r>
@@ -5210,9 +5739,9 @@
               </a:spcBef>
               <a:defRPr sz="1600" b="1">
                 <a:solidFill>
-                  <a:srgbClr val="6366F1"/>
-                </a:solidFill>
-                <a:latin typeface="Plus Jakarta Sans"/>
+                  <a:srgbClr val="7C3AED"/>
+                </a:solidFill>
+                <a:latin typeface="Montserrat"/>
               </a:defRPr>
             </a:pPr>
             <a:r>
@@ -5226,9 +5755,9 @@
               </a:spcBef>
               <a:defRPr sz="1300">
                 <a:solidFill>
-                  <a:srgbClr val="94A3B8"/>
-                </a:solidFill>
-                <a:latin typeface="Plus Jakarta Sans"/>
+                  <a:srgbClr val="475569"/>
+                </a:solidFill>
+                <a:latin typeface="Montserrat"/>
               </a:defRPr>
             </a:pPr>
             <a:r>
@@ -5242,9 +5771,9 @@
               </a:spcBef>
               <a:defRPr sz="1600" b="1">
                 <a:solidFill>
-                  <a:srgbClr val="6366F1"/>
-                </a:solidFill>
-                <a:latin typeface="Plus Jakarta Sans"/>
+                  <a:srgbClr val="7C3AED"/>
+                </a:solidFill>
+                <a:latin typeface="Montserrat"/>
               </a:defRPr>
             </a:pPr>
             <a:r>
@@ -5258,9 +5787,9 @@
               </a:spcBef>
               <a:defRPr sz="1300">
                 <a:solidFill>
-                  <a:srgbClr val="94A3B8"/>
-                </a:solidFill>
-                <a:latin typeface="Plus Jakarta Sans"/>
+                  <a:srgbClr val="475569"/>
+                </a:solidFill>
+                <a:latin typeface="Montserrat"/>
               </a:defRPr>
             </a:pPr>
             <a:r>
@@ -5274,9 +5803,9 @@
               </a:spcBef>
               <a:defRPr sz="1600" b="1">
                 <a:solidFill>
-                  <a:srgbClr val="6366F1"/>
-                </a:solidFill>
-                <a:latin typeface="Plus Jakarta Sans"/>
+                  <a:srgbClr val="7C3AED"/>
+                </a:solidFill>
+                <a:latin typeface="Montserrat"/>
               </a:defRPr>
             </a:pPr>
             <a:r>
@@ -5290,9 +5819,9 @@
               </a:spcBef>
               <a:defRPr sz="1300">
                 <a:solidFill>
-                  <a:srgbClr val="94A3B8"/>
-                </a:solidFill>
-                <a:latin typeface="Plus Jakarta Sans"/>
+                  <a:srgbClr val="475569"/>
+                </a:solidFill>
+                <a:latin typeface="Montserrat"/>
               </a:defRPr>
             </a:pPr>
             <a:r>
@@ -5303,7 +5832,7 @@
       </p:sp>
       <p:pic>
         <p:nvPicPr>
-          <p:cNvPr id="5" name="Picture 4" descr="screenshot_mobile_camera.png"/>
+          <p:cNvPr id="6" name="Picture 5" descr="screenshot_mobile_camera.png"/>
           <p:cNvPicPr>
             <a:picLocks noChangeAspect="1"/>
           </p:cNvPicPr>
@@ -5327,7 +5856,7 @@
       </p:pic>
       <p:sp>
         <p:nvSpPr>
-          <p:cNvPr id="6" name="TextBox 5"/>
+          <p:cNvPr id="7" name="TextBox 6"/>
           <p:cNvSpPr txBox="1"/>
           <p:nvPr/>
         </p:nvSpPr>
@@ -5350,9 +5879,9 @@
             <a:pPr algn="ctr">
               <a:defRPr sz="1100">
                 <a:solidFill>
-                  <a:srgbClr val="94A3B8"/>
-                </a:solidFill>
-                <a:latin typeface="Plus Jakarta Sans"/>
+                  <a:srgbClr val="475569"/>
+                </a:solidFill>
+                <a:latin typeface="Montserrat"/>
               </a:defRPr>
             </a:pPr>
             <a:r>
@@ -5375,7 +5904,7 @@
     <p:bg>
       <p:bgPr>
         <a:solidFill>
-          <a:srgbClr val="0F172A"/>
+          <a:srgbClr val="FAF9FE"/>
         </a:solidFill>
         <a:effectLst/>
       </p:bgPr>
@@ -5412,9 +5941,9 @@
             <a:pPr>
               <a:defRPr sz="1000" b="1">
                 <a:solidFill>
-                  <a:srgbClr val="6366F1"/>
-                </a:solidFill>
-                <a:latin typeface="Plus Jakarta Sans"/>
+                  <a:srgbClr val="EC4899"/>
+                </a:solidFill>
+                <a:latin typeface="Montserrat"/>
               </a:defRPr>
             </a:pPr>
             <a:r>
@@ -5448,9 +5977,9 @@
             <a:pPr>
               <a:defRPr sz="2600" b="1">
                 <a:solidFill>
-                  <a:srgbClr val="F8FAFC"/>
-                </a:solidFill>
-                <a:latin typeface="Plus Jakarta Sans"/>
+                  <a:srgbClr val="1E1B4B"/>
+                </a:solidFill>
+                <a:latin typeface="Montserrat"/>
               </a:defRPr>
             </a:pPr>
             <a:r>
@@ -5461,152 +5990,23 @@
       </p:sp>
       <p:sp>
         <p:nvSpPr>
-          <p:cNvPr id="4" name="TextBox 3"/>
-          <p:cNvSpPr txBox="1"/>
-          <p:nvPr/>
-        </p:nvSpPr>
-        <p:spPr>
-          <a:xfrm>
-            <a:off x="731520" y="1645920"/>
-            <a:ext cx="4572000" cy="4572000"/>
-          </a:xfrm>
-          <a:prstGeom prst="rect">
-            <a:avLst/>
-          </a:prstGeom>
-          <a:noFill/>
-        </p:spPr>
-        <p:txBody>
-          <a:bodyPr wrap="square">
-            <a:spAutoFit/>
-          </a:bodyPr>
-          <a:lstStyle/>
-          <a:p>
-            <a:pPr>
-              <a:spcBef>
-                <a:spcPts val="1500"/>
-              </a:spcBef>
-              <a:defRPr sz="1600" b="1">
-                <a:solidFill>
-                  <a:srgbClr val="6366F1"/>
-                </a:solidFill>
-                <a:latin typeface="Plus Jakarta Sans"/>
-              </a:defRPr>
-            </a:pPr>
-            <a:r>
-              <a:t>1. Importing Libraries:</a:t>
-            </a:r>
-          </a:p>
-          <a:p>
-            <a:pPr>
-              <a:spcBef>
-                <a:spcPts val="400"/>
-              </a:spcBef>
-              <a:defRPr sz="1300">
-                <a:solidFill>
-                  <a:srgbClr val="94A3B8"/>
-                </a:solidFill>
-                <a:latin typeface="Plus Jakarta Sans"/>
-              </a:defRPr>
-            </a:pPr>
-            <a:r>
-              <a:t>We load A-Frame (3D positioning wrapper) and the MindAR image-tracking extension to enable browser-based AR processing.</a:t>
-            </a:r>
-          </a:p>
-          <a:p>
-            <a:pPr>
-              <a:spcBef>
-                <a:spcPts val="1500"/>
-              </a:spcBef>
-              <a:defRPr sz="1600" b="1">
-                <a:solidFill>
-                  <a:srgbClr val="6366F1"/>
-                </a:solidFill>
-                <a:latin typeface="Plus Jakarta Sans"/>
-              </a:defRPr>
-            </a:pPr>
-            <a:r>
-              <a:t>2. Setting up the Scene Container:</a:t>
-            </a:r>
-          </a:p>
-          <a:p>
-            <a:pPr>
-              <a:spcBef>
-                <a:spcPts val="400"/>
-              </a:spcBef>
-              <a:defRPr sz="1300">
-                <a:solidFill>
-                  <a:srgbClr val="94A3B8"/>
-                </a:solidFill>
-                <a:latin typeface="Plus Jakarta Sans"/>
-              </a:defRPr>
-            </a:pPr>
-            <a:r>
-              <a:t>The &lt;a-scene&gt; tag acts as the main 3D scene container. MindAR is attached as an attribute parameter.</a:t>
-            </a:r>
-          </a:p>
-          <a:p>
-            <a:pPr>
-              <a:spcBef>
-                <a:spcPts val="1500"/>
-              </a:spcBef>
-              <a:defRPr sz="1600" b="1">
-                <a:solidFill>
-                  <a:srgbClr val="6366F1"/>
-                </a:solidFill>
-                <a:latin typeface="Plus Jakarta Sans"/>
-              </a:defRPr>
-            </a:pPr>
-            <a:r>
-              <a:t>3. Key Properties:</a:t>
-            </a:r>
-          </a:p>
-          <a:p>
-            <a:pPr>
-              <a:spcBef>
-                <a:spcPts val="400"/>
-              </a:spcBef>
-              <a:defRPr sz="1300">
-                <a:solidFill>
-                  <a:srgbClr val="94A3B8"/>
-                </a:solidFill>
-                <a:latin typeface="Plus Jakarta Sans"/>
-              </a:defRPr>
-            </a:pPr>
-            <a:r>
-              <a:t>• imageTargetSrc: points to the compiled card.mind anchors.</a:t>
-            </a:r>
-            <a:br/>
-            <a:r>
-              <a:t>• autoStart: false (prevents camera from starting before click).</a:t>
-            </a:r>
-            <a:br/>
-            <a:r>
-              <a:t>• filterMinCF / filterBeta: configures tracking sensitivity to reduce video overlay jitter.</a:t>
-            </a:r>
-          </a:p>
-        </p:txBody>
-      </p:sp>
-      <p:sp>
-        <p:nvSpPr>
-          <p:cNvPr id="5" name="Rectangle 4"/>
+          <p:cNvPr id="4" name="Rectangle 3"/>
           <p:cNvSpPr/>
           <p:nvPr/>
         </p:nvSpPr>
         <p:spPr>
           <a:xfrm>
-            <a:off x="5669280" y="1645920"/>
-            <a:ext cx="5760720" cy="4114800"/>
+            <a:off x="731520" y="1325880"/>
+            <a:ext cx="10728655" cy="18288"/>
           </a:xfrm>
           <a:prstGeom prst="rect">
             <a:avLst/>
           </a:prstGeom>
           <a:solidFill>
-            <a:srgbClr val="1E293B"/>
+            <a:srgbClr val="7C3AED"/>
           </a:solidFill>
-          <a:ln w="12700">
-            <a:solidFill>
-              <a:srgbClr val="475569"/>
-            </a:solidFill>
+          <a:ln>
+            <a:noFill/>
           </a:ln>
         </p:spPr>
         <p:style>
@@ -5624,13 +6024,185 @@
           </a:fontRef>
         </p:style>
         <p:txBody>
+          <a:bodyPr rtlCol="0" anchor="ctr"/>
+          <a:lstStyle/>
+          <a:p>
+            <a:pPr algn="ctr"/>
+          </a:p>
+        </p:txBody>
+      </p:sp>
+      <p:sp>
+        <p:nvSpPr>
+          <p:cNvPr id="5" name="TextBox 4"/>
+          <p:cNvSpPr txBox="1"/>
+          <p:nvPr/>
+        </p:nvSpPr>
+        <p:spPr>
+          <a:xfrm>
+            <a:off x="731520" y="1645920"/>
+            <a:ext cx="4572000" cy="4572000"/>
+          </a:xfrm>
+          <a:prstGeom prst="rect">
+            <a:avLst/>
+          </a:prstGeom>
+          <a:noFill/>
+        </p:spPr>
+        <p:txBody>
+          <a:bodyPr wrap="square">
+            <a:spAutoFit/>
+          </a:bodyPr>
+          <a:lstStyle/>
+          <a:p>
+            <a:pPr>
+              <a:spcBef>
+                <a:spcPts val="1500"/>
+              </a:spcBef>
+              <a:defRPr sz="1600" b="1">
+                <a:solidFill>
+                  <a:srgbClr val="7C3AED"/>
+                </a:solidFill>
+                <a:latin typeface="Montserrat"/>
+              </a:defRPr>
+            </a:pPr>
+            <a:r>
+              <a:t>1. Importing Libraries:</a:t>
+            </a:r>
+          </a:p>
+          <a:p>
+            <a:pPr>
+              <a:spcBef>
+                <a:spcPts val="400"/>
+              </a:spcBef>
+              <a:defRPr sz="1300">
+                <a:solidFill>
+                  <a:srgbClr val="475569"/>
+                </a:solidFill>
+                <a:latin typeface="Montserrat"/>
+              </a:defRPr>
+            </a:pPr>
+            <a:r>
+              <a:t>We load A-Frame (3D positioning wrapper) and the MindAR image-tracking extension to enable browser-based AR processing.</a:t>
+            </a:r>
+          </a:p>
+          <a:p>
+            <a:pPr>
+              <a:spcBef>
+                <a:spcPts val="1500"/>
+              </a:spcBef>
+              <a:defRPr sz="1600" b="1">
+                <a:solidFill>
+                  <a:srgbClr val="7C3AED"/>
+                </a:solidFill>
+                <a:latin typeface="Montserrat"/>
+              </a:defRPr>
+            </a:pPr>
+            <a:r>
+              <a:t>2. Setting up the Scene Container:</a:t>
+            </a:r>
+          </a:p>
+          <a:p>
+            <a:pPr>
+              <a:spcBef>
+                <a:spcPts val="400"/>
+              </a:spcBef>
+              <a:defRPr sz="1300">
+                <a:solidFill>
+                  <a:srgbClr val="475569"/>
+                </a:solidFill>
+                <a:latin typeface="Montserrat"/>
+              </a:defRPr>
+            </a:pPr>
+            <a:r>
+              <a:t>The &lt;a-scene&gt; tag acts as the main 3D scene container. MindAR is attached as an attribute parameter.</a:t>
+            </a:r>
+          </a:p>
+          <a:p>
+            <a:pPr>
+              <a:spcBef>
+                <a:spcPts val="1500"/>
+              </a:spcBef>
+              <a:defRPr sz="1600" b="1">
+                <a:solidFill>
+                  <a:srgbClr val="7C3AED"/>
+                </a:solidFill>
+                <a:latin typeface="Montserrat"/>
+              </a:defRPr>
+            </a:pPr>
+            <a:r>
+              <a:t>3. Key Properties:</a:t>
+            </a:r>
+          </a:p>
+          <a:p>
+            <a:pPr>
+              <a:spcBef>
+                <a:spcPts val="400"/>
+              </a:spcBef>
+              <a:defRPr sz="1300">
+                <a:solidFill>
+                  <a:srgbClr val="475569"/>
+                </a:solidFill>
+                <a:latin typeface="Montserrat"/>
+              </a:defRPr>
+            </a:pPr>
+            <a:r>
+              <a:t>• imageTargetSrc: points to the compiled card.mind anchors.</a:t>
+            </a:r>
+            <a:br/>
+            <a:r>
+              <a:t>• autoStart: false (prevents camera from starting before click).</a:t>
+            </a:r>
+            <a:br/>
+            <a:r>
+              <a:t>• filterMinCF / filterBeta: configures tracking sensitivity to reduce video overlay jitter.</a:t>
+            </a:r>
+          </a:p>
+        </p:txBody>
+      </p:sp>
+      <p:sp>
+        <p:nvSpPr>
+          <p:cNvPr id="6" name="Rounded Rectangle 5"/>
+          <p:cNvSpPr/>
+          <p:nvPr/>
+        </p:nvSpPr>
+        <p:spPr>
+          <a:xfrm>
+            <a:off x="5669280" y="1645920"/>
+            <a:ext cx="5760720" cy="4114800"/>
+          </a:xfrm>
+          <a:prstGeom prst="roundRect">
+            <a:avLst/>
+          </a:prstGeom>
+          <a:solidFill>
+            <a:srgbClr val="F1F5F9"/>
+          </a:solidFill>
+          <a:ln w="12700">
+            <a:solidFill>
+              <a:srgbClr val="E2E8F0"/>
+            </a:solidFill>
+          </a:ln>
+        </p:spPr>
+        <p:style>
+          <a:lnRef idx="1">
+            <a:schemeClr val="accent1"/>
+          </a:lnRef>
+          <a:fillRef idx="3">
+            <a:schemeClr val="accent1"/>
+          </a:fillRef>
+          <a:effectRef idx="2">
+            <a:schemeClr val="accent1"/>
+          </a:effectRef>
+          <a:fontRef idx="minor">
+            <a:schemeClr val="lt1"/>
+          </a:fontRef>
+        </p:style>
+        <p:txBody>
           <a:bodyPr rtlCol="0" anchor="ctr" wrap="square" lIns="182880" rIns="182880" tIns="182880" bIns="182880"/>
           <a:lstStyle/>
           <a:p>
             <a:pPr algn="ctr">
               <a:defRPr sz="1100">
                 <a:solidFill>
-                  <a:srgbClr val="38BDF8"/>
+                  <a:srgbClr val="0F766E"/>
                 </a:solidFill>
                 <a:latin typeface="Courier New"/>
               </a:defRPr>
@@ -5643,7 +6215,7 @@
             <a:pPr>
               <a:defRPr sz="1100">
                 <a:solidFill>
-                  <a:srgbClr val="38BDF8"/>
+                  <a:srgbClr val="0F766E"/>
                 </a:solidFill>
                 <a:latin typeface="Courier New"/>
               </a:defRPr>
@@ -5656,7 +6228,7 @@
             <a:pPr>
               <a:defRPr sz="1100">
                 <a:solidFill>
-                  <a:srgbClr val="38BDF8"/>
+                  <a:srgbClr val="0F766E"/>
                 </a:solidFill>
                 <a:latin typeface="Courier New"/>
               </a:defRPr>
@@ -5669,7 +6241,7 @@
             <a:pPr>
               <a:defRPr sz="1100">
                 <a:solidFill>
-                  <a:srgbClr val="38BDF8"/>
+                  <a:srgbClr val="0F766E"/>
                 </a:solidFill>
                 <a:latin typeface="Courier New"/>
               </a:defRPr>
@@ -5679,7 +6251,7 @@
             <a:pPr>
               <a:defRPr sz="1100">
                 <a:solidFill>
-                  <a:srgbClr val="38BDF8"/>
+                  <a:srgbClr val="0F766E"/>
                 </a:solidFill>
                 <a:latin typeface="Courier New"/>
               </a:defRPr>
@@ -5692,7 +6264,7 @@
             <a:pPr>
               <a:defRPr sz="1100">
                 <a:solidFill>
-                  <a:srgbClr val="38BDF8"/>
+                  <a:srgbClr val="0F766E"/>
                 </a:solidFill>
                 <a:latin typeface="Courier New"/>
               </a:defRPr>
@@ -5705,7 +6277,7 @@
             <a:pPr>
               <a:defRPr sz="1100">
                 <a:solidFill>
-                  <a:srgbClr val="38BDF8"/>
+                  <a:srgbClr val="0F766E"/>
                 </a:solidFill>
                 <a:latin typeface="Courier New"/>
               </a:defRPr>
@@ -5718,7 +6290,7 @@
             <a:pPr>
               <a:defRPr sz="1100">
                 <a:solidFill>
-                  <a:srgbClr val="38BDF8"/>
+                  <a:srgbClr val="0F766E"/>
                 </a:solidFill>
                 <a:latin typeface="Courier New"/>
               </a:defRPr>
@@ -5731,7 +6303,7 @@
             <a:pPr>
               <a:defRPr sz="1100">
                 <a:solidFill>
-                  <a:srgbClr val="38BDF8"/>
+                  <a:srgbClr val="0F766E"/>
                 </a:solidFill>
                 <a:latin typeface="Courier New"/>
               </a:defRPr>
@@ -5744,7 +6316,7 @@
             <a:pPr>
               <a:defRPr sz="1100">
                 <a:solidFill>
-                  <a:srgbClr val="38BDF8"/>
+                  <a:srgbClr val="0F766E"/>
                 </a:solidFill>
                 <a:latin typeface="Courier New"/>
               </a:defRPr>
@@ -5757,7 +6329,7 @@
             <a:pPr>
               <a:defRPr sz="1100">
                 <a:solidFill>
-                  <a:srgbClr val="38BDF8"/>
+                  <a:srgbClr val="0F766E"/>
                 </a:solidFill>
                 <a:latin typeface="Courier New"/>
               </a:defRPr>
@@ -5770,7 +6342,7 @@
             <a:pPr>
               <a:defRPr sz="1100">
                 <a:solidFill>
-                  <a:srgbClr val="38BDF8"/>
+                  <a:srgbClr val="0F766E"/>
                 </a:solidFill>
                 <a:latin typeface="Courier New"/>
               </a:defRPr>
@@ -5783,7 +6355,7 @@
             <a:pPr>
               <a:defRPr sz="1100">
                 <a:solidFill>
-                  <a:srgbClr val="38BDF8"/>
+                  <a:srgbClr val="0F766E"/>
                 </a:solidFill>
                 <a:latin typeface="Courier New"/>
               </a:defRPr>
@@ -5796,7 +6368,7 @@
             <a:pPr>
               <a:defRPr sz="1100">
                 <a:solidFill>
-                  <a:srgbClr val="38BDF8"/>
+                  <a:srgbClr val="0F766E"/>
                 </a:solidFill>
                 <a:latin typeface="Courier New"/>
               </a:defRPr>
@@ -5809,7 +6381,7 @@
             <a:pPr>
               <a:defRPr sz="1100">
                 <a:solidFill>
-                  <a:srgbClr val="38BDF8"/>
+                  <a:srgbClr val="0F766E"/>
                 </a:solidFill>
                 <a:latin typeface="Courier New"/>
               </a:defRPr>
@@ -5822,7 +6394,7 @@
             <a:pPr>
               <a:defRPr sz="1100">
                 <a:solidFill>
-                  <a:srgbClr val="38BDF8"/>
+                  <a:srgbClr val="0F766E"/>
                 </a:solidFill>
                 <a:latin typeface="Courier New"/>
               </a:defRPr>
@@ -5835,7 +6407,7 @@
             <a:pPr>
               <a:defRPr sz="1100">
                 <a:solidFill>
-                  <a:srgbClr val="38BDF8"/>
+                  <a:srgbClr val="0F766E"/>
                 </a:solidFill>
                 <a:latin typeface="Courier New"/>
               </a:defRPr>
@@ -5860,7 +6432,7 @@
     <p:bg>
       <p:bgPr>
         <a:solidFill>
-          <a:srgbClr val="0F172A"/>
+          <a:srgbClr val="FAF9FE"/>
         </a:solidFill>
         <a:effectLst/>
       </p:bgPr>
@@ -5897,9 +6469,9 @@
             <a:pPr>
               <a:defRPr sz="1000" b="1">
                 <a:solidFill>
-                  <a:srgbClr val="6366F1"/>
-                </a:solidFill>
-                <a:latin typeface="Plus Jakarta Sans"/>
+                  <a:srgbClr val="EC4899"/>
+                </a:solidFill>
+                <a:latin typeface="Montserrat"/>
               </a:defRPr>
             </a:pPr>
             <a:r>
@@ -5933,9 +6505,9 @@
             <a:pPr>
               <a:defRPr sz="2600" b="1">
                 <a:solidFill>
-                  <a:srgbClr val="F8FAFC"/>
-                </a:solidFill>
-                <a:latin typeface="Plus Jakarta Sans"/>
+                  <a:srgbClr val="1E1B4B"/>
+                </a:solidFill>
+                <a:latin typeface="Montserrat"/>
               </a:defRPr>
             </a:pPr>
             <a:r>
@@ -5946,148 +6518,23 @@
       </p:sp>
       <p:sp>
         <p:nvSpPr>
-          <p:cNvPr id="4" name="TextBox 3"/>
-          <p:cNvSpPr txBox="1"/>
-          <p:nvPr/>
-        </p:nvSpPr>
-        <p:spPr>
-          <a:xfrm>
-            <a:off x="731520" y="1645920"/>
-            <a:ext cx="4572000" cy="4572000"/>
-          </a:xfrm>
-          <a:prstGeom prst="rect">
-            <a:avLst/>
-          </a:prstGeom>
-          <a:noFill/>
-        </p:spPr>
-        <p:txBody>
-          <a:bodyPr wrap="square">
-            <a:spAutoFit/>
-          </a:bodyPr>
-          <a:lstStyle/>
-          <a:p>
-            <a:pPr>
-              <a:spcBef>
-                <a:spcPts val="1500"/>
-              </a:spcBef>
-              <a:defRPr sz="1600" b="1">
-                <a:solidFill>
-                  <a:srgbClr val="6366F1"/>
-                </a:solidFill>
-                <a:latin typeface="Plus Jakarta Sans"/>
-              </a:defRPr>
-            </a:pPr>
-            <a:r>
-              <a:t>1. Asset Preloading (&lt;a-assets&gt;):</a:t>
-            </a:r>
-          </a:p>
-          <a:p>
-            <a:pPr>
-              <a:spcBef>
-                <a:spcPts val="400"/>
-              </a:spcBef>
-              <a:defRPr sz="1300">
-                <a:solidFill>
-                  <a:srgbClr val="94A3B8"/>
-                </a:solidFill>
-                <a:latin typeface="Plus Jakarta Sans"/>
-              </a:defRPr>
-            </a:pPr>
-            <a:r>
-              <a:t>Preloads large media assets in system memory before WebGL starts to guarantee lag-free insertion.</a:t>
-            </a:r>
-          </a:p>
-          <a:p>
-            <a:pPr>
-              <a:spcBef>
-                <a:spcPts val="1500"/>
-              </a:spcBef>
-              <a:defRPr sz="1600" b="1">
-                <a:solidFill>
-                  <a:srgbClr val="6366F1"/>
-                </a:solidFill>
-                <a:latin typeface="Plus Jakarta Sans"/>
-              </a:defRPr>
-            </a:pPr>
-            <a:r>
-              <a:t>2. Crucial Autoplay Attributes:</a:t>
-            </a:r>
-          </a:p>
-          <a:p>
-            <a:pPr>
-              <a:spcBef>
-                <a:spcPts val="400"/>
-              </a:spcBef>
-              <a:defRPr sz="1300">
-                <a:solidFill>
-                  <a:srgbClr val="94A3B8"/>
-                </a:solidFill>
-                <a:latin typeface="Plus Jakarta Sans"/>
-              </a:defRPr>
-            </a:pPr>
-            <a:r>
-              <a:t>• playsinline &amp; webkit-playsinline: Force the video to render inside the page flow on iPhones, avoiding full-screen Apple media player takeovers.</a:t>
-            </a:r>
-            <a:br/>
-            <a:r>
-              <a:t>• loop muted: Necessary parameters to bypass browser autoplay blocks.</a:t>
-            </a:r>
-          </a:p>
-          <a:p>
-            <a:pPr>
-              <a:spcBef>
-                <a:spcPts val="1500"/>
-              </a:spcBef>
-              <a:defRPr sz="1600" b="1">
-                <a:solidFill>
-                  <a:srgbClr val="6366F1"/>
-                </a:solidFill>
-                <a:latin typeface="Plus Jakarta Sans"/>
-              </a:defRPr>
-            </a:pPr>
-            <a:r>
-              <a:t>3. The Tracking Entity:</a:t>
-            </a:r>
-          </a:p>
-          <a:p>
-            <a:pPr>
-              <a:spcBef>
-                <a:spcPts val="400"/>
-              </a:spcBef>
-              <a:defRPr sz="1300">
-                <a:solidFill>
-                  <a:srgbClr val="94A3B8"/>
-                </a:solidFill>
-                <a:latin typeface="Plus Jakarta Sans"/>
-              </a:defRPr>
-            </a:pPr>
-            <a:r>
-              <a:t>&lt;a-entity mindar-image-target="targetIndex: 0"&gt; anchors the overlay plane. When MindAR detects the card, this entity mirrors its coordinates dynamically.</a:t>
-            </a:r>
-          </a:p>
-        </p:txBody>
-      </p:sp>
-      <p:sp>
-        <p:nvSpPr>
-          <p:cNvPr id="5" name="Rectangle 4"/>
+          <p:cNvPr id="4" name="Rectangle 3"/>
           <p:cNvSpPr/>
           <p:nvPr/>
         </p:nvSpPr>
         <p:spPr>
           <a:xfrm>
-            <a:off x="5669280" y="1645920"/>
-            <a:ext cx="5760720" cy="4389120"/>
+            <a:off x="731520" y="1325880"/>
+            <a:ext cx="10728655" cy="18288"/>
           </a:xfrm>
           <a:prstGeom prst="rect">
             <a:avLst/>
           </a:prstGeom>
           <a:solidFill>
-            <a:srgbClr val="1E293B"/>
+            <a:srgbClr val="7C3AED"/>
           </a:solidFill>
-          <a:ln w="12700">
-            <a:solidFill>
-              <a:srgbClr val="475569"/>
-            </a:solidFill>
+          <a:ln>
+            <a:noFill/>
           </a:ln>
         </p:spPr>
         <p:style>
@@ -6105,13 +6552,181 @@
           </a:fontRef>
         </p:style>
         <p:txBody>
+          <a:bodyPr rtlCol="0" anchor="ctr"/>
+          <a:lstStyle/>
+          <a:p>
+            <a:pPr algn="ctr"/>
+          </a:p>
+        </p:txBody>
+      </p:sp>
+      <p:sp>
+        <p:nvSpPr>
+          <p:cNvPr id="5" name="TextBox 4"/>
+          <p:cNvSpPr txBox="1"/>
+          <p:nvPr/>
+        </p:nvSpPr>
+        <p:spPr>
+          <a:xfrm>
+            <a:off x="731520" y="1645920"/>
+            <a:ext cx="4572000" cy="4572000"/>
+          </a:xfrm>
+          <a:prstGeom prst="rect">
+            <a:avLst/>
+          </a:prstGeom>
+          <a:noFill/>
+        </p:spPr>
+        <p:txBody>
+          <a:bodyPr wrap="square">
+            <a:spAutoFit/>
+          </a:bodyPr>
+          <a:lstStyle/>
+          <a:p>
+            <a:pPr>
+              <a:spcBef>
+                <a:spcPts val="1500"/>
+              </a:spcBef>
+              <a:defRPr sz="1600" b="1">
+                <a:solidFill>
+                  <a:srgbClr val="7C3AED"/>
+                </a:solidFill>
+                <a:latin typeface="Montserrat"/>
+              </a:defRPr>
+            </a:pPr>
+            <a:r>
+              <a:t>1. Asset Preloading (&lt;a-assets&gt;):</a:t>
+            </a:r>
+          </a:p>
+          <a:p>
+            <a:pPr>
+              <a:spcBef>
+                <a:spcPts val="400"/>
+              </a:spcBef>
+              <a:defRPr sz="1300">
+                <a:solidFill>
+                  <a:srgbClr val="475569"/>
+                </a:solidFill>
+                <a:latin typeface="Montserrat"/>
+              </a:defRPr>
+            </a:pPr>
+            <a:r>
+              <a:t>Preloads large media assets in system memory before WebGL starts to guarantee lag-free insertion.</a:t>
+            </a:r>
+          </a:p>
+          <a:p>
+            <a:pPr>
+              <a:spcBef>
+                <a:spcPts val="1500"/>
+              </a:spcBef>
+              <a:defRPr sz="1600" b="1">
+                <a:solidFill>
+                  <a:srgbClr val="7C3AED"/>
+                </a:solidFill>
+                <a:latin typeface="Montserrat"/>
+              </a:defRPr>
+            </a:pPr>
+            <a:r>
+              <a:t>2. Crucial Autoplay Attributes:</a:t>
+            </a:r>
+          </a:p>
+          <a:p>
+            <a:pPr>
+              <a:spcBef>
+                <a:spcPts val="400"/>
+              </a:spcBef>
+              <a:defRPr sz="1300">
+                <a:solidFill>
+                  <a:srgbClr val="475569"/>
+                </a:solidFill>
+                <a:latin typeface="Montserrat"/>
+              </a:defRPr>
+            </a:pPr>
+            <a:r>
+              <a:t>• playsinline &amp; webkit-playsinline: Force the video to render inside the page flow on iPhones, avoiding full-screen Apple media player takeovers.</a:t>
+            </a:r>
+            <a:br/>
+            <a:r>
+              <a:t>• loop muted: Necessary parameters to bypass browser autoplay blocks.</a:t>
+            </a:r>
+          </a:p>
+          <a:p>
+            <a:pPr>
+              <a:spcBef>
+                <a:spcPts val="1500"/>
+              </a:spcBef>
+              <a:defRPr sz="1600" b="1">
+                <a:solidFill>
+                  <a:srgbClr val="7C3AED"/>
+                </a:solidFill>
+                <a:latin typeface="Montserrat"/>
+              </a:defRPr>
+            </a:pPr>
+            <a:r>
+              <a:t>3. The Tracking Entity:</a:t>
+            </a:r>
+          </a:p>
+          <a:p>
+            <a:pPr>
+              <a:spcBef>
+                <a:spcPts val="400"/>
+              </a:spcBef>
+              <a:defRPr sz="1300">
+                <a:solidFill>
+                  <a:srgbClr val="475569"/>
+                </a:solidFill>
+                <a:latin typeface="Montserrat"/>
+              </a:defRPr>
+            </a:pPr>
+            <a:r>
+              <a:t>&lt;a-entity mindar-image-target="targetIndex: 0"&gt; anchors the overlay plane. When MindAR detects the card, this entity mirrors its coordinates dynamically.</a:t>
+            </a:r>
+          </a:p>
+        </p:txBody>
+      </p:sp>
+      <p:sp>
+        <p:nvSpPr>
+          <p:cNvPr id="6" name="Rounded Rectangle 5"/>
+          <p:cNvSpPr/>
+          <p:nvPr/>
+        </p:nvSpPr>
+        <p:spPr>
+          <a:xfrm>
+            <a:off x="5669280" y="1645920"/>
+            <a:ext cx="5760720" cy="4389120"/>
+          </a:xfrm>
+          <a:prstGeom prst="roundRect">
+            <a:avLst/>
+          </a:prstGeom>
+          <a:solidFill>
+            <a:srgbClr val="F1F5F9"/>
+          </a:solidFill>
+          <a:ln w="12700">
+            <a:solidFill>
+              <a:srgbClr val="E2E8F0"/>
+            </a:solidFill>
+          </a:ln>
+        </p:spPr>
+        <p:style>
+          <a:lnRef idx="1">
+            <a:schemeClr val="accent1"/>
+          </a:lnRef>
+          <a:fillRef idx="3">
+            <a:schemeClr val="accent1"/>
+          </a:fillRef>
+          <a:effectRef idx="2">
+            <a:schemeClr val="accent1"/>
+          </a:effectRef>
+          <a:fontRef idx="minor">
+            <a:schemeClr val="lt1"/>
+          </a:fontRef>
+        </p:style>
+        <p:txBody>
           <a:bodyPr rtlCol="0" anchor="ctr" wrap="square" lIns="182880" rIns="182880" tIns="182880" bIns="182880"/>
           <a:lstStyle/>
           <a:p>
             <a:pPr algn="ctr">
               <a:defRPr sz="1100">
                 <a:solidFill>
-                  <a:srgbClr val="38BDF8"/>
+                  <a:srgbClr val="0F766E"/>
                 </a:solidFill>
                 <a:latin typeface="Courier New"/>
               </a:defRPr>
@@ -6124,7 +6739,7 @@
             <a:pPr>
               <a:defRPr sz="1100">
                 <a:solidFill>
-                  <a:srgbClr val="38BDF8"/>
+                  <a:srgbClr val="0F766E"/>
                 </a:solidFill>
                 <a:latin typeface="Courier New"/>
               </a:defRPr>
@@ -6137,7 +6752,7 @@
             <a:pPr>
               <a:defRPr sz="1100">
                 <a:solidFill>
-                  <a:srgbClr val="38BDF8"/>
+                  <a:srgbClr val="0F766E"/>
                 </a:solidFill>
                 <a:latin typeface="Courier New"/>
               </a:defRPr>
@@ -6150,7 +6765,7 @@
             <a:pPr>
               <a:defRPr sz="1100">
                 <a:solidFill>
-                  <a:srgbClr val="38BDF8"/>
+                  <a:srgbClr val="0F766E"/>
                 </a:solidFill>
                 <a:latin typeface="Courier New"/>
               </a:defRPr>
@@ -6163,7 +6778,7 @@
             <a:pPr>
               <a:defRPr sz="1100">
                 <a:solidFill>
-                  <a:srgbClr val="38BDF8"/>
+                  <a:srgbClr val="0F766E"/>
                 </a:solidFill>
                 <a:latin typeface="Courier New"/>
               </a:defRPr>
@@ -6176,7 +6791,7 @@
             <a:pPr>
               <a:defRPr sz="1100">
                 <a:solidFill>
-                  <a:srgbClr val="38BDF8"/>
+                  <a:srgbClr val="0F766E"/>
                 </a:solidFill>
                 <a:latin typeface="Courier New"/>
               </a:defRPr>
@@ -6189,7 +6804,7 @@
             <a:pPr>
               <a:defRPr sz="1100">
                 <a:solidFill>
-                  <a:srgbClr val="38BDF8"/>
+                  <a:srgbClr val="0F766E"/>
                 </a:solidFill>
                 <a:latin typeface="Courier New"/>
               </a:defRPr>
@@ -6202,7 +6817,7 @@
             <a:pPr>
               <a:defRPr sz="1100">
                 <a:solidFill>
-                  <a:srgbClr val="38BDF8"/>
+                  <a:srgbClr val="0F766E"/>
                 </a:solidFill>
                 <a:latin typeface="Courier New"/>
               </a:defRPr>
@@ -6212,7 +6827,7 @@
             <a:pPr>
               <a:defRPr sz="1100">
                 <a:solidFill>
-                  <a:srgbClr val="38BDF8"/>
+                  <a:srgbClr val="0F766E"/>
                 </a:solidFill>
                 <a:latin typeface="Courier New"/>
               </a:defRPr>
@@ -6225,7 +6840,7 @@
             <a:pPr>
               <a:defRPr sz="1100">
                 <a:solidFill>
-                  <a:srgbClr val="38BDF8"/>
+                  <a:srgbClr val="0F766E"/>
                 </a:solidFill>
                 <a:latin typeface="Courier New"/>
               </a:defRPr>
@@ -6238,7 +6853,7 @@
             <a:pPr>
               <a:defRPr sz="1100">
                 <a:solidFill>
-                  <a:srgbClr val="38BDF8"/>
+                  <a:srgbClr val="0F766E"/>
                 </a:solidFill>
                 <a:latin typeface="Courier New"/>
               </a:defRPr>
@@ -6251,7 +6866,7 @@
             <a:pPr>
               <a:defRPr sz="1100">
                 <a:solidFill>
-                  <a:srgbClr val="38BDF8"/>
+                  <a:srgbClr val="0F766E"/>
                 </a:solidFill>
                 <a:latin typeface="Courier New"/>
               </a:defRPr>
@@ -6264,7 +6879,7 @@
             <a:pPr>
               <a:defRPr sz="1100">
                 <a:solidFill>
-                  <a:srgbClr val="38BDF8"/>
+                  <a:srgbClr val="0F766E"/>
                 </a:solidFill>
                 <a:latin typeface="Courier New"/>
               </a:defRPr>
@@ -6274,7 +6889,7 @@
             <a:pPr>
               <a:defRPr sz="1100">
                 <a:solidFill>
-                  <a:srgbClr val="38BDF8"/>
+                  <a:srgbClr val="0F766E"/>
                 </a:solidFill>
                 <a:latin typeface="Courier New"/>
               </a:defRPr>
@@ -6287,7 +6902,7 @@
             <a:pPr>
               <a:defRPr sz="1100">
                 <a:solidFill>
-                  <a:srgbClr val="38BDF8"/>
+                  <a:srgbClr val="0F766E"/>
                 </a:solidFill>
                 <a:latin typeface="Courier New"/>
               </a:defRPr>
@@ -6300,7 +6915,7 @@
             <a:pPr>
               <a:defRPr sz="1100">
                 <a:solidFill>
-                  <a:srgbClr val="38BDF8"/>
+                  <a:srgbClr val="0F766E"/>
                 </a:solidFill>
                 <a:latin typeface="Courier New"/>
               </a:defRPr>
@@ -6313,7 +6928,7 @@
             <a:pPr>
               <a:defRPr sz="1100">
                 <a:solidFill>
-                  <a:srgbClr val="38BDF8"/>
+                  <a:srgbClr val="0F766E"/>
                 </a:solidFill>
                 <a:latin typeface="Courier New"/>
               </a:defRPr>
@@ -6326,7 +6941,7 @@
             <a:pPr>
               <a:defRPr sz="1100">
                 <a:solidFill>
-                  <a:srgbClr val="38BDF8"/>
+                  <a:srgbClr val="0F766E"/>
                 </a:solidFill>
                 <a:latin typeface="Courier New"/>
               </a:defRPr>
@@ -6351,7 +6966,7 @@
     <p:bg>
       <p:bgPr>
         <a:solidFill>
-          <a:srgbClr val="0F172A"/>
+          <a:srgbClr val="FAF9FE"/>
         </a:solidFill>
         <a:effectLst/>
       </p:bgPr>
@@ -6388,9 +7003,9 @@
             <a:pPr>
               <a:defRPr sz="1000" b="1">
                 <a:solidFill>
-                  <a:srgbClr val="6366F1"/>
-                </a:solidFill>
-                <a:latin typeface="Plus Jakarta Sans"/>
+                  <a:srgbClr val="EC4899"/>
+                </a:solidFill>
+                <a:latin typeface="Montserrat"/>
               </a:defRPr>
             </a:pPr>
             <a:r>
@@ -6424,9 +7039,9 @@
             <a:pPr>
               <a:defRPr sz="2600" b="1">
                 <a:solidFill>
-                  <a:srgbClr val="F8FAFC"/>
-                </a:solidFill>
-                <a:latin typeface="Plus Jakarta Sans"/>
+                  <a:srgbClr val="1E1B4B"/>
+                </a:solidFill>
+                <a:latin typeface="Montserrat"/>
               </a:defRPr>
             </a:pPr>
             <a:r>
@@ -6437,7 +7052,50 @@
       </p:sp>
       <p:sp>
         <p:nvSpPr>
-          <p:cNvPr id="4" name="TextBox 3"/>
+          <p:cNvPr id="4" name="Rectangle 3"/>
+          <p:cNvSpPr/>
+          <p:nvPr/>
+        </p:nvSpPr>
+        <p:spPr>
+          <a:xfrm>
+            <a:off x="731520" y="1325880"/>
+            <a:ext cx="10728655" cy="18288"/>
+          </a:xfrm>
+          <a:prstGeom prst="rect">
+            <a:avLst/>
+          </a:prstGeom>
+          <a:solidFill>
+            <a:srgbClr val="7C3AED"/>
+          </a:solidFill>
+          <a:ln>
+            <a:noFill/>
+          </a:ln>
+        </p:spPr>
+        <p:style>
+          <a:lnRef idx="1">
+            <a:schemeClr val="accent1"/>
+          </a:lnRef>
+          <a:fillRef idx="3">
+            <a:schemeClr val="accent1"/>
+          </a:fillRef>
+          <a:effectRef idx="2">
+            <a:schemeClr val="accent1"/>
+          </a:effectRef>
+          <a:fontRef idx="minor">
+            <a:schemeClr val="lt1"/>
+          </a:fontRef>
+        </p:style>
+        <p:txBody>
+          <a:bodyPr rtlCol="0" anchor="ctr"/>
+          <a:lstStyle/>
+          <a:p>
+            <a:pPr algn="ctr"/>
+          </a:p>
+        </p:txBody>
+      </p:sp>
+      <p:sp>
+        <p:nvSpPr>
+          <p:cNvPr id="5" name="TextBox 4"/>
           <p:cNvSpPr txBox="1"/>
           <p:nvPr/>
         </p:nvSpPr>
@@ -6463,9 +7121,9 @@
               </a:spcBef>
               <a:defRPr sz="1800" b="1">
                 <a:solidFill>
-                  <a:srgbClr val="6366F1"/>
-                </a:solidFill>
-                <a:latin typeface="Plus Jakarta Sans"/>
+                  <a:srgbClr val="7C3AED"/>
+                </a:solidFill>
+                <a:latin typeface="Montserrat"/>
               </a:defRPr>
             </a:pPr>
             <a:r>
@@ -6479,9 +7137,9 @@
               </a:spcBef>
               <a:defRPr sz="1400">
                 <a:solidFill>
-                  <a:srgbClr val="94A3B8"/>
-                </a:solidFill>
-                <a:latin typeface="Plus Jakarta Sans"/>
+                  <a:srgbClr val="475569"/>
+                </a:solidFill>
+                <a:latin typeface="Montserrat"/>
               </a:defRPr>
             </a:pPr>
             <a:r>
@@ -6495,9 +7153,9 @@
               </a:spcBef>
               <a:defRPr sz="1800" b="1">
                 <a:solidFill>
-                  <a:srgbClr val="6366F1"/>
-                </a:solidFill>
-                <a:latin typeface="Plus Jakarta Sans"/>
+                  <a:srgbClr val="7C3AED"/>
+                </a:solidFill>
+                <a:latin typeface="Montserrat"/>
               </a:defRPr>
             </a:pPr>
             <a:r>
@@ -6511,9 +7169,9 @@
               </a:spcBef>
               <a:defRPr sz="1400">
                 <a:solidFill>
-                  <a:srgbClr val="94A3B8"/>
-                </a:solidFill>
-                <a:latin typeface="Plus Jakarta Sans"/>
+                  <a:srgbClr val="475569"/>
+                </a:solidFill>
+                <a:latin typeface="Montserrat"/>
               </a:defRPr>
             </a:pPr>
             <a:r>
@@ -6527,9 +7185,9 @@
               </a:spcBef>
               <a:defRPr sz="1800" b="1">
                 <a:solidFill>
-                  <a:srgbClr val="6366F1"/>
-                </a:solidFill>
-                <a:latin typeface="Plus Jakarta Sans"/>
+                  <a:srgbClr val="7C3AED"/>
+                </a:solidFill>
+                <a:latin typeface="Montserrat"/>
               </a:defRPr>
             </a:pPr>
             <a:r>
@@ -6543,9 +7201,9 @@
               </a:spcBef>
               <a:defRPr sz="1400">
                 <a:solidFill>
-                  <a:srgbClr val="94A3B8"/>
-                </a:solidFill>
-                <a:latin typeface="Plus Jakarta Sans"/>
+                  <a:srgbClr val="475569"/>
+                </a:solidFill>
+                <a:latin typeface="Montserrat"/>
               </a:defRPr>
             </a:pPr>
             <a:r>
@@ -6576,7 +7234,7 @@
     <p:bg>
       <p:bgPr>
         <a:solidFill>
-          <a:srgbClr val="0F172A"/>
+          <a:srgbClr val="FAF9FE"/>
         </a:solidFill>
         <a:effectLst/>
       </p:bgPr>
@@ -6613,9 +7271,9 @@
             <a:pPr>
               <a:defRPr sz="1000" b="1">
                 <a:solidFill>
-                  <a:srgbClr val="6366F1"/>
-                </a:solidFill>
-                <a:latin typeface="Plus Jakarta Sans"/>
+                  <a:srgbClr val="EC4899"/>
+                </a:solidFill>
+                <a:latin typeface="Montserrat"/>
               </a:defRPr>
             </a:pPr>
             <a:r>
@@ -6649,9 +7307,9 @@
             <a:pPr>
               <a:defRPr sz="2600" b="1">
                 <a:solidFill>
-                  <a:srgbClr val="F8FAFC"/>
-                </a:solidFill>
-                <a:latin typeface="Plus Jakarta Sans"/>
+                  <a:srgbClr val="1E1B4B"/>
+                </a:solidFill>
+                <a:latin typeface="Montserrat"/>
               </a:defRPr>
             </a:pPr>
             <a:r>
@@ -6662,7 +7320,50 @@
       </p:sp>
       <p:sp>
         <p:nvSpPr>
-          <p:cNvPr id="4" name="TextBox 3"/>
+          <p:cNvPr id="4" name="Rectangle 3"/>
+          <p:cNvSpPr/>
+          <p:nvPr/>
+        </p:nvSpPr>
+        <p:spPr>
+          <a:xfrm>
+            <a:off x="731520" y="1325880"/>
+            <a:ext cx="10728655" cy="18288"/>
+          </a:xfrm>
+          <a:prstGeom prst="rect">
+            <a:avLst/>
+          </a:prstGeom>
+          <a:solidFill>
+            <a:srgbClr val="7C3AED"/>
+          </a:solidFill>
+          <a:ln>
+            <a:noFill/>
+          </a:ln>
+        </p:spPr>
+        <p:style>
+          <a:lnRef idx="1">
+            <a:schemeClr val="accent1"/>
+          </a:lnRef>
+          <a:fillRef idx="3">
+            <a:schemeClr val="accent1"/>
+          </a:fillRef>
+          <a:effectRef idx="2">
+            <a:schemeClr val="accent1"/>
+          </a:effectRef>
+          <a:fontRef idx="minor">
+            <a:schemeClr val="lt1"/>
+          </a:fontRef>
+        </p:style>
+        <p:txBody>
+          <a:bodyPr rtlCol="0" anchor="ctr"/>
+          <a:lstStyle/>
+          <a:p>
+            <a:pPr algn="ctr"/>
+          </a:p>
+        </p:txBody>
+      </p:sp>
+      <p:sp>
+        <p:nvSpPr>
+          <p:cNvPr id="5" name="TextBox 4"/>
           <p:cNvSpPr txBox="1"/>
           <p:nvPr/>
         </p:nvSpPr>
@@ -6688,9 +7389,9 @@
               </a:spcBef>
               <a:defRPr sz="1600" b="1">
                 <a:solidFill>
-                  <a:srgbClr val="6366F1"/>
-                </a:solidFill>
-                <a:latin typeface="Plus Jakarta Sans"/>
+                  <a:srgbClr val="7C3AED"/>
+                </a:solidFill>
+                <a:latin typeface="Montserrat"/>
               </a:defRPr>
             </a:pPr>
             <a:r>
@@ -6704,9 +7405,9 @@
               </a:spcBef>
               <a:defRPr sz="1300">
                 <a:solidFill>
-                  <a:srgbClr val="94A3B8"/>
-                </a:solidFill>
-                <a:latin typeface="Plus Jakarta Sans"/>
+                  <a:srgbClr val="475569"/>
+                </a:solidFill>
+                <a:latin typeface="Montserrat"/>
               </a:defRPr>
             </a:pPr>
             <a:r>
@@ -6724,9 +7425,9 @@
               </a:spcBef>
               <a:defRPr sz="1600" b="1">
                 <a:solidFill>
-                  <a:srgbClr val="6366F1"/>
-                </a:solidFill>
-                <a:latin typeface="Plus Jakarta Sans"/>
+                  <a:srgbClr val="7C3AED"/>
+                </a:solidFill>
+                <a:latin typeface="Montserrat"/>
               </a:defRPr>
             </a:pPr>
             <a:r>
@@ -6740,9 +7441,9 @@
               </a:spcBef>
               <a:defRPr sz="1300">
                 <a:solidFill>
-                  <a:srgbClr val="94A3B8"/>
-                </a:solidFill>
-                <a:latin typeface="Plus Jakarta Sans"/>
+                  <a:srgbClr val="475569"/>
+                </a:solidFill>
+                <a:latin typeface="Montserrat"/>
               </a:defRPr>
             </a:pPr>
             <a:r>
@@ -6756,9 +7457,9 @@
               </a:spcBef>
               <a:defRPr sz="1600" b="1">
                 <a:solidFill>
-                  <a:srgbClr val="6366F1"/>
-                </a:solidFill>
-                <a:latin typeface="Plus Jakarta Sans"/>
+                  <a:srgbClr val="7C3AED"/>
+                </a:solidFill>
+                <a:latin typeface="Montserrat"/>
               </a:defRPr>
             </a:pPr>
             <a:r>
@@ -6772,9 +7473,9 @@
               </a:spcBef>
               <a:defRPr sz="1300">
                 <a:solidFill>
-                  <a:srgbClr val="94A3B8"/>
-                </a:solidFill>
-                <a:latin typeface="Plus Jakarta Sans"/>
+                  <a:srgbClr val="475569"/>
+                </a:solidFill>
+                <a:latin typeface="Montserrat"/>
               </a:defRPr>
             </a:pPr>
             <a:r>

</xml_diff>

<commit_message>
design: remove all shadows and unify color palette to slate and indigo
</commit_message>
<xml_diff>
--- a/slides.pptx
+++ b/slides.pptx
@@ -3094,7 +3094,7 @@
     <p:bg>
       <p:bgPr>
         <a:solidFill>
-          <a:srgbClr val="FAF9FE"/>
+          <a:srgbClr val="F8FAFC"/>
         </a:solidFill>
         <a:effectLst/>
       </p:bgPr>
@@ -3108,24 +3108,25 @@
       <p:grpSpPr/>
       <p:sp>
         <p:nvSpPr>
-          <p:cNvPr id="2" name="Oval 1"/>
+          <p:cNvPr id="2" name="Rounded Rectangle 1"/>
           <p:cNvSpPr/>
           <p:nvPr/>
         </p:nvSpPr>
         <p:spPr>
           <a:xfrm>
-            <a:off x="9326880" y="-1371600"/>
-            <a:ext cx="4114800" cy="4114800"/>
-          </a:xfrm>
-          <a:prstGeom prst="ellipse">
+            <a:off x="731520" y="2057400"/>
+            <a:ext cx="109728" cy="1645920"/>
+          </a:xfrm>
+          <a:prstGeom prst="roundRect">
             <a:avLst/>
           </a:prstGeom>
           <a:solidFill>
-            <a:srgbClr val="EDE9FE"/>
+            <a:srgbClr val="4338CA"/>
           </a:solidFill>
           <a:ln>
             <a:noFill/>
           </a:ln>
+          <a:effectLst/>
         </p:spPr>
         <p:style>
           <a:lnRef idx="1">
@@ -3151,24 +3152,211 @@
       </p:sp>
       <p:sp>
         <p:nvSpPr>
-          <p:cNvPr id="3" name="Oval 2"/>
+          <p:cNvPr id="3" name="TextBox 2"/>
+          <p:cNvSpPr txBox="1"/>
+          <p:nvPr/>
+        </p:nvSpPr>
+        <p:spPr>
+          <a:xfrm>
+            <a:off x="1097280" y="2011680"/>
+            <a:ext cx="10149840" cy="1828800"/>
+          </a:xfrm>
+          <a:prstGeom prst="rect">
+            <a:avLst/>
+          </a:prstGeom>
+          <a:noFill/>
+        </p:spPr>
+        <p:txBody>
+          <a:bodyPr wrap="square">
+            <a:spAutoFit/>
+          </a:bodyPr>
+          <a:lstStyle/>
+          <a:p>
+            <a:pPr>
+              <a:defRPr sz="4600" b="1">
+                <a:solidFill>
+                  <a:srgbClr val="4338CA"/>
+                </a:solidFill>
+                <a:latin typeface="Montserrat"/>
+              </a:defRPr>
+            </a:pPr>
+            <a:r>
+              <a:t>Introduction to WebAR</a:t>
+            </a:r>
+          </a:p>
+          <a:p>
+            <a:pPr>
+              <a:spcBef>
+                <a:spcPts val="1200"/>
+              </a:spcBef>
+              <a:defRPr sz="2000">
+                <a:solidFill>
+                  <a:srgbClr val="0F172A"/>
+                </a:solidFill>
+                <a:latin typeface="Montserrat"/>
+              </a:defRPr>
+            </a:pPr>
+            <a:r>
+              <a:t>Building an Image-Tracked Video Overlay Application</a:t>
+            </a:r>
+          </a:p>
+        </p:txBody>
+      </p:sp>
+      <p:sp>
+        <p:nvSpPr>
+          <p:cNvPr id="4" name="TextBox 3"/>
+          <p:cNvSpPr txBox="1"/>
+          <p:nvPr/>
+        </p:nvSpPr>
+        <p:spPr>
+          <a:xfrm>
+            <a:off x="914400" y="5029200"/>
+            <a:ext cx="10332720" cy="914400"/>
+          </a:xfrm>
+          <a:prstGeom prst="rect">
+            <a:avLst/>
+          </a:prstGeom>
+          <a:noFill/>
+        </p:spPr>
+        <p:txBody>
+          <a:bodyPr wrap="none">
+            <a:spAutoFit/>
+          </a:bodyPr>
+          <a:lstStyle/>
+          <a:p>
+            <a:pPr>
+              <a:defRPr sz="1400">
+                <a:solidFill>
+                  <a:srgbClr val="475569"/>
+                </a:solidFill>
+                <a:latin typeface="Montserrat"/>
+              </a:defRPr>
+            </a:pPr>
+            <a:r>
+              <a:t>A Step-by-Step Educational Curriculum for Beginners</a:t>
+            </a:r>
+          </a:p>
+        </p:txBody>
+      </p:sp>
+    </p:spTree>
+  </p:cSld>
+  <p:clrMapOvr>
+    <a:masterClrMapping/>
+  </p:clrMapOvr>
+</p:sld>
+</file>
+
+<file path=ppt/slides/slide10.xml><?xml version="1.0" encoding="utf-8"?>
+<p:sld xmlns:a="http://schemas.openxmlformats.org/drawingml/2006/main" xmlns:p="http://schemas.openxmlformats.org/presentationml/2006/main" xmlns:r="http://schemas.openxmlformats.org/officeDocument/2006/relationships">
+  <p:cSld>
+    <p:bg>
+      <p:bgPr>
+        <a:solidFill>
+          <a:srgbClr val="F8FAFC"/>
+        </a:solidFill>
+        <a:effectLst/>
+      </p:bgPr>
+    </p:bg>
+    <p:spTree>
+      <p:nvGrpSpPr>
+        <p:cNvPr id="1" name=""/>
+        <p:cNvGrpSpPr/>
+        <p:nvPr/>
+      </p:nvGrpSpPr>
+      <p:grpSpPr/>
+      <p:sp>
+        <p:nvSpPr>
+          <p:cNvPr id="2" name="TextBox 1"/>
+          <p:cNvSpPr txBox="1"/>
+          <p:nvPr/>
+        </p:nvSpPr>
+        <p:spPr>
+          <a:xfrm>
+            <a:off x="731520" y="365760"/>
+            <a:ext cx="10698480" cy="365760"/>
+          </a:xfrm>
+          <a:prstGeom prst="rect">
+            <a:avLst/>
+          </a:prstGeom>
+          <a:noFill/>
+        </p:spPr>
+        <p:txBody>
+          <a:bodyPr wrap="square">
+            <a:spAutoFit/>
+          </a:bodyPr>
+          <a:lstStyle/>
+          <a:p>
+            <a:pPr>
+              <a:defRPr sz="1000" b="1">
+                <a:solidFill>
+                  <a:srgbClr val="4338CA"/>
+                </a:solidFill>
+                <a:latin typeface="Montserrat"/>
+              </a:defRPr>
+            </a:pPr>
+            <a:r>
+              <a:t>MEDIA CONTROLS</a:t>
+            </a:r>
+          </a:p>
+        </p:txBody>
+      </p:sp>
+      <p:sp>
+        <p:nvSpPr>
+          <p:cNvPr id="3" name="TextBox 2"/>
+          <p:cNvSpPr txBox="1"/>
+          <p:nvPr/>
+        </p:nvSpPr>
+        <p:spPr>
+          <a:xfrm>
+            <a:off x="731520" y="548640"/>
+            <a:ext cx="10698480" cy="731520"/>
+          </a:xfrm>
+          <a:prstGeom prst="rect">
+            <a:avLst/>
+          </a:prstGeom>
+          <a:noFill/>
+        </p:spPr>
+        <p:txBody>
+          <a:bodyPr wrap="square">
+            <a:spAutoFit/>
+          </a:bodyPr>
+          <a:lstStyle/>
+          <a:p>
+            <a:pPr>
+              <a:defRPr sz="2600" b="1">
+                <a:solidFill>
+                  <a:srgbClr val="0F172A"/>
+                </a:solidFill>
+                <a:latin typeface="Montserrat"/>
+              </a:defRPr>
+            </a:pPr>
+            <a:r>
+              <a:t>Autoplay Bypass &amp; Instagram-Style Sound Controls</a:t>
+            </a:r>
+          </a:p>
+        </p:txBody>
+      </p:sp>
+      <p:sp>
+        <p:nvSpPr>
+          <p:cNvPr id="4" name="Rectangle 3"/>
           <p:cNvSpPr/>
           <p:nvPr/>
         </p:nvSpPr>
         <p:spPr>
           <a:xfrm>
-            <a:off x="8686800" y="1097280"/>
-            <a:ext cx="731520" cy="731520"/>
-          </a:xfrm>
-          <a:prstGeom prst="ellipse">
+            <a:off x="731520" y="1325880"/>
+            <a:ext cx="10728655" cy="18288"/>
+          </a:xfrm>
+          <a:prstGeom prst="rect">
             <a:avLst/>
           </a:prstGeom>
           <a:solidFill>
-            <a:srgbClr val="FEE2E2"/>
+            <a:srgbClr val="4338CA"/>
           </a:solidFill>
           <a:ln>
             <a:noFill/>
           </a:ln>
+          <a:effectLst/>
         </p:spPr>
         <p:style>
           <a:lnRef idx="1">
@@ -3194,24 +3382,146 @@
       </p:sp>
       <p:sp>
         <p:nvSpPr>
-          <p:cNvPr id="4" name="Rounded Rectangle 3"/>
+          <p:cNvPr id="5" name="TextBox 4"/>
+          <p:cNvSpPr txBox="1"/>
+          <p:nvPr/>
+        </p:nvSpPr>
+        <p:spPr>
+          <a:xfrm>
+            <a:off x="731520" y="1645920"/>
+            <a:ext cx="4572000" cy="4572000"/>
+          </a:xfrm>
+          <a:prstGeom prst="rect">
+            <a:avLst/>
+          </a:prstGeom>
+          <a:noFill/>
+        </p:spPr>
+        <p:txBody>
+          <a:bodyPr wrap="square">
+            <a:spAutoFit/>
+          </a:bodyPr>
+          <a:lstStyle/>
+          <a:p>
+            <a:pPr>
+              <a:spcBef>
+                <a:spcPts val="1500"/>
+              </a:spcBef>
+              <a:defRPr sz="1600" b="1">
+                <a:solidFill>
+                  <a:srgbClr val="4338CA"/>
+                </a:solidFill>
+                <a:latin typeface="Montserrat"/>
+              </a:defRPr>
+            </a:pPr>
+            <a:r>
+              <a:t>• Bypassing Autoplay Restrictions:</a:t>
+            </a:r>
+          </a:p>
+          <a:p>
+            <a:pPr>
+              <a:spcBef>
+                <a:spcPts val="400"/>
+              </a:spcBef>
+              <a:defRPr sz="1300">
+                <a:solidFill>
+                  <a:srgbClr val="475569"/>
+                </a:solidFill>
+                <a:latin typeface="Montserrat"/>
+              </a:defRPr>
+            </a:pPr>
+            <a:r>
+              <a:t>Mobile browsers block videos from playing automatically if they have sound. To build a seamless AR experience where the video starts immediately when the card is scanned, the video element MUST have the 'muted' attribute.</a:t>
+            </a:r>
+          </a:p>
+          <a:p>
+            <a:pPr>
+              <a:spcBef>
+                <a:spcPts val="1500"/>
+              </a:spcBef>
+              <a:defRPr sz="1600" b="1">
+                <a:solidFill>
+                  <a:srgbClr val="4338CA"/>
+                </a:solidFill>
+                <a:latin typeface="Montserrat"/>
+              </a:defRPr>
+            </a:pPr>
+            <a:r>
+              <a:t>• Instagram-Style Screen Taps:</a:t>
+            </a:r>
+          </a:p>
+          <a:p>
+            <a:pPr>
+              <a:spcBef>
+                <a:spcPts val="400"/>
+              </a:spcBef>
+              <a:defRPr sz="1300">
+                <a:solidFill>
+                  <a:srgbClr val="475569"/>
+                </a:solidFill>
+                <a:latin typeface="Montserrat"/>
+              </a:defRPr>
+            </a:pPr>
+            <a:r>
+              <a:t>To let students unmute the video overlay easily, we attach a page-wide click listener. Clicking anywhere on the camera canvas toggles between muted and unmuted playback.</a:t>
+            </a:r>
+          </a:p>
+          <a:p>
+            <a:pPr>
+              <a:spcBef>
+                <a:spcPts val="1500"/>
+              </a:spcBef>
+              <a:defRPr sz="1600" b="1">
+                <a:solidFill>
+                  <a:srgbClr val="4338CA"/>
+                </a:solidFill>
+                <a:latin typeface="Montserrat"/>
+              </a:defRPr>
+            </a:pPr>
+            <a:r>
+              <a:t>• Visual pop-up indicators:</a:t>
+            </a:r>
+          </a:p>
+          <a:p>
+            <a:pPr>
+              <a:spcBef>
+                <a:spcPts val="400"/>
+              </a:spcBef>
+              <a:defRPr sz="1300">
+                <a:solidFill>
+                  <a:srgbClr val="475569"/>
+                </a:solidFill>
+                <a:latin typeface="Montserrat"/>
+              </a:defRPr>
+            </a:pPr>
+            <a:r>
+              <a:t>When unmuting, a circular speaker status icon flashes in the center of the viewport for 600ms before fading away, matching Instagram's native video layout.</a:t>
+            </a:r>
+          </a:p>
+        </p:txBody>
+      </p:sp>
+      <p:sp>
+        <p:nvSpPr>
+          <p:cNvPr id="6" name="Rounded Rectangle 5"/>
           <p:cNvSpPr/>
           <p:nvPr/>
         </p:nvSpPr>
         <p:spPr>
           <a:xfrm>
-            <a:off x="731520" y="2057400"/>
-            <a:ext cx="109728" cy="1645920"/>
+            <a:off x="5669280" y="1645920"/>
+            <a:ext cx="5760720" cy="4389120"/>
           </a:xfrm>
           <a:prstGeom prst="roundRect">
             <a:avLst/>
           </a:prstGeom>
           <a:solidFill>
-            <a:srgbClr val="7C3AED"/>
+            <a:srgbClr val="F1F5F9"/>
           </a:solidFill>
-          <a:ln>
-            <a:noFill/>
+          <a:ln w="12700">
+            <a:solidFill>
+              <a:srgbClr val="E2E8F0"/>
+            </a:solidFill>
           </a:ln>
+          <a:effectLst/>
         </p:spPr>
         <p:style>
           <a:lnRef idx="1">
@@ -3228,97 +3538,364 @@
           </a:fontRef>
         </p:style>
         <p:txBody>
-          <a:bodyPr rtlCol="0" anchor="ctr"/>
-          <a:lstStyle/>
-          <a:p>
-            <a:pPr algn="ctr"/>
-          </a:p>
-        </p:txBody>
-      </p:sp>
-      <p:sp>
-        <p:nvSpPr>
-          <p:cNvPr id="5" name="TextBox 4"/>
-          <p:cNvSpPr txBox="1"/>
-          <p:nvPr/>
-        </p:nvSpPr>
-        <p:spPr>
-          <a:xfrm>
-            <a:off x="1097280" y="2011680"/>
-            <a:ext cx="10149840" cy="1828800"/>
-          </a:xfrm>
-          <a:prstGeom prst="rect">
-            <a:avLst/>
-          </a:prstGeom>
-          <a:noFill/>
-        </p:spPr>
-        <p:txBody>
-          <a:bodyPr wrap="square">
-            <a:spAutoFit/>
-          </a:bodyPr>
-          <a:lstStyle/>
-          <a:p>
-            <a:pPr>
-              <a:defRPr sz="4600" b="1">
-                <a:solidFill>
-                  <a:srgbClr val="7C3AED"/>
-                </a:solidFill>
-                <a:latin typeface="Montserrat"/>
-              </a:defRPr>
-            </a:pPr>
-            <a:r>
-              <a:t>Introduction to WebAR</a:t>
-            </a:r>
-          </a:p>
-          <a:p>
-            <a:pPr>
-              <a:spcBef>
-                <a:spcPts val="1200"/>
-              </a:spcBef>
-              <a:defRPr sz="2000">
-                <a:solidFill>
-                  <a:srgbClr val="1E1B4B"/>
-                </a:solidFill>
-                <a:latin typeface="Montserrat"/>
-              </a:defRPr>
-            </a:pPr>
-            <a:r>
-              <a:t>Building an Image-Tracked Video Overlay Application</a:t>
-            </a:r>
-          </a:p>
-        </p:txBody>
-      </p:sp>
-      <p:sp>
-        <p:nvSpPr>
-          <p:cNvPr id="6" name="TextBox 5"/>
-          <p:cNvSpPr txBox="1"/>
-          <p:nvPr/>
-        </p:nvSpPr>
-        <p:spPr>
-          <a:xfrm>
-            <a:off x="914400" y="5029200"/>
-            <a:ext cx="10332720" cy="914400"/>
-          </a:xfrm>
-          <a:prstGeom prst="rect">
-            <a:avLst/>
-          </a:prstGeom>
-          <a:noFill/>
-        </p:spPr>
-        <p:txBody>
-          <a:bodyPr wrap="none">
-            <a:spAutoFit/>
-          </a:bodyPr>
-          <a:lstStyle/>
-          <a:p>
-            <a:pPr>
-              <a:defRPr sz="1400">
-                <a:solidFill>
-                  <a:srgbClr val="475569"/>
-                </a:solidFill>
-                <a:latin typeface="Montserrat"/>
-              </a:defRPr>
-            </a:pPr>
-            <a:r>
-              <a:t>A Step-by-Step Educational Curriculum for Beginners</a:t>
+          <a:bodyPr rtlCol="0" anchor="ctr" wrap="square" lIns="182880" rIns="182880" tIns="182880" bIns="182880"/>
+          <a:lstStyle/>
+          <a:p>
+            <a:pPr algn="ctr">
+              <a:defRPr sz="1100">
+                <a:solidFill>
+                  <a:srgbClr val="334155"/>
+                </a:solidFill>
+                <a:latin typeface="Courier New"/>
+              </a:defRPr>
+            </a:pPr>
+            <a:r>
+              <a:t>// Toggle mute state and center sound flash</a:t>
+            </a:r>
+          </a:p>
+          <a:p>
+            <a:pPr>
+              <a:defRPr sz="1100">
+                <a:solidFill>
+                  <a:srgbClr val="334155"/>
+                </a:solidFill>
+                <a:latin typeface="Courier New"/>
+              </a:defRPr>
+            </a:pPr>
+            <a:r>
+              <a:t>const toggleMuteState = () =&gt; {</a:t>
+            </a:r>
+          </a:p>
+          <a:p>
+            <a:pPr>
+              <a:defRPr sz="1100">
+                <a:solidFill>
+                  <a:srgbClr val="334155"/>
+                </a:solidFill>
+                <a:latin typeface="Courier New"/>
+              </a:defRPr>
+            </a:pPr>
+            <a:r>
+              <a:t>  if (arVideo.muted) {</a:t>
+            </a:r>
+          </a:p>
+          <a:p>
+            <a:pPr>
+              <a:defRPr sz="1100">
+                <a:solidFill>
+                  <a:srgbClr val="334155"/>
+                </a:solidFill>
+                <a:latin typeface="Courier New"/>
+              </a:defRPr>
+            </a:pPr>
+            <a:r>
+              <a:t>    arVideo.muted = false;</a:t>
+            </a:r>
+          </a:p>
+          <a:p>
+            <a:pPr>
+              <a:defRPr sz="1100">
+                <a:solidFill>
+                  <a:srgbClr val="334155"/>
+                </a:solidFill>
+                <a:latin typeface="Courier New"/>
+              </a:defRPr>
+            </a:pPr>
+            <a:r>
+              <a:t>    muteIcon.innerHTML = SPEAKER_UNMUTED_SVG;</a:t>
+            </a:r>
+          </a:p>
+          <a:p>
+            <a:pPr>
+              <a:defRPr sz="1100">
+                <a:solidFill>
+                  <a:srgbClr val="334155"/>
+                </a:solidFill>
+                <a:latin typeface="Courier New"/>
+              </a:defRPr>
+            </a:pPr>
+            <a:r>
+              <a:t>    soundFlashIcon.innerHTML = SPEAKER_UNMUTED_SVG;</a:t>
+            </a:r>
+          </a:p>
+          <a:p>
+            <a:pPr>
+              <a:defRPr sz="1100">
+                <a:solidFill>
+                  <a:srgbClr val="334155"/>
+                </a:solidFill>
+                <a:latin typeface="Courier New"/>
+              </a:defRPr>
+            </a:pPr>
+            <a:r>
+              <a:t>  } else {</a:t>
+            </a:r>
+          </a:p>
+          <a:p>
+            <a:pPr>
+              <a:defRPr sz="1100">
+                <a:solidFill>
+                  <a:srgbClr val="334155"/>
+                </a:solidFill>
+                <a:latin typeface="Courier New"/>
+              </a:defRPr>
+            </a:pPr>
+            <a:r>
+              <a:t>    arVideo.muted = true;</a:t>
+            </a:r>
+          </a:p>
+          <a:p>
+            <a:pPr>
+              <a:defRPr sz="1100">
+                <a:solidFill>
+                  <a:srgbClr val="334155"/>
+                </a:solidFill>
+                <a:latin typeface="Courier New"/>
+              </a:defRPr>
+            </a:pPr>
+            <a:r>
+              <a:t>    muteIcon.innerHTML = SPEAKER_MUTED_SVG;</a:t>
+            </a:r>
+          </a:p>
+          <a:p>
+            <a:pPr>
+              <a:defRPr sz="1100">
+                <a:solidFill>
+                  <a:srgbClr val="334155"/>
+                </a:solidFill>
+                <a:latin typeface="Courier New"/>
+              </a:defRPr>
+            </a:pPr>
+            <a:r>
+              <a:t>    soundFlashIcon.innerHTML = SPEAKER_MUTED_SVG;</a:t>
+            </a:r>
+          </a:p>
+          <a:p>
+            <a:pPr>
+              <a:defRPr sz="1100">
+                <a:solidFill>
+                  <a:srgbClr val="334155"/>
+                </a:solidFill>
+                <a:latin typeface="Courier New"/>
+              </a:defRPr>
+            </a:pPr>
+            <a:r>
+              <a:t>  }</a:t>
+            </a:r>
+          </a:p>
+          <a:p>
+            <a:pPr>
+              <a:defRPr sz="1100">
+                <a:solidFill>
+                  <a:srgbClr val="334155"/>
+                </a:solidFill>
+                <a:latin typeface="Courier New"/>
+              </a:defRPr>
+            </a:pPr>
+          </a:p>
+          <a:p>
+            <a:pPr>
+              <a:defRPr sz="1100">
+                <a:solidFill>
+                  <a:srgbClr val="334155"/>
+                </a:solidFill>
+                <a:latin typeface="Courier New"/>
+              </a:defRPr>
+            </a:pPr>
+            <a:r>
+              <a:t>  // Flash pop-up icon in center</a:t>
+            </a:r>
+          </a:p>
+          <a:p>
+            <a:pPr>
+              <a:defRPr sz="1100">
+                <a:solidFill>
+                  <a:srgbClr val="334155"/>
+                </a:solidFill>
+                <a:latin typeface="Courier New"/>
+              </a:defRPr>
+            </a:pPr>
+            <a:r>
+              <a:t>  soundFlash.classList.remove("show");</a:t>
+            </a:r>
+          </a:p>
+          <a:p>
+            <a:pPr>
+              <a:defRPr sz="1100">
+                <a:solidFill>
+                  <a:srgbClr val="334155"/>
+                </a:solidFill>
+                <a:latin typeface="Courier New"/>
+              </a:defRPr>
+            </a:pPr>
+            <a:r>
+              <a:t>  void soundFlash.offsetWidth; // force reflow</a:t>
+            </a:r>
+          </a:p>
+          <a:p>
+            <a:pPr>
+              <a:defRPr sz="1100">
+                <a:solidFill>
+                  <a:srgbClr val="334155"/>
+                </a:solidFill>
+                <a:latin typeface="Courier New"/>
+              </a:defRPr>
+            </a:pPr>
+            <a:r>
+              <a:t>  soundFlash.classList.add("show");</a:t>
+            </a:r>
+          </a:p>
+          <a:p>
+            <a:pPr>
+              <a:defRPr sz="1100">
+                <a:solidFill>
+                  <a:srgbClr val="334155"/>
+                </a:solidFill>
+                <a:latin typeface="Courier New"/>
+              </a:defRPr>
+            </a:pPr>
+            <a:r>
+              <a:t>  setTimeout(() =&gt; {</a:t>
+            </a:r>
+          </a:p>
+          <a:p>
+            <a:pPr>
+              <a:defRPr sz="1100">
+                <a:solidFill>
+                  <a:srgbClr val="334155"/>
+                </a:solidFill>
+                <a:latin typeface="Courier New"/>
+              </a:defRPr>
+            </a:pPr>
+            <a:r>
+              <a:t>    soundFlash.classList.remove("show");</a:t>
+            </a:r>
+          </a:p>
+          <a:p>
+            <a:pPr>
+              <a:defRPr sz="1100">
+                <a:solidFill>
+                  <a:srgbClr val="334155"/>
+                </a:solidFill>
+                <a:latin typeface="Courier New"/>
+              </a:defRPr>
+            </a:pPr>
+            <a:r>
+              <a:t>  }, 600);</a:t>
+            </a:r>
+          </a:p>
+          <a:p>
+            <a:pPr>
+              <a:defRPr sz="1100">
+                <a:solidFill>
+                  <a:srgbClr val="334155"/>
+                </a:solidFill>
+                <a:latin typeface="Courier New"/>
+              </a:defRPr>
+            </a:pPr>
+            <a:r>
+              <a:t>};</a:t>
+            </a:r>
+          </a:p>
+          <a:p>
+            <a:pPr>
+              <a:defRPr sz="1100">
+                <a:solidFill>
+                  <a:srgbClr val="334155"/>
+                </a:solidFill>
+                <a:latin typeface="Courier New"/>
+              </a:defRPr>
+            </a:pPr>
+          </a:p>
+          <a:p>
+            <a:pPr>
+              <a:defRPr sz="1100">
+                <a:solidFill>
+                  <a:srgbClr val="334155"/>
+                </a:solidFill>
+                <a:latin typeface="Courier New"/>
+              </a:defRPr>
+            </a:pPr>
+            <a:r>
+              <a:t>// Tap screen background to toggle</a:t>
+            </a:r>
+          </a:p>
+          <a:p>
+            <a:pPr>
+              <a:defRPr sz="1100">
+                <a:solidFill>
+                  <a:srgbClr val="334155"/>
+                </a:solidFill>
+                <a:latin typeface="Courier New"/>
+              </a:defRPr>
+            </a:pPr>
+            <a:r>
+              <a:t>document.body.addEventListener("click", (e) =&gt; {</a:t>
+            </a:r>
+          </a:p>
+          <a:p>
+            <a:pPr>
+              <a:defRPr sz="1100">
+                <a:solidFill>
+                  <a:srgbClr val="334155"/>
+                </a:solidFill>
+                <a:latin typeface="Courier New"/>
+              </a:defRPr>
+            </a:pPr>
+            <a:r>
+              <a:t>  if (e.target.closest("#start-screen") ||</a:t>
+            </a:r>
+          </a:p>
+          <a:p>
+            <a:pPr>
+              <a:defRPr sz="1100">
+                <a:solidFill>
+                  <a:srgbClr val="334155"/>
+                </a:solidFill>
+                <a:latin typeface="Courier New"/>
+              </a:defRPr>
+            </a:pPr>
+            <a:r>
+              <a:t>      e.target.closest(".header") ||</a:t>
+            </a:r>
+          </a:p>
+          <a:p>
+            <a:pPr>
+              <a:defRPr sz="1100">
+                <a:solidFill>
+                  <a:srgbClr val="334155"/>
+                </a:solidFill>
+                <a:latin typeface="Courier New"/>
+              </a:defRPr>
+            </a:pPr>
+            <a:r>
+              <a:t>      e.target.closest("#mute-button")) return;</a:t>
+            </a:r>
+          </a:p>
+          <a:p>
+            <a:pPr>
+              <a:defRPr sz="1100">
+                <a:solidFill>
+                  <a:srgbClr val="334155"/>
+                </a:solidFill>
+                <a:latin typeface="Courier New"/>
+              </a:defRPr>
+            </a:pPr>
+            <a:r>
+              <a:t>  toggleMuteState();</a:t>
+            </a:r>
+          </a:p>
+          <a:p>
+            <a:pPr>
+              <a:defRPr sz="1100">
+                <a:solidFill>
+                  <a:srgbClr val="334155"/>
+                </a:solidFill>
+                <a:latin typeface="Courier New"/>
+              </a:defRPr>
+            </a:pPr>
+            <a:r>
+              <a:t>});</a:t>
             </a:r>
           </a:p>
         </p:txBody>
@@ -3331,13 +3908,13 @@
 </p:sld>
 </file>
 
-<file path=ppt/slides/slide10.xml><?xml version="1.0" encoding="utf-8"?>
+<file path=ppt/slides/slide11.xml><?xml version="1.0" encoding="utf-8"?>
 <p:sld xmlns:a="http://schemas.openxmlformats.org/drawingml/2006/main" xmlns:p="http://schemas.openxmlformats.org/presentationml/2006/main" xmlns:r="http://schemas.openxmlformats.org/officeDocument/2006/relationships">
   <p:cSld>
     <p:bg>
       <p:bgPr>
         <a:solidFill>
-          <a:srgbClr val="FAF9FE"/>
+          <a:srgbClr val="F8FAFC"/>
         </a:solidFill>
         <a:effectLst/>
       </p:bgPr>
@@ -3374,13 +3951,13 @@
             <a:pPr>
               <a:defRPr sz="1000" b="1">
                 <a:solidFill>
-                  <a:srgbClr val="EC4899"/>
-                </a:solidFill>
-                <a:latin typeface="Montserrat"/>
-              </a:defRPr>
-            </a:pPr>
-            <a:r>
-              <a:t>MEDIA CONTROLS</a:t>
+                  <a:srgbClr val="4338CA"/>
+                </a:solidFill>
+                <a:latin typeface="Montserrat"/>
+              </a:defRPr>
+            </a:pPr>
+            <a:r>
+              <a:t>TESTING TARGETS</a:t>
             </a:r>
           </a:p>
         </p:txBody>
@@ -3410,13 +3987,13 @@
             <a:pPr>
               <a:defRPr sz="2600" b="1">
                 <a:solidFill>
-                  <a:srgbClr val="1E1B4B"/>
-                </a:solidFill>
-                <a:latin typeface="Montserrat"/>
-              </a:defRPr>
-            </a:pPr>
-            <a:r>
-              <a:t>Autoplay Bypass &amp; Instagram-Style Sound Controls</a:t>
+                  <a:srgbClr val="0F172A"/>
+                </a:solidFill>
+                <a:latin typeface="Montserrat"/>
+              </a:defRPr>
+            </a:pPr>
+            <a:r>
+              <a:t>Target Anchor Cards: preview.html</a:t>
             </a:r>
           </a:p>
         </p:txBody>
@@ -3436,11 +4013,12 @@
             <a:avLst/>
           </a:prstGeom>
           <a:solidFill>
-            <a:srgbClr val="7C3AED"/>
+            <a:srgbClr val="4338CA"/>
           </a:solidFill>
           <a:ln>
             <a:noFill/>
           </a:ln>
+          <a:effectLst/>
         </p:spPr>
         <p:style>
           <a:lnRef idx="1">
@@ -3492,13 +4070,13 @@
               </a:spcBef>
               <a:defRPr sz="1600" b="1">
                 <a:solidFill>
-                  <a:srgbClr val="7C3AED"/>
-                </a:solidFill>
-                <a:latin typeface="Montserrat"/>
-              </a:defRPr>
-            </a:pPr>
-            <a:r>
-              <a:t>• Bypassing Autoplay Restrictions:</a:t>
+                  <a:srgbClr val="4338CA"/>
+                </a:solidFill>
+                <a:latin typeface="Montserrat"/>
+              </a:defRPr>
+            </a:pPr>
+            <a:r>
+              <a:t>• Target Cards Utility Page:</a:t>
             </a:r>
           </a:p>
           <a:p>
@@ -3514,7 +4092,7 @@
               </a:defRPr>
             </a:pPr>
             <a:r>
-              <a:t>Mobile browsers block videos from playing automatically if they have sound. To build a seamless AR experience where the video starts immediately when the card is scanned, the video element MUST have the 'muted' attribute.</a:t>
+              <a:t>The preview.html page hosts the target card display and printing instructions so students can load it on their desktop monitor or print it out.</a:t>
             </a:r>
           </a:p>
           <a:p>
@@ -3524,13 +4102,13 @@
               </a:spcBef>
               <a:defRPr sz="1600" b="1">
                 <a:solidFill>
-                  <a:srgbClr val="7C3AED"/>
-                </a:solidFill>
-                <a:latin typeface="Montserrat"/>
-              </a:defRPr>
-            </a:pPr>
-            <a:r>
-              <a:t>• Instagram-Style Screen Taps:</a:t>
+                  <a:srgbClr val="4338CA"/>
+                </a:solidFill>
+                <a:latin typeface="Montserrat"/>
+              </a:defRPr>
+            </a:pPr>
+            <a:r>
+              <a:t>• CSS Print Stylesheets (@media print):</a:t>
             </a:r>
           </a:p>
           <a:p>
@@ -3546,7 +4124,7 @@
               </a:defRPr>
             </a:pPr>
             <a:r>
-              <a:t>To let students unmute the video overlay easily, we attach a page-wide click listener. Clicking anywhere on the camera canvas toggles between muted and unmuted playback.</a:t>
+              <a:t>To ensure printer ink is not wasted on dark Web UI colors and instructions, preview.html contains a print media query that hides all descriptions, guide corners, and buttons when printing, leaving only the exact target card.</a:t>
             </a:r>
           </a:p>
           <a:p>
@@ -3556,667 +4134,7 @@
               </a:spcBef>
               <a:defRPr sz="1600" b="1">
                 <a:solidFill>
-                  <a:srgbClr val="7C3AED"/>
-                </a:solidFill>
-                <a:latin typeface="Montserrat"/>
-              </a:defRPr>
-            </a:pPr>
-            <a:r>
-              <a:t>• Visual pop-up indicators:</a:t>
-            </a:r>
-          </a:p>
-          <a:p>
-            <a:pPr>
-              <a:spcBef>
-                <a:spcPts val="400"/>
-              </a:spcBef>
-              <a:defRPr sz="1300">
-                <a:solidFill>
-                  <a:srgbClr val="475569"/>
-                </a:solidFill>
-                <a:latin typeface="Montserrat"/>
-              </a:defRPr>
-            </a:pPr>
-            <a:r>
-              <a:t>When unmuting, a circular speaker status icon flashes in the center of the viewport for 600ms before fading away, matching Instagram's native video layout.</a:t>
-            </a:r>
-          </a:p>
-        </p:txBody>
-      </p:sp>
-      <p:sp>
-        <p:nvSpPr>
-          <p:cNvPr id="6" name="Rounded Rectangle 5"/>
-          <p:cNvSpPr/>
-          <p:nvPr/>
-        </p:nvSpPr>
-        <p:spPr>
-          <a:xfrm>
-            <a:off x="5669280" y="1645920"/>
-            <a:ext cx="5760720" cy="4389120"/>
-          </a:xfrm>
-          <a:prstGeom prst="roundRect">
-            <a:avLst/>
-          </a:prstGeom>
-          <a:solidFill>
-            <a:srgbClr val="F1F5F9"/>
-          </a:solidFill>
-          <a:ln w="12700">
-            <a:solidFill>
-              <a:srgbClr val="E2E8F0"/>
-            </a:solidFill>
-          </a:ln>
-        </p:spPr>
-        <p:style>
-          <a:lnRef idx="1">
-            <a:schemeClr val="accent1"/>
-          </a:lnRef>
-          <a:fillRef idx="3">
-            <a:schemeClr val="accent1"/>
-          </a:fillRef>
-          <a:effectRef idx="2">
-            <a:schemeClr val="accent1"/>
-          </a:effectRef>
-          <a:fontRef idx="minor">
-            <a:schemeClr val="lt1"/>
-          </a:fontRef>
-        </p:style>
-        <p:txBody>
-          <a:bodyPr rtlCol="0" anchor="ctr" wrap="square" lIns="182880" rIns="182880" tIns="182880" bIns="182880"/>
-          <a:lstStyle/>
-          <a:p>
-            <a:pPr algn="ctr">
-              <a:defRPr sz="1100">
-                <a:solidFill>
-                  <a:srgbClr val="0F766E"/>
-                </a:solidFill>
-                <a:latin typeface="Courier New"/>
-              </a:defRPr>
-            </a:pPr>
-            <a:r>
-              <a:t>// Toggle mute state and center sound flash</a:t>
-            </a:r>
-          </a:p>
-          <a:p>
-            <a:pPr>
-              <a:defRPr sz="1100">
-                <a:solidFill>
-                  <a:srgbClr val="0F766E"/>
-                </a:solidFill>
-                <a:latin typeface="Courier New"/>
-              </a:defRPr>
-            </a:pPr>
-            <a:r>
-              <a:t>const toggleMuteState = () =&gt; {</a:t>
-            </a:r>
-          </a:p>
-          <a:p>
-            <a:pPr>
-              <a:defRPr sz="1100">
-                <a:solidFill>
-                  <a:srgbClr val="0F766E"/>
-                </a:solidFill>
-                <a:latin typeface="Courier New"/>
-              </a:defRPr>
-            </a:pPr>
-            <a:r>
-              <a:t>  if (arVideo.muted) {</a:t>
-            </a:r>
-          </a:p>
-          <a:p>
-            <a:pPr>
-              <a:defRPr sz="1100">
-                <a:solidFill>
-                  <a:srgbClr val="0F766E"/>
-                </a:solidFill>
-                <a:latin typeface="Courier New"/>
-              </a:defRPr>
-            </a:pPr>
-            <a:r>
-              <a:t>    arVideo.muted = false;</a:t>
-            </a:r>
-          </a:p>
-          <a:p>
-            <a:pPr>
-              <a:defRPr sz="1100">
-                <a:solidFill>
-                  <a:srgbClr val="0F766E"/>
-                </a:solidFill>
-                <a:latin typeface="Courier New"/>
-              </a:defRPr>
-            </a:pPr>
-            <a:r>
-              <a:t>    muteIcon.innerHTML = SPEAKER_UNMUTED_SVG;</a:t>
-            </a:r>
-          </a:p>
-          <a:p>
-            <a:pPr>
-              <a:defRPr sz="1100">
-                <a:solidFill>
-                  <a:srgbClr val="0F766E"/>
-                </a:solidFill>
-                <a:latin typeface="Courier New"/>
-              </a:defRPr>
-            </a:pPr>
-            <a:r>
-              <a:t>    soundFlashIcon.innerHTML = SPEAKER_UNMUTED_SVG;</a:t>
-            </a:r>
-          </a:p>
-          <a:p>
-            <a:pPr>
-              <a:defRPr sz="1100">
-                <a:solidFill>
-                  <a:srgbClr val="0F766E"/>
-                </a:solidFill>
-                <a:latin typeface="Courier New"/>
-              </a:defRPr>
-            </a:pPr>
-            <a:r>
-              <a:t>  } else {</a:t>
-            </a:r>
-          </a:p>
-          <a:p>
-            <a:pPr>
-              <a:defRPr sz="1100">
-                <a:solidFill>
-                  <a:srgbClr val="0F766E"/>
-                </a:solidFill>
-                <a:latin typeface="Courier New"/>
-              </a:defRPr>
-            </a:pPr>
-            <a:r>
-              <a:t>    arVideo.muted = true;</a:t>
-            </a:r>
-          </a:p>
-          <a:p>
-            <a:pPr>
-              <a:defRPr sz="1100">
-                <a:solidFill>
-                  <a:srgbClr val="0F766E"/>
-                </a:solidFill>
-                <a:latin typeface="Courier New"/>
-              </a:defRPr>
-            </a:pPr>
-            <a:r>
-              <a:t>    muteIcon.innerHTML = SPEAKER_MUTED_SVG;</a:t>
-            </a:r>
-          </a:p>
-          <a:p>
-            <a:pPr>
-              <a:defRPr sz="1100">
-                <a:solidFill>
-                  <a:srgbClr val="0F766E"/>
-                </a:solidFill>
-                <a:latin typeface="Courier New"/>
-              </a:defRPr>
-            </a:pPr>
-            <a:r>
-              <a:t>    soundFlashIcon.innerHTML = SPEAKER_MUTED_SVG;</a:t>
-            </a:r>
-          </a:p>
-          <a:p>
-            <a:pPr>
-              <a:defRPr sz="1100">
-                <a:solidFill>
-                  <a:srgbClr val="0F766E"/>
-                </a:solidFill>
-                <a:latin typeface="Courier New"/>
-              </a:defRPr>
-            </a:pPr>
-            <a:r>
-              <a:t>  }</a:t>
-            </a:r>
-          </a:p>
-          <a:p>
-            <a:pPr>
-              <a:defRPr sz="1100">
-                <a:solidFill>
-                  <a:srgbClr val="0F766E"/>
-                </a:solidFill>
-                <a:latin typeface="Courier New"/>
-              </a:defRPr>
-            </a:pPr>
-          </a:p>
-          <a:p>
-            <a:pPr>
-              <a:defRPr sz="1100">
-                <a:solidFill>
-                  <a:srgbClr val="0F766E"/>
-                </a:solidFill>
-                <a:latin typeface="Courier New"/>
-              </a:defRPr>
-            </a:pPr>
-            <a:r>
-              <a:t>  // Flash pop-up icon in center</a:t>
-            </a:r>
-          </a:p>
-          <a:p>
-            <a:pPr>
-              <a:defRPr sz="1100">
-                <a:solidFill>
-                  <a:srgbClr val="0F766E"/>
-                </a:solidFill>
-                <a:latin typeface="Courier New"/>
-              </a:defRPr>
-            </a:pPr>
-            <a:r>
-              <a:t>  soundFlash.classList.remove("show");</a:t>
-            </a:r>
-          </a:p>
-          <a:p>
-            <a:pPr>
-              <a:defRPr sz="1100">
-                <a:solidFill>
-                  <a:srgbClr val="0F766E"/>
-                </a:solidFill>
-                <a:latin typeface="Courier New"/>
-              </a:defRPr>
-            </a:pPr>
-            <a:r>
-              <a:t>  void soundFlash.offsetWidth; // force reflow</a:t>
-            </a:r>
-          </a:p>
-          <a:p>
-            <a:pPr>
-              <a:defRPr sz="1100">
-                <a:solidFill>
-                  <a:srgbClr val="0F766E"/>
-                </a:solidFill>
-                <a:latin typeface="Courier New"/>
-              </a:defRPr>
-            </a:pPr>
-            <a:r>
-              <a:t>  soundFlash.classList.add("show");</a:t>
-            </a:r>
-          </a:p>
-          <a:p>
-            <a:pPr>
-              <a:defRPr sz="1100">
-                <a:solidFill>
-                  <a:srgbClr val="0F766E"/>
-                </a:solidFill>
-                <a:latin typeface="Courier New"/>
-              </a:defRPr>
-            </a:pPr>
-            <a:r>
-              <a:t>  setTimeout(() =&gt; {</a:t>
-            </a:r>
-          </a:p>
-          <a:p>
-            <a:pPr>
-              <a:defRPr sz="1100">
-                <a:solidFill>
-                  <a:srgbClr val="0F766E"/>
-                </a:solidFill>
-                <a:latin typeface="Courier New"/>
-              </a:defRPr>
-            </a:pPr>
-            <a:r>
-              <a:t>    soundFlash.classList.remove("show");</a:t>
-            </a:r>
-          </a:p>
-          <a:p>
-            <a:pPr>
-              <a:defRPr sz="1100">
-                <a:solidFill>
-                  <a:srgbClr val="0F766E"/>
-                </a:solidFill>
-                <a:latin typeface="Courier New"/>
-              </a:defRPr>
-            </a:pPr>
-            <a:r>
-              <a:t>  }, 600);</a:t>
-            </a:r>
-          </a:p>
-          <a:p>
-            <a:pPr>
-              <a:defRPr sz="1100">
-                <a:solidFill>
-                  <a:srgbClr val="0F766E"/>
-                </a:solidFill>
-                <a:latin typeface="Courier New"/>
-              </a:defRPr>
-            </a:pPr>
-            <a:r>
-              <a:t>};</a:t>
-            </a:r>
-          </a:p>
-          <a:p>
-            <a:pPr>
-              <a:defRPr sz="1100">
-                <a:solidFill>
-                  <a:srgbClr val="0F766E"/>
-                </a:solidFill>
-                <a:latin typeface="Courier New"/>
-              </a:defRPr>
-            </a:pPr>
-          </a:p>
-          <a:p>
-            <a:pPr>
-              <a:defRPr sz="1100">
-                <a:solidFill>
-                  <a:srgbClr val="0F766E"/>
-                </a:solidFill>
-                <a:latin typeface="Courier New"/>
-              </a:defRPr>
-            </a:pPr>
-            <a:r>
-              <a:t>// Tap screen background to toggle</a:t>
-            </a:r>
-          </a:p>
-          <a:p>
-            <a:pPr>
-              <a:defRPr sz="1100">
-                <a:solidFill>
-                  <a:srgbClr val="0F766E"/>
-                </a:solidFill>
-                <a:latin typeface="Courier New"/>
-              </a:defRPr>
-            </a:pPr>
-            <a:r>
-              <a:t>document.body.addEventListener("click", (e) =&gt; {</a:t>
-            </a:r>
-          </a:p>
-          <a:p>
-            <a:pPr>
-              <a:defRPr sz="1100">
-                <a:solidFill>
-                  <a:srgbClr val="0F766E"/>
-                </a:solidFill>
-                <a:latin typeface="Courier New"/>
-              </a:defRPr>
-            </a:pPr>
-            <a:r>
-              <a:t>  if (e.target.closest("#start-screen") ||</a:t>
-            </a:r>
-          </a:p>
-          <a:p>
-            <a:pPr>
-              <a:defRPr sz="1100">
-                <a:solidFill>
-                  <a:srgbClr val="0F766E"/>
-                </a:solidFill>
-                <a:latin typeface="Courier New"/>
-              </a:defRPr>
-            </a:pPr>
-            <a:r>
-              <a:t>      e.target.closest(".header") ||</a:t>
-            </a:r>
-          </a:p>
-          <a:p>
-            <a:pPr>
-              <a:defRPr sz="1100">
-                <a:solidFill>
-                  <a:srgbClr val="0F766E"/>
-                </a:solidFill>
-                <a:latin typeface="Courier New"/>
-              </a:defRPr>
-            </a:pPr>
-            <a:r>
-              <a:t>      e.target.closest("#mute-button")) return;</a:t>
-            </a:r>
-          </a:p>
-          <a:p>
-            <a:pPr>
-              <a:defRPr sz="1100">
-                <a:solidFill>
-                  <a:srgbClr val="0F766E"/>
-                </a:solidFill>
-                <a:latin typeface="Courier New"/>
-              </a:defRPr>
-            </a:pPr>
-            <a:r>
-              <a:t>  toggleMuteState();</a:t>
-            </a:r>
-          </a:p>
-          <a:p>
-            <a:pPr>
-              <a:defRPr sz="1100">
-                <a:solidFill>
-                  <a:srgbClr val="0F766E"/>
-                </a:solidFill>
-                <a:latin typeface="Courier New"/>
-              </a:defRPr>
-            </a:pPr>
-            <a:r>
-              <a:t>});</a:t>
-            </a:r>
-          </a:p>
-        </p:txBody>
-      </p:sp>
-    </p:spTree>
-  </p:cSld>
-  <p:clrMapOvr>
-    <a:masterClrMapping/>
-  </p:clrMapOvr>
-</p:sld>
-</file>
-
-<file path=ppt/slides/slide11.xml><?xml version="1.0" encoding="utf-8"?>
-<p:sld xmlns:a="http://schemas.openxmlformats.org/drawingml/2006/main" xmlns:p="http://schemas.openxmlformats.org/presentationml/2006/main" xmlns:r="http://schemas.openxmlformats.org/officeDocument/2006/relationships">
-  <p:cSld>
-    <p:bg>
-      <p:bgPr>
-        <a:solidFill>
-          <a:srgbClr val="FAF9FE"/>
-        </a:solidFill>
-        <a:effectLst/>
-      </p:bgPr>
-    </p:bg>
-    <p:spTree>
-      <p:nvGrpSpPr>
-        <p:cNvPr id="1" name=""/>
-        <p:cNvGrpSpPr/>
-        <p:nvPr/>
-      </p:nvGrpSpPr>
-      <p:grpSpPr/>
-      <p:sp>
-        <p:nvSpPr>
-          <p:cNvPr id="2" name="TextBox 1"/>
-          <p:cNvSpPr txBox="1"/>
-          <p:nvPr/>
-        </p:nvSpPr>
-        <p:spPr>
-          <a:xfrm>
-            <a:off x="731520" y="365760"/>
-            <a:ext cx="10698480" cy="365760"/>
-          </a:xfrm>
-          <a:prstGeom prst="rect">
-            <a:avLst/>
-          </a:prstGeom>
-          <a:noFill/>
-        </p:spPr>
-        <p:txBody>
-          <a:bodyPr wrap="square">
-            <a:spAutoFit/>
-          </a:bodyPr>
-          <a:lstStyle/>
-          <a:p>
-            <a:pPr>
-              <a:defRPr sz="1000" b="1">
-                <a:solidFill>
-                  <a:srgbClr val="EC4899"/>
-                </a:solidFill>
-                <a:latin typeface="Montserrat"/>
-              </a:defRPr>
-            </a:pPr>
-            <a:r>
-              <a:t>TESTING TARGETS</a:t>
-            </a:r>
-          </a:p>
-        </p:txBody>
-      </p:sp>
-      <p:sp>
-        <p:nvSpPr>
-          <p:cNvPr id="3" name="TextBox 2"/>
-          <p:cNvSpPr txBox="1"/>
-          <p:nvPr/>
-        </p:nvSpPr>
-        <p:spPr>
-          <a:xfrm>
-            <a:off x="731520" y="548640"/>
-            <a:ext cx="10698480" cy="731520"/>
-          </a:xfrm>
-          <a:prstGeom prst="rect">
-            <a:avLst/>
-          </a:prstGeom>
-          <a:noFill/>
-        </p:spPr>
-        <p:txBody>
-          <a:bodyPr wrap="square">
-            <a:spAutoFit/>
-          </a:bodyPr>
-          <a:lstStyle/>
-          <a:p>
-            <a:pPr>
-              <a:defRPr sz="2600" b="1">
-                <a:solidFill>
-                  <a:srgbClr val="1E1B4B"/>
-                </a:solidFill>
-                <a:latin typeface="Montserrat"/>
-              </a:defRPr>
-            </a:pPr>
-            <a:r>
-              <a:t>Target Anchor Cards: preview.html</a:t>
-            </a:r>
-          </a:p>
-        </p:txBody>
-      </p:sp>
-      <p:sp>
-        <p:nvSpPr>
-          <p:cNvPr id="4" name="Rectangle 3"/>
-          <p:cNvSpPr/>
-          <p:nvPr/>
-        </p:nvSpPr>
-        <p:spPr>
-          <a:xfrm>
-            <a:off x="731520" y="1325880"/>
-            <a:ext cx="10728655" cy="18288"/>
-          </a:xfrm>
-          <a:prstGeom prst="rect">
-            <a:avLst/>
-          </a:prstGeom>
-          <a:solidFill>
-            <a:srgbClr val="7C3AED"/>
-          </a:solidFill>
-          <a:ln>
-            <a:noFill/>
-          </a:ln>
-        </p:spPr>
-        <p:style>
-          <a:lnRef idx="1">
-            <a:schemeClr val="accent1"/>
-          </a:lnRef>
-          <a:fillRef idx="3">
-            <a:schemeClr val="accent1"/>
-          </a:fillRef>
-          <a:effectRef idx="2">
-            <a:schemeClr val="accent1"/>
-          </a:effectRef>
-          <a:fontRef idx="minor">
-            <a:schemeClr val="lt1"/>
-          </a:fontRef>
-        </p:style>
-        <p:txBody>
-          <a:bodyPr rtlCol="0" anchor="ctr"/>
-          <a:lstStyle/>
-          <a:p>
-            <a:pPr algn="ctr"/>
-          </a:p>
-        </p:txBody>
-      </p:sp>
-      <p:sp>
-        <p:nvSpPr>
-          <p:cNvPr id="5" name="TextBox 4"/>
-          <p:cNvSpPr txBox="1"/>
-          <p:nvPr/>
-        </p:nvSpPr>
-        <p:spPr>
-          <a:xfrm>
-            <a:off x="731520" y="1645920"/>
-            <a:ext cx="4572000" cy="4572000"/>
-          </a:xfrm>
-          <a:prstGeom prst="rect">
-            <a:avLst/>
-          </a:prstGeom>
-          <a:noFill/>
-        </p:spPr>
-        <p:txBody>
-          <a:bodyPr wrap="square">
-            <a:spAutoFit/>
-          </a:bodyPr>
-          <a:lstStyle/>
-          <a:p>
-            <a:pPr>
-              <a:spcBef>
-                <a:spcPts val="1500"/>
-              </a:spcBef>
-              <a:defRPr sz="1600" b="1">
-                <a:solidFill>
-                  <a:srgbClr val="7C3AED"/>
-                </a:solidFill>
-                <a:latin typeface="Montserrat"/>
-              </a:defRPr>
-            </a:pPr>
-            <a:r>
-              <a:t>• Target Cards Utility Page:</a:t>
-            </a:r>
-          </a:p>
-          <a:p>
-            <a:pPr>
-              <a:spcBef>
-                <a:spcPts val="400"/>
-              </a:spcBef>
-              <a:defRPr sz="1300">
-                <a:solidFill>
-                  <a:srgbClr val="475569"/>
-                </a:solidFill>
-                <a:latin typeface="Montserrat"/>
-              </a:defRPr>
-            </a:pPr>
-            <a:r>
-              <a:t>The preview.html page hosts the target card display and printing instructions so students can load it on their desktop monitor or print it out.</a:t>
-            </a:r>
-          </a:p>
-          <a:p>
-            <a:pPr>
-              <a:spcBef>
-                <a:spcPts val="1500"/>
-              </a:spcBef>
-              <a:defRPr sz="1600" b="1">
-                <a:solidFill>
-                  <a:srgbClr val="7C3AED"/>
-                </a:solidFill>
-                <a:latin typeface="Montserrat"/>
-              </a:defRPr>
-            </a:pPr>
-            <a:r>
-              <a:t>• CSS Print Stylesheets (@media print):</a:t>
-            </a:r>
-          </a:p>
-          <a:p>
-            <a:pPr>
-              <a:spcBef>
-                <a:spcPts val="400"/>
-              </a:spcBef>
-              <a:defRPr sz="1300">
-                <a:solidFill>
-                  <a:srgbClr val="475569"/>
-                </a:solidFill>
-                <a:latin typeface="Montserrat"/>
-              </a:defRPr>
-            </a:pPr>
-            <a:r>
-              <a:t>To ensure printer ink is not wasted on dark Web UI colors and instructions, preview.html contains a print media query that hides all descriptions, guide corners, and buttons when printing, leaving only the exact target card.</a:t>
-            </a:r>
-          </a:p>
-          <a:p>
-            <a:pPr>
-              <a:spcBef>
-                <a:spcPts val="1500"/>
-              </a:spcBef>
-              <a:defRPr sz="1600" b="1">
-                <a:solidFill>
-                  <a:srgbClr val="7C3AED"/>
+                  <a:srgbClr val="4338CA"/>
                 </a:solidFill>
                 <a:latin typeface="Montserrat"/>
               </a:defRPr>
@@ -4281,7 +4199,7 @@
     <p:bg>
       <p:bgPr>
         <a:solidFill>
-          <a:srgbClr val="FAF9FE"/>
+          <a:srgbClr val="F8FAFC"/>
         </a:solidFill>
         <a:effectLst/>
       </p:bgPr>
@@ -4318,7 +4236,7 @@
             <a:pPr>
               <a:defRPr sz="1000" b="1">
                 <a:solidFill>
-                  <a:srgbClr val="EC4899"/>
+                  <a:srgbClr val="4338CA"/>
                 </a:solidFill>
                 <a:latin typeface="Montserrat"/>
               </a:defRPr>
@@ -4354,7 +4272,7 @@
             <a:pPr>
               <a:defRPr sz="2600" b="1">
                 <a:solidFill>
-                  <a:srgbClr val="1E1B4B"/>
+                  <a:srgbClr val="0F172A"/>
                 </a:solidFill>
                 <a:latin typeface="Montserrat"/>
               </a:defRPr>
@@ -4380,11 +4298,12 @@
             <a:avLst/>
           </a:prstGeom>
           <a:solidFill>
-            <a:srgbClr val="7C3AED"/>
+            <a:srgbClr val="4338CA"/>
           </a:solidFill>
           <a:ln>
             <a:noFill/>
           </a:ln>
+          <a:effectLst/>
         </p:spPr>
         <p:style>
           <a:lnRef idx="1">
@@ -4430,6 +4349,7 @@
               <a:srgbClr val="E2E8F0"/>
             </a:solidFill>
           </a:ln>
+          <a:effectLst/>
         </p:spPr>
         <p:style>
           <a:lnRef idx="1">
@@ -4455,7 +4375,7 @@
               </a:spcAft>
               <a:defRPr sz="1100" b="1">
                 <a:solidFill>
-                  <a:srgbClr val="EC4899"/>
+                  <a:srgbClr val="4338CA"/>
                 </a:solidFill>
                 <a:latin typeface="Montserrat"/>
               </a:defRPr>
@@ -4471,7 +4391,7 @@
               </a:spcAft>
               <a:defRPr sz="1600" b="1">
                 <a:solidFill>
-                  <a:srgbClr val="1E1B4B"/>
+                  <a:srgbClr val="0F172A"/>
                 </a:solidFill>
                 <a:latin typeface="Montserrat"/>
               </a:defRPr>
@@ -4517,6 +4437,7 @@
               <a:srgbClr val="E2E8F0"/>
             </a:solidFill>
           </a:ln>
+          <a:effectLst/>
         </p:spPr>
         <p:style>
           <a:lnRef idx="1">
@@ -4542,7 +4463,7 @@
               </a:spcAft>
               <a:defRPr sz="1100" b="1">
                 <a:solidFill>
-                  <a:srgbClr val="EC4899"/>
+                  <a:srgbClr val="4338CA"/>
                 </a:solidFill>
                 <a:latin typeface="Montserrat"/>
               </a:defRPr>
@@ -4558,7 +4479,7 @@
               </a:spcAft>
               <a:defRPr sz="1600" b="1">
                 <a:solidFill>
-                  <a:srgbClr val="1E1B4B"/>
+                  <a:srgbClr val="0F172A"/>
                 </a:solidFill>
                 <a:latin typeface="Montserrat"/>
               </a:defRPr>
@@ -4604,6 +4525,7 @@
               <a:srgbClr val="E2E8F0"/>
             </a:solidFill>
           </a:ln>
+          <a:effectLst/>
         </p:spPr>
         <p:style>
           <a:lnRef idx="1">
@@ -4629,7 +4551,7 @@
               </a:spcAft>
               <a:defRPr sz="1100" b="1">
                 <a:solidFill>
-                  <a:srgbClr val="EC4899"/>
+                  <a:srgbClr val="4338CA"/>
                 </a:solidFill>
                 <a:latin typeface="Montserrat"/>
               </a:defRPr>
@@ -4645,7 +4567,7 @@
               </a:spcAft>
               <a:defRPr sz="1600" b="1">
                 <a:solidFill>
-                  <a:srgbClr val="1E1B4B"/>
+                  <a:srgbClr val="0F172A"/>
                 </a:solidFill>
                 <a:latin typeface="Montserrat"/>
               </a:defRPr>
@@ -4683,7 +4605,7 @@
     <p:bg>
       <p:bgPr>
         <a:solidFill>
-          <a:srgbClr val="FAF9FE"/>
+          <a:srgbClr val="F8FAFC"/>
         </a:solidFill>
         <a:effectLst/>
       </p:bgPr>
@@ -4720,7 +4642,7 @@
             <a:pPr>
               <a:defRPr sz="1000" b="1">
                 <a:solidFill>
-                  <a:srgbClr val="EC4899"/>
+                  <a:srgbClr val="4338CA"/>
                 </a:solidFill>
                 <a:latin typeface="Montserrat"/>
               </a:defRPr>
@@ -4756,7 +4678,7 @@
             <a:pPr>
               <a:defRPr sz="2600" b="1">
                 <a:solidFill>
-                  <a:srgbClr val="1E1B4B"/>
+                  <a:srgbClr val="0F172A"/>
                 </a:solidFill>
                 <a:latin typeface="Montserrat"/>
               </a:defRPr>
@@ -4782,11 +4704,12 @@
             <a:avLst/>
           </a:prstGeom>
           <a:solidFill>
-            <a:srgbClr val="7C3AED"/>
+            <a:srgbClr val="4338CA"/>
           </a:solidFill>
           <a:ln>
             <a:noFill/>
           </a:ln>
+          <a:effectLst/>
         </p:spPr>
         <p:style>
           <a:lnRef idx="1">
@@ -4838,7 +4761,7 @@
               </a:spcBef>
               <a:defRPr sz="1600" b="1">
                 <a:solidFill>
-                  <a:srgbClr val="7C3AED"/>
+                  <a:srgbClr val="4338CA"/>
                 </a:solidFill>
                 <a:latin typeface="Montserrat"/>
               </a:defRPr>
@@ -4882,7 +4805,7 @@
               </a:spcBef>
               <a:defRPr sz="1600" b="1">
                 <a:solidFill>
-                  <a:srgbClr val="7C3AED"/>
+                  <a:srgbClr val="4338CA"/>
                 </a:solidFill>
                 <a:latin typeface="Montserrat"/>
               </a:defRPr>
@@ -4914,7 +4837,7 @@
               </a:spcBef>
               <a:defRPr sz="1600" b="1">
                 <a:solidFill>
-                  <a:srgbClr val="7C3AED"/>
+                  <a:srgbClr val="4338CA"/>
                 </a:solidFill>
                 <a:latin typeface="Montserrat"/>
               </a:defRPr>
@@ -4946,7 +4869,7 @@
               </a:spcBef>
               <a:defRPr sz="1600" b="1">
                 <a:solidFill>
-                  <a:srgbClr val="7C3AED"/>
+                  <a:srgbClr val="4338CA"/>
                 </a:solidFill>
                 <a:latin typeface="Montserrat"/>
               </a:defRPr>
@@ -4995,6 +4918,7 @@
               <a:srgbClr val="E2E8F0"/>
             </a:solidFill>
           </a:ln>
+          <a:effectLst/>
         </p:spPr>
         <p:style>
           <a:lnRef idx="1">
@@ -5017,7 +4941,7 @@
             <a:pPr algn="ctr">
               <a:defRPr sz="1100">
                 <a:solidFill>
-                  <a:srgbClr val="0F766E"/>
+                  <a:srgbClr val="334155"/>
                 </a:solidFill>
                 <a:latin typeface="Courier New"/>
               </a:defRPr>
@@ -5030,7 +4954,7 @@
             <a:pPr>
               <a:defRPr sz="1100">
                 <a:solidFill>
-                  <a:srgbClr val="0F766E"/>
+                  <a:srgbClr val="334155"/>
                 </a:solidFill>
                 <a:latin typeface="Courier New"/>
               </a:defRPr>
@@ -5043,7 +4967,7 @@
             <a:pPr>
               <a:defRPr sz="1100">
                 <a:solidFill>
-                  <a:srgbClr val="0F766E"/>
+                  <a:srgbClr val="334155"/>
                 </a:solidFill>
                 <a:latin typeface="Courier New"/>
               </a:defRPr>
@@ -5056,7 +4980,7 @@
             <a:pPr>
               <a:defRPr sz="1100">
                 <a:solidFill>
-                  <a:srgbClr val="0F766E"/>
+                  <a:srgbClr val="334155"/>
                 </a:solidFill>
                 <a:latin typeface="Courier New"/>
               </a:defRPr>
@@ -5069,7 +4993,7 @@
             <a:pPr>
               <a:defRPr sz="1100">
                 <a:solidFill>
-                  <a:srgbClr val="0F766E"/>
+                  <a:srgbClr val="334155"/>
                 </a:solidFill>
                 <a:latin typeface="Courier New"/>
               </a:defRPr>
@@ -5082,7 +5006,7 @@
             <a:pPr>
               <a:defRPr sz="1100">
                 <a:solidFill>
-                  <a:srgbClr val="0F766E"/>
+                  <a:srgbClr val="334155"/>
                 </a:solidFill>
                 <a:latin typeface="Courier New"/>
               </a:defRPr>
@@ -5095,7 +5019,7 @@
             <a:pPr>
               <a:defRPr sz="1100">
                 <a:solidFill>
-                  <a:srgbClr val="0F766E"/>
+                  <a:srgbClr val="334155"/>
                 </a:solidFill>
                 <a:latin typeface="Courier New"/>
               </a:defRPr>
@@ -5108,7 +5032,7 @@
             <a:pPr>
               <a:defRPr sz="1100">
                 <a:solidFill>
-                  <a:srgbClr val="0F766E"/>
+                  <a:srgbClr val="334155"/>
                 </a:solidFill>
                 <a:latin typeface="Courier New"/>
               </a:defRPr>
@@ -5121,7 +5045,7 @@
             <a:pPr>
               <a:defRPr sz="1100">
                 <a:solidFill>
-                  <a:srgbClr val="0F766E"/>
+                  <a:srgbClr val="334155"/>
                 </a:solidFill>
                 <a:latin typeface="Courier New"/>
               </a:defRPr>
@@ -5134,7 +5058,7 @@
             <a:pPr>
               <a:defRPr sz="1100">
                 <a:solidFill>
-                  <a:srgbClr val="0F766E"/>
+                  <a:srgbClr val="334155"/>
                 </a:solidFill>
                 <a:latin typeface="Courier New"/>
               </a:defRPr>
@@ -5147,7 +5071,7 @@
             <a:pPr>
               <a:defRPr sz="1100">
                 <a:solidFill>
-                  <a:srgbClr val="0F766E"/>
+                  <a:srgbClr val="334155"/>
                 </a:solidFill>
                 <a:latin typeface="Courier New"/>
               </a:defRPr>
@@ -5172,7 +5096,7 @@
     <p:bg>
       <p:bgPr>
         <a:solidFill>
-          <a:srgbClr val="FAF9FE"/>
+          <a:srgbClr val="F8FAFC"/>
         </a:solidFill>
         <a:effectLst/>
       </p:bgPr>
@@ -5209,7 +5133,7 @@
             <a:pPr>
               <a:defRPr sz="1000" b="1">
                 <a:solidFill>
-                  <a:srgbClr val="EC4899"/>
+                  <a:srgbClr val="4338CA"/>
                 </a:solidFill>
                 <a:latin typeface="Montserrat"/>
               </a:defRPr>
@@ -5245,7 +5169,7 @@
             <a:pPr>
               <a:defRPr sz="2600" b="1">
                 <a:solidFill>
-                  <a:srgbClr val="1E1B4B"/>
+                  <a:srgbClr val="0F172A"/>
                 </a:solidFill>
                 <a:latin typeface="Montserrat"/>
               </a:defRPr>
@@ -5271,11 +5195,12 @@
             <a:avLst/>
           </a:prstGeom>
           <a:solidFill>
-            <a:srgbClr val="7C3AED"/>
+            <a:srgbClr val="4338CA"/>
           </a:solidFill>
           <a:ln>
             <a:noFill/>
           </a:ln>
+          <a:effectLst/>
         </p:spPr>
         <p:style>
           <a:lnRef idx="1">
@@ -5327,7 +5252,7 @@
               </a:spcBef>
               <a:defRPr sz="1600" b="1">
                 <a:solidFill>
-                  <a:srgbClr val="7C3AED"/>
+                  <a:srgbClr val="4338CA"/>
                 </a:solidFill>
                 <a:latin typeface="Montserrat"/>
               </a:defRPr>
@@ -5359,7 +5284,7 @@
               </a:spcBef>
               <a:defRPr sz="1600" b="1">
                 <a:solidFill>
-                  <a:srgbClr val="7C3AED"/>
+                  <a:srgbClr val="4338CA"/>
                 </a:solidFill>
                 <a:latin typeface="Montserrat"/>
               </a:defRPr>
@@ -5391,7 +5316,7 @@
               </a:spcBef>
               <a:defRPr sz="1600" b="1">
                 <a:solidFill>
-                  <a:srgbClr val="7C3AED"/>
+                  <a:srgbClr val="4338CA"/>
                 </a:solidFill>
                 <a:latin typeface="Montserrat"/>
               </a:defRPr>
@@ -5552,7 +5477,7 @@
     <p:bg>
       <p:bgPr>
         <a:solidFill>
-          <a:srgbClr val="FAF9FE"/>
+          <a:srgbClr val="F8FAFC"/>
         </a:solidFill>
         <a:effectLst/>
       </p:bgPr>
@@ -5589,7 +5514,7 @@
             <a:pPr>
               <a:defRPr sz="1000" b="1">
                 <a:solidFill>
-                  <a:srgbClr val="EC4899"/>
+                  <a:srgbClr val="4338CA"/>
                 </a:solidFill>
                 <a:latin typeface="Montserrat"/>
               </a:defRPr>
@@ -5625,7 +5550,7 @@
             <a:pPr>
               <a:defRPr sz="2600" b="1">
                 <a:solidFill>
-                  <a:srgbClr val="1E1B4B"/>
+                  <a:srgbClr val="0F172A"/>
                 </a:solidFill>
                 <a:latin typeface="Montserrat"/>
               </a:defRPr>
@@ -5651,11 +5576,12 @@
             <a:avLst/>
           </a:prstGeom>
           <a:solidFill>
-            <a:srgbClr val="7C3AED"/>
+            <a:srgbClr val="4338CA"/>
           </a:solidFill>
           <a:ln>
             <a:noFill/>
           </a:ln>
+          <a:effectLst/>
         </p:spPr>
         <p:style>
           <a:lnRef idx="1">
@@ -5707,7 +5633,7 @@
               </a:spcBef>
               <a:defRPr sz="1600" b="1">
                 <a:solidFill>
-                  <a:srgbClr val="7C3AED"/>
+                  <a:srgbClr val="4338CA"/>
                 </a:solidFill>
                 <a:latin typeface="Montserrat"/>
               </a:defRPr>
@@ -5739,7 +5665,7 @@
               </a:spcBef>
               <a:defRPr sz="1600" b="1">
                 <a:solidFill>
-                  <a:srgbClr val="7C3AED"/>
+                  <a:srgbClr val="4338CA"/>
                 </a:solidFill>
                 <a:latin typeface="Montserrat"/>
               </a:defRPr>
@@ -5771,7 +5697,7 @@
               </a:spcBef>
               <a:defRPr sz="1600" b="1">
                 <a:solidFill>
-                  <a:srgbClr val="7C3AED"/>
+                  <a:srgbClr val="4338CA"/>
                 </a:solidFill>
                 <a:latin typeface="Montserrat"/>
               </a:defRPr>
@@ -5803,7 +5729,7 @@
               </a:spcBef>
               <a:defRPr sz="1600" b="1">
                 <a:solidFill>
-                  <a:srgbClr val="7C3AED"/>
+                  <a:srgbClr val="4338CA"/>
                 </a:solidFill>
                 <a:latin typeface="Montserrat"/>
               </a:defRPr>
@@ -5904,7 +5830,7 @@
     <p:bg>
       <p:bgPr>
         <a:solidFill>
-          <a:srgbClr val="FAF9FE"/>
+          <a:srgbClr val="F8FAFC"/>
         </a:solidFill>
         <a:effectLst/>
       </p:bgPr>
@@ -5941,7 +5867,7 @@
             <a:pPr>
               <a:defRPr sz="1000" b="1">
                 <a:solidFill>
-                  <a:srgbClr val="EC4899"/>
+                  <a:srgbClr val="4338CA"/>
                 </a:solidFill>
                 <a:latin typeface="Montserrat"/>
               </a:defRPr>
@@ -5977,7 +5903,7 @@
             <a:pPr>
               <a:defRPr sz="2600" b="1">
                 <a:solidFill>
-                  <a:srgbClr val="1E1B4B"/>
+                  <a:srgbClr val="0F172A"/>
                 </a:solidFill>
                 <a:latin typeface="Montserrat"/>
               </a:defRPr>
@@ -6003,11 +5929,12 @@
             <a:avLst/>
           </a:prstGeom>
           <a:solidFill>
-            <a:srgbClr val="7C3AED"/>
+            <a:srgbClr val="4338CA"/>
           </a:solidFill>
           <a:ln>
             <a:noFill/>
           </a:ln>
+          <a:effectLst/>
         </p:spPr>
         <p:style>
           <a:lnRef idx="1">
@@ -6059,7 +5986,7 @@
               </a:spcBef>
               <a:defRPr sz="1600" b="1">
                 <a:solidFill>
-                  <a:srgbClr val="7C3AED"/>
+                  <a:srgbClr val="4338CA"/>
                 </a:solidFill>
                 <a:latin typeface="Montserrat"/>
               </a:defRPr>
@@ -6091,7 +6018,7 @@
               </a:spcBef>
               <a:defRPr sz="1600" b="1">
                 <a:solidFill>
-                  <a:srgbClr val="7C3AED"/>
+                  <a:srgbClr val="4338CA"/>
                 </a:solidFill>
                 <a:latin typeface="Montserrat"/>
               </a:defRPr>
@@ -6123,7 +6050,7 @@
               </a:spcBef>
               <a:defRPr sz="1600" b="1">
                 <a:solidFill>
-                  <a:srgbClr val="7C3AED"/>
+                  <a:srgbClr val="4338CA"/>
                 </a:solidFill>
                 <a:latin typeface="Montserrat"/>
               </a:defRPr>
@@ -6180,6 +6107,7 @@
               <a:srgbClr val="E2E8F0"/>
             </a:solidFill>
           </a:ln>
+          <a:effectLst/>
         </p:spPr>
         <p:style>
           <a:lnRef idx="1">
@@ -6202,7 +6130,7 @@
             <a:pPr algn="ctr">
               <a:defRPr sz="1100">
                 <a:solidFill>
-                  <a:srgbClr val="0F766E"/>
+                  <a:srgbClr val="334155"/>
                 </a:solidFill>
                 <a:latin typeface="Courier New"/>
               </a:defRPr>
@@ -6215,7 +6143,7 @@
             <a:pPr>
               <a:defRPr sz="1100">
                 <a:solidFill>
-                  <a:srgbClr val="0F766E"/>
+                  <a:srgbClr val="334155"/>
                 </a:solidFill>
                 <a:latin typeface="Courier New"/>
               </a:defRPr>
@@ -6228,7 +6156,7 @@
             <a:pPr>
               <a:defRPr sz="1100">
                 <a:solidFill>
-                  <a:srgbClr val="0F766E"/>
+                  <a:srgbClr val="334155"/>
                 </a:solidFill>
                 <a:latin typeface="Courier New"/>
               </a:defRPr>
@@ -6241,7 +6169,7 @@
             <a:pPr>
               <a:defRPr sz="1100">
                 <a:solidFill>
-                  <a:srgbClr val="0F766E"/>
+                  <a:srgbClr val="334155"/>
                 </a:solidFill>
                 <a:latin typeface="Courier New"/>
               </a:defRPr>
@@ -6251,7 +6179,7 @@
             <a:pPr>
               <a:defRPr sz="1100">
                 <a:solidFill>
-                  <a:srgbClr val="0F766E"/>
+                  <a:srgbClr val="334155"/>
                 </a:solidFill>
                 <a:latin typeface="Courier New"/>
               </a:defRPr>
@@ -6264,7 +6192,7 @@
             <a:pPr>
               <a:defRPr sz="1100">
                 <a:solidFill>
-                  <a:srgbClr val="0F766E"/>
+                  <a:srgbClr val="334155"/>
                 </a:solidFill>
                 <a:latin typeface="Courier New"/>
               </a:defRPr>
@@ -6277,7 +6205,7 @@
             <a:pPr>
               <a:defRPr sz="1100">
                 <a:solidFill>
-                  <a:srgbClr val="0F766E"/>
+                  <a:srgbClr val="334155"/>
                 </a:solidFill>
                 <a:latin typeface="Courier New"/>
               </a:defRPr>
@@ -6290,7 +6218,7 @@
             <a:pPr>
               <a:defRPr sz="1100">
                 <a:solidFill>
-                  <a:srgbClr val="0F766E"/>
+                  <a:srgbClr val="334155"/>
                 </a:solidFill>
                 <a:latin typeface="Courier New"/>
               </a:defRPr>
@@ -6303,7 +6231,7 @@
             <a:pPr>
               <a:defRPr sz="1100">
                 <a:solidFill>
-                  <a:srgbClr val="0F766E"/>
+                  <a:srgbClr val="334155"/>
                 </a:solidFill>
                 <a:latin typeface="Courier New"/>
               </a:defRPr>
@@ -6316,7 +6244,7 @@
             <a:pPr>
               <a:defRPr sz="1100">
                 <a:solidFill>
-                  <a:srgbClr val="0F766E"/>
+                  <a:srgbClr val="334155"/>
                 </a:solidFill>
                 <a:latin typeface="Courier New"/>
               </a:defRPr>
@@ -6329,7 +6257,7 @@
             <a:pPr>
               <a:defRPr sz="1100">
                 <a:solidFill>
-                  <a:srgbClr val="0F766E"/>
+                  <a:srgbClr val="334155"/>
                 </a:solidFill>
                 <a:latin typeface="Courier New"/>
               </a:defRPr>
@@ -6342,7 +6270,7 @@
             <a:pPr>
               <a:defRPr sz="1100">
                 <a:solidFill>
-                  <a:srgbClr val="0F766E"/>
+                  <a:srgbClr val="334155"/>
                 </a:solidFill>
                 <a:latin typeface="Courier New"/>
               </a:defRPr>
@@ -6355,7 +6283,7 @@
             <a:pPr>
               <a:defRPr sz="1100">
                 <a:solidFill>
-                  <a:srgbClr val="0F766E"/>
+                  <a:srgbClr val="334155"/>
                 </a:solidFill>
                 <a:latin typeface="Courier New"/>
               </a:defRPr>
@@ -6368,7 +6296,7 @@
             <a:pPr>
               <a:defRPr sz="1100">
                 <a:solidFill>
-                  <a:srgbClr val="0F766E"/>
+                  <a:srgbClr val="334155"/>
                 </a:solidFill>
                 <a:latin typeface="Courier New"/>
               </a:defRPr>
@@ -6381,7 +6309,7 @@
             <a:pPr>
               <a:defRPr sz="1100">
                 <a:solidFill>
-                  <a:srgbClr val="0F766E"/>
+                  <a:srgbClr val="334155"/>
                 </a:solidFill>
                 <a:latin typeface="Courier New"/>
               </a:defRPr>
@@ -6394,7 +6322,7 @@
             <a:pPr>
               <a:defRPr sz="1100">
                 <a:solidFill>
-                  <a:srgbClr val="0F766E"/>
+                  <a:srgbClr val="334155"/>
                 </a:solidFill>
                 <a:latin typeface="Courier New"/>
               </a:defRPr>
@@ -6407,7 +6335,7 @@
             <a:pPr>
               <a:defRPr sz="1100">
                 <a:solidFill>
-                  <a:srgbClr val="0F766E"/>
+                  <a:srgbClr val="334155"/>
                 </a:solidFill>
                 <a:latin typeface="Courier New"/>
               </a:defRPr>
@@ -6432,7 +6360,7 @@
     <p:bg>
       <p:bgPr>
         <a:solidFill>
-          <a:srgbClr val="FAF9FE"/>
+          <a:srgbClr val="F8FAFC"/>
         </a:solidFill>
         <a:effectLst/>
       </p:bgPr>
@@ -6469,7 +6397,7 @@
             <a:pPr>
               <a:defRPr sz="1000" b="1">
                 <a:solidFill>
-                  <a:srgbClr val="EC4899"/>
+                  <a:srgbClr val="4338CA"/>
                 </a:solidFill>
                 <a:latin typeface="Montserrat"/>
               </a:defRPr>
@@ -6505,7 +6433,7 @@
             <a:pPr>
               <a:defRPr sz="2600" b="1">
                 <a:solidFill>
-                  <a:srgbClr val="1E1B4B"/>
+                  <a:srgbClr val="0F172A"/>
                 </a:solidFill>
                 <a:latin typeface="Montserrat"/>
               </a:defRPr>
@@ -6531,11 +6459,12 @@
             <a:avLst/>
           </a:prstGeom>
           <a:solidFill>
-            <a:srgbClr val="7C3AED"/>
+            <a:srgbClr val="4338CA"/>
           </a:solidFill>
           <a:ln>
             <a:noFill/>
           </a:ln>
+          <a:effectLst/>
         </p:spPr>
         <p:style>
           <a:lnRef idx="1">
@@ -6587,7 +6516,7 @@
               </a:spcBef>
               <a:defRPr sz="1600" b="1">
                 <a:solidFill>
-                  <a:srgbClr val="7C3AED"/>
+                  <a:srgbClr val="4338CA"/>
                 </a:solidFill>
                 <a:latin typeface="Montserrat"/>
               </a:defRPr>
@@ -6619,7 +6548,7 @@
               </a:spcBef>
               <a:defRPr sz="1600" b="1">
                 <a:solidFill>
-                  <a:srgbClr val="7C3AED"/>
+                  <a:srgbClr val="4338CA"/>
                 </a:solidFill>
                 <a:latin typeface="Montserrat"/>
               </a:defRPr>
@@ -6655,7 +6584,7 @@
               </a:spcBef>
               <a:defRPr sz="1600" b="1">
                 <a:solidFill>
-                  <a:srgbClr val="7C3AED"/>
+                  <a:srgbClr val="4338CA"/>
                 </a:solidFill>
                 <a:latin typeface="Montserrat"/>
               </a:defRPr>
@@ -6704,6 +6633,7 @@
               <a:srgbClr val="E2E8F0"/>
             </a:solidFill>
           </a:ln>
+          <a:effectLst/>
         </p:spPr>
         <p:style>
           <a:lnRef idx="1">
@@ -6726,7 +6656,7 @@
             <a:pPr algn="ctr">
               <a:defRPr sz="1100">
                 <a:solidFill>
-                  <a:srgbClr val="0F766E"/>
+                  <a:srgbClr val="334155"/>
                 </a:solidFill>
                 <a:latin typeface="Courier New"/>
               </a:defRPr>
@@ -6739,7 +6669,7 @@
             <a:pPr>
               <a:defRPr sz="1100">
                 <a:solidFill>
-                  <a:srgbClr val="0F766E"/>
+                  <a:srgbClr val="334155"/>
                 </a:solidFill>
                 <a:latin typeface="Courier New"/>
               </a:defRPr>
@@ -6752,7 +6682,7 @@
             <a:pPr>
               <a:defRPr sz="1100">
                 <a:solidFill>
-                  <a:srgbClr val="0F766E"/>
+                  <a:srgbClr val="334155"/>
                 </a:solidFill>
                 <a:latin typeface="Courier New"/>
               </a:defRPr>
@@ -6765,7 +6695,7 @@
             <a:pPr>
               <a:defRPr sz="1100">
                 <a:solidFill>
-                  <a:srgbClr val="0F766E"/>
+                  <a:srgbClr val="334155"/>
                 </a:solidFill>
                 <a:latin typeface="Courier New"/>
               </a:defRPr>
@@ -6778,7 +6708,7 @@
             <a:pPr>
               <a:defRPr sz="1100">
                 <a:solidFill>
-                  <a:srgbClr val="0F766E"/>
+                  <a:srgbClr val="334155"/>
                 </a:solidFill>
                 <a:latin typeface="Courier New"/>
               </a:defRPr>
@@ -6791,7 +6721,7 @@
             <a:pPr>
               <a:defRPr sz="1100">
                 <a:solidFill>
-                  <a:srgbClr val="0F766E"/>
+                  <a:srgbClr val="334155"/>
                 </a:solidFill>
                 <a:latin typeface="Courier New"/>
               </a:defRPr>
@@ -6804,7 +6734,7 @@
             <a:pPr>
               <a:defRPr sz="1100">
                 <a:solidFill>
-                  <a:srgbClr val="0F766E"/>
+                  <a:srgbClr val="334155"/>
                 </a:solidFill>
                 <a:latin typeface="Courier New"/>
               </a:defRPr>
@@ -6817,7 +6747,7 @@
             <a:pPr>
               <a:defRPr sz="1100">
                 <a:solidFill>
-                  <a:srgbClr val="0F766E"/>
+                  <a:srgbClr val="334155"/>
                 </a:solidFill>
                 <a:latin typeface="Courier New"/>
               </a:defRPr>
@@ -6827,7 +6757,7 @@
             <a:pPr>
               <a:defRPr sz="1100">
                 <a:solidFill>
-                  <a:srgbClr val="0F766E"/>
+                  <a:srgbClr val="334155"/>
                 </a:solidFill>
                 <a:latin typeface="Courier New"/>
               </a:defRPr>
@@ -6840,7 +6770,7 @@
             <a:pPr>
               <a:defRPr sz="1100">
                 <a:solidFill>
-                  <a:srgbClr val="0F766E"/>
+                  <a:srgbClr val="334155"/>
                 </a:solidFill>
                 <a:latin typeface="Courier New"/>
               </a:defRPr>
@@ -6853,7 +6783,7 @@
             <a:pPr>
               <a:defRPr sz="1100">
                 <a:solidFill>
-                  <a:srgbClr val="0F766E"/>
+                  <a:srgbClr val="334155"/>
                 </a:solidFill>
                 <a:latin typeface="Courier New"/>
               </a:defRPr>
@@ -6866,7 +6796,7 @@
             <a:pPr>
               <a:defRPr sz="1100">
                 <a:solidFill>
-                  <a:srgbClr val="0F766E"/>
+                  <a:srgbClr val="334155"/>
                 </a:solidFill>
                 <a:latin typeface="Courier New"/>
               </a:defRPr>
@@ -6879,7 +6809,7 @@
             <a:pPr>
               <a:defRPr sz="1100">
                 <a:solidFill>
-                  <a:srgbClr val="0F766E"/>
+                  <a:srgbClr val="334155"/>
                 </a:solidFill>
                 <a:latin typeface="Courier New"/>
               </a:defRPr>
@@ -6889,7 +6819,7 @@
             <a:pPr>
               <a:defRPr sz="1100">
                 <a:solidFill>
-                  <a:srgbClr val="0F766E"/>
+                  <a:srgbClr val="334155"/>
                 </a:solidFill>
                 <a:latin typeface="Courier New"/>
               </a:defRPr>
@@ -6902,7 +6832,7 @@
             <a:pPr>
               <a:defRPr sz="1100">
                 <a:solidFill>
-                  <a:srgbClr val="0F766E"/>
+                  <a:srgbClr val="334155"/>
                 </a:solidFill>
                 <a:latin typeface="Courier New"/>
               </a:defRPr>
@@ -6915,7 +6845,7 @@
             <a:pPr>
               <a:defRPr sz="1100">
                 <a:solidFill>
-                  <a:srgbClr val="0F766E"/>
+                  <a:srgbClr val="334155"/>
                 </a:solidFill>
                 <a:latin typeface="Courier New"/>
               </a:defRPr>
@@ -6928,7 +6858,7 @@
             <a:pPr>
               <a:defRPr sz="1100">
                 <a:solidFill>
-                  <a:srgbClr val="0F766E"/>
+                  <a:srgbClr val="334155"/>
                 </a:solidFill>
                 <a:latin typeface="Courier New"/>
               </a:defRPr>
@@ -6941,7 +6871,7 @@
             <a:pPr>
               <a:defRPr sz="1100">
                 <a:solidFill>
-                  <a:srgbClr val="0F766E"/>
+                  <a:srgbClr val="334155"/>
                 </a:solidFill>
                 <a:latin typeface="Courier New"/>
               </a:defRPr>
@@ -6966,7 +6896,7 @@
     <p:bg>
       <p:bgPr>
         <a:solidFill>
-          <a:srgbClr val="FAF9FE"/>
+          <a:srgbClr val="F8FAFC"/>
         </a:solidFill>
         <a:effectLst/>
       </p:bgPr>
@@ -7003,7 +6933,7 @@
             <a:pPr>
               <a:defRPr sz="1000" b="1">
                 <a:solidFill>
-                  <a:srgbClr val="EC4899"/>
+                  <a:srgbClr val="4338CA"/>
                 </a:solidFill>
                 <a:latin typeface="Montserrat"/>
               </a:defRPr>
@@ -7039,7 +6969,7 @@
             <a:pPr>
               <a:defRPr sz="2600" b="1">
                 <a:solidFill>
-                  <a:srgbClr val="1E1B4B"/>
+                  <a:srgbClr val="0F172A"/>
                 </a:solidFill>
                 <a:latin typeface="Montserrat"/>
               </a:defRPr>
@@ -7065,11 +6995,12 @@
             <a:avLst/>
           </a:prstGeom>
           <a:solidFill>
-            <a:srgbClr val="7C3AED"/>
+            <a:srgbClr val="4338CA"/>
           </a:solidFill>
           <a:ln>
             <a:noFill/>
           </a:ln>
+          <a:effectLst/>
         </p:spPr>
         <p:style>
           <a:lnRef idx="1">
@@ -7121,7 +7052,7 @@
               </a:spcBef>
               <a:defRPr sz="1800" b="1">
                 <a:solidFill>
-                  <a:srgbClr val="7C3AED"/>
+                  <a:srgbClr val="4338CA"/>
                 </a:solidFill>
                 <a:latin typeface="Montserrat"/>
               </a:defRPr>
@@ -7153,7 +7084,7 @@
               </a:spcBef>
               <a:defRPr sz="1800" b="1">
                 <a:solidFill>
-                  <a:srgbClr val="7C3AED"/>
+                  <a:srgbClr val="4338CA"/>
                 </a:solidFill>
                 <a:latin typeface="Montserrat"/>
               </a:defRPr>
@@ -7185,7 +7116,7 @@
               </a:spcBef>
               <a:defRPr sz="1800" b="1">
                 <a:solidFill>
-                  <a:srgbClr val="7C3AED"/>
+                  <a:srgbClr val="4338CA"/>
                 </a:solidFill>
                 <a:latin typeface="Montserrat"/>
               </a:defRPr>
@@ -7234,7 +7165,7 @@
     <p:bg>
       <p:bgPr>
         <a:solidFill>
-          <a:srgbClr val="FAF9FE"/>
+          <a:srgbClr val="F8FAFC"/>
         </a:solidFill>
         <a:effectLst/>
       </p:bgPr>
@@ -7271,7 +7202,7 @@
             <a:pPr>
               <a:defRPr sz="1000" b="1">
                 <a:solidFill>
-                  <a:srgbClr val="EC4899"/>
+                  <a:srgbClr val="4338CA"/>
                 </a:solidFill>
                 <a:latin typeface="Montserrat"/>
               </a:defRPr>
@@ -7307,7 +7238,7 @@
             <a:pPr>
               <a:defRPr sz="2600" b="1">
                 <a:solidFill>
-                  <a:srgbClr val="1E1B4B"/>
+                  <a:srgbClr val="0F172A"/>
                 </a:solidFill>
                 <a:latin typeface="Montserrat"/>
               </a:defRPr>
@@ -7333,11 +7264,12 @@
             <a:avLst/>
           </a:prstGeom>
           <a:solidFill>
-            <a:srgbClr val="7C3AED"/>
+            <a:srgbClr val="4338CA"/>
           </a:solidFill>
           <a:ln>
             <a:noFill/>
           </a:ln>
+          <a:effectLst/>
         </p:spPr>
         <p:style>
           <a:lnRef idx="1">
@@ -7389,7 +7321,7 @@
               </a:spcBef>
               <a:defRPr sz="1600" b="1">
                 <a:solidFill>
-                  <a:srgbClr val="7C3AED"/>
+                  <a:srgbClr val="4338CA"/>
                 </a:solidFill>
                 <a:latin typeface="Montserrat"/>
               </a:defRPr>
@@ -7425,7 +7357,7 @@
               </a:spcBef>
               <a:defRPr sz="1600" b="1">
                 <a:solidFill>
-                  <a:srgbClr val="7C3AED"/>
+                  <a:srgbClr val="4338CA"/>
                 </a:solidFill>
                 <a:latin typeface="Montserrat"/>
               </a:defRPr>
@@ -7457,7 +7389,7 @@
               </a:spcBef>
               <a:defRPr sz="1600" b="1">
                 <a:solidFill>
-                  <a:srgbClr val="7C3AED"/>
+                  <a:srgbClr val="4338CA"/>
                 </a:solidFill>
                 <a:latin typeface="Montserrat"/>
               </a:defRPr>

</xml_diff>